<commit_message>
Update the design document.
</commit_message>
<xml_diff>
--- a/Articles/5_OpenclawWithDeepSeek/img/designDoc.pptx
+++ b/Articles/5_OpenclawWithDeepSeek/img/designDoc.pptx
@@ -4,9 +4,14 @@
   <p:sldMasterIdLst>
     <p:sldMasterId id="2147483648" r:id="rId1"/>
   </p:sldMasterIdLst>
+  <p:notesMasterIdLst>
+    <p:notesMasterId r:id="rId6"/>
+  </p:notesMasterIdLst>
   <p:sldIdLst>
     <p:sldId id="256" r:id="rId2"/>
     <p:sldId id="257" r:id="rId3"/>
+    <p:sldId id="258" r:id="rId4"/>
+    <p:sldId id="259" r:id="rId5"/>
   </p:sldIdLst>
   <p:sldSz cx="12192000" cy="6858000"/>
   <p:notesSz cx="6858000" cy="9144000"/>
@@ -113,6 +118,440 @@
 </p:presentation>
 </file>
 
+<file path=ppt/notesMasters/notesMaster1.xml><?xml version="1.0" encoding="utf-8"?>
+<p:notesMaster xmlns:a="http://schemas.openxmlformats.org/drawingml/2006/main" xmlns:r="http://schemas.openxmlformats.org/officeDocument/2006/relationships" xmlns:p="http://schemas.openxmlformats.org/presentationml/2006/main">
+  <p:cSld>
+    <p:bg>
+      <p:bgRef idx="1001">
+        <a:schemeClr val="bg1"/>
+      </p:bgRef>
+    </p:bg>
+    <p:spTree>
+      <p:nvGrpSpPr>
+        <p:cNvPr id="1" name=""/>
+        <p:cNvGrpSpPr/>
+        <p:nvPr/>
+      </p:nvGrpSpPr>
+      <p:grpSpPr>
+        <a:xfrm>
+          <a:off x="0" y="0"/>
+          <a:ext cx="0" cy="0"/>
+          <a:chOff x="0" y="0"/>
+          <a:chExt cx="0" cy="0"/>
+        </a:xfrm>
+      </p:grpSpPr>
+      <p:sp>
+        <p:nvSpPr>
+          <p:cNvPr id="2" name="Header Placeholder 1"/>
+          <p:cNvSpPr>
+            <a:spLocks noGrp="1"/>
+          </p:cNvSpPr>
+          <p:nvPr>
+            <p:ph type="hdr" sz="quarter"/>
+          </p:nvPr>
+        </p:nvSpPr>
+        <p:spPr>
+          <a:xfrm>
+            <a:off x="0" y="0"/>
+            <a:ext cx="2971800" cy="458788"/>
+          </a:xfrm>
+          <a:prstGeom prst="rect">
+            <a:avLst/>
+          </a:prstGeom>
+        </p:spPr>
+        <p:txBody>
+          <a:bodyPr vert="horz" lIns="91440" tIns="45720" rIns="91440" bIns="45720" rtlCol="0"/>
+          <a:lstStyle>
+            <a:lvl1pPr algn="l">
+              <a:defRPr sz="1200"/>
+            </a:lvl1pPr>
+          </a:lstStyle>
+          <a:p>
+            <a:endParaRPr lang="en-SG"/>
+          </a:p>
+        </p:txBody>
+      </p:sp>
+      <p:sp>
+        <p:nvSpPr>
+          <p:cNvPr id="3" name="Date Placeholder 2"/>
+          <p:cNvSpPr>
+            <a:spLocks noGrp="1"/>
+          </p:cNvSpPr>
+          <p:nvPr>
+            <p:ph type="dt" idx="1"/>
+          </p:nvPr>
+        </p:nvSpPr>
+        <p:spPr>
+          <a:xfrm>
+            <a:off x="3884613" y="0"/>
+            <a:ext cx="2971800" cy="458788"/>
+          </a:xfrm>
+          <a:prstGeom prst="rect">
+            <a:avLst/>
+          </a:prstGeom>
+        </p:spPr>
+        <p:txBody>
+          <a:bodyPr vert="horz" lIns="91440" tIns="45720" rIns="91440" bIns="45720" rtlCol="0"/>
+          <a:lstStyle>
+            <a:lvl1pPr algn="r">
+              <a:defRPr sz="1200"/>
+            </a:lvl1pPr>
+          </a:lstStyle>
+          <a:p>
+            <a:fld id="{5FD7CF5F-CA5D-4CC3-AFB2-C100E3D4BFD0}" type="datetimeFigureOut">
+              <a:rPr lang="en-SG" smtClean="0"/>
+              <a:t>13/3/2026</a:t>
+            </a:fld>
+            <a:endParaRPr lang="en-SG"/>
+          </a:p>
+        </p:txBody>
+      </p:sp>
+      <p:sp>
+        <p:nvSpPr>
+          <p:cNvPr id="4" name="Slide Image Placeholder 3"/>
+          <p:cNvSpPr>
+            <a:spLocks noGrp="1" noRot="1" noChangeAspect="1"/>
+          </p:cNvSpPr>
+          <p:nvPr>
+            <p:ph type="sldImg" idx="2"/>
+          </p:nvPr>
+        </p:nvSpPr>
+        <p:spPr>
+          <a:xfrm>
+            <a:off x="685800" y="1143000"/>
+            <a:ext cx="5486400" cy="3086100"/>
+          </a:xfrm>
+          <a:prstGeom prst="rect">
+            <a:avLst/>
+          </a:prstGeom>
+          <a:noFill/>
+          <a:ln w="12700">
+            <a:solidFill>
+              <a:prstClr val="black"/>
+            </a:solidFill>
+          </a:ln>
+        </p:spPr>
+        <p:txBody>
+          <a:bodyPr vert="horz" lIns="91440" tIns="45720" rIns="91440" bIns="45720" rtlCol="0" anchor="ctr"/>
+          <a:lstStyle/>
+          <a:p>
+            <a:endParaRPr lang="en-SG"/>
+          </a:p>
+        </p:txBody>
+      </p:sp>
+      <p:sp>
+        <p:nvSpPr>
+          <p:cNvPr id="5" name="Notes Placeholder 4"/>
+          <p:cNvSpPr>
+            <a:spLocks noGrp="1"/>
+          </p:cNvSpPr>
+          <p:nvPr>
+            <p:ph type="body" sz="quarter" idx="3"/>
+          </p:nvPr>
+        </p:nvSpPr>
+        <p:spPr>
+          <a:xfrm>
+            <a:off x="685800" y="4400550"/>
+            <a:ext cx="5486400" cy="3600450"/>
+          </a:xfrm>
+          <a:prstGeom prst="rect">
+            <a:avLst/>
+          </a:prstGeom>
+        </p:spPr>
+        <p:txBody>
+          <a:bodyPr vert="horz" lIns="91440" tIns="45720" rIns="91440" bIns="45720" rtlCol="0"/>
+          <a:lstStyle/>
+          <a:p>
+            <a:pPr lvl="0"/>
+            <a:r>
+              <a:rPr lang="en-US"/>
+              <a:t>Click to edit Master text styles</a:t>
+            </a:r>
+          </a:p>
+          <a:p>
+            <a:pPr lvl="1"/>
+            <a:r>
+              <a:rPr lang="en-US"/>
+              <a:t>Second level</a:t>
+            </a:r>
+          </a:p>
+          <a:p>
+            <a:pPr lvl="2"/>
+            <a:r>
+              <a:rPr lang="en-US"/>
+              <a:t>Third level</a:t>
+            </a:r>
+          </a:p>
+          <a:p>
+            <a:pPr lvl="3"/>
+            <a:r>
+              <a:rPr lang="en-US"/>
+              <a:t>Fourth level</a:t>
+            </a:r>
+          </a:p>
+          <a:p>
+            <a:pPr lvl="4"/>
+            <a:r>
+              <a:rPr lang="en-US"/>
+              <a:t>Fifth level</a:t>
+            </a:r>
+            <a:endParaRPr lang="en-SG"/>
+          </a:p>
+        </p:txBody>
+      </p:sp>
+      <p:sp>
+        <p:nvSpPr>
+          <p:cNvPr id="6" name="Footer Placeholder 5"/>
+          <p:cNvSpPr>
+            <a:spLocks noGrp="1"/>
+          </p:cNvSpPr>
+          <p:nvPr>
+            <p:ph type="ftr" sz="quarter" idx="4"/>
+          </p:nvPr>
+        </p:nvSpPr>
+        <p:spPr>
+          <a:xfrm>
+            <a:off x="0" y="8685213"/>
+            <a:ext cx="2971800" cy="458787"/>
+          </a:xfrm>
+          <a:prstGeom prst="rect">
+            <a:avLst/>
+          </a:prstGeom>
+        </p:spPr>
+        <p:txBody>
+          <a:bodyPr vert="horz" lIns="91440" tIns="45720" rIns="91440" bIns="45720" rtlCol="0" anchor="b"/>
+          <a:lstStyle>
+            <a:lvl1pPr algn="l">
+              <a:defRPr sz="1200"/>
+            </a:lvl1pPr>
+          </a:lstStyle>
+          <a:p>
+            <a:endParaRPr lang="en-SG"/>
+          </a:p>
+        </p:txBody>
+      </p:sp>
+      <p:sp>
+        <p:nvSpPr>
+          <p:cNvPr id="7" name="Slide Number Placeholder 6"/>
+          <p:cNvSpPr>
+            <a:spLocks noGrp="1"/>
+          </p:cNvSpPr>
+          <p:nvPr>
+            <p:ph type="sldNum" sz="quarter" idx="5"/>
+          </p:nvPr>
+        </p:nvSpPr>
+        <p:spPr>
+          <a:xfrm>
+            <a:off x="3884613" y="8685213"/>
+            <a:ext cx="2971800" cy="458787"/>
+          </a:xfrm>
+          <a:prstGeom prst="rect">
+            <a:avLst/>
+          </a:prstGeom>
+        </p:spPr>
+        <p:txBody>
+          <a:bodyPr vert="horz" lIns="91440" tIns="45720" rIns="91440" bIns="45720" rtlCol="0" anchor="b"/>
+          <a:lstStyle>
+            <a:lvl1pPr algn="r">
+              <a:defRPr sz="1200"/>
+            </a:lvl1pPr>
+          </a:lstStyle>
+          <a:p>
+            <a:fld id="{36D3BBB4-C4FE-47A6-B9D4-00C7D602B05D}" type="slidenum">
+              <a:rPr lang="en-SG" smtClean="0"/>
+              <a:t>‹#›</a:t>
+            </a:fld>
+            <a:endParaRPr lang="en-SG"/>
+          </a:p>
+        </p:txBody>
+      </p:sp>
+    </p:spTree>
+    <p:extLst>
+      <p:ext uri="{BB962C8B-B14F-4D97-AF65-F5344CB8AC3E}">
+        <p14:creationId xmlns:p14="http://schemas.microsoft.com/office/powerpoint/2010/main" val="2482329771"/>
+      </p:ext>
+    </p:extLst>
+  </p:cSld>
+  <p:clrMap bg1="lt1" tx1="dk1" bg2="lt2" tx2="dk2" accent1="accent1" accent2="accent2" accent3="accent3" accent4="accent4" accent5="accent5" accent6="accent6" hlink="hlink" folHlink="folHlink"/>
+  <p:notesStyle>
+    <a:lvl1pPr marL="0" algn="l" defTabSz="914400" rtl="0" eaLnBrk="1" latinLnBrk="0" hangingPunct="1">
+      <a:defRPr sz="1200" kern="1200">
+        <a:solidFill>
+          <a:schemeClr val="tx1"/>
+        </a:solidFill>
+        <a:latin typeface="+mn-lt"/>
+        <a:ea typeface="+mn-ea"/>
+        <a:cs typeface="+mn-cs"/>
+      </a:defRPr>
+    </a:lvl1pPr>
+    <a:lvl2pPr marL="457200" algn="l" defTabSz="914400" rtl="0" eaLnBrk="1" latinLnBrk="0" hangingPunct="1">
+      <a:defRPr sz="1200" kern="1200">
+        <a:solidFill>
+          <a:schemeClr val="tx1"/>
+        </a:solidFill>
+        <a:latin typeface="+mn-lt"/>
+        <a:ea typeface="+mn-ea"/>
+        <a:cs typeface="+mn-cs"/>
+      </a:defRPr>
+    </a:lvl2pPr>
+    <a:lvl3pPr marL="914400" algn="l" defTabSz="914400" rtl="0" eaLnBrk="1" latinLnBrk="0" hangingPunct="1">
+      <a:defRPr sz="1200" kern="1200">
+        <a:solidFill>
+          <a:schemeClr val="tx1"/>
+        </a:solidFill>
+        <a:latin typeface="+mn-lt"/>
+        <a:ea typeface="+mn-ea"/>
+        <a:cs typeface="+mn-cs"/>
+      </a:defRPr>
+    </a:lvl3pPr>
+    <a:lvl4pPr marL="1371600" algn="l" defTabSz="914400" rtl="0" eaLnBrk="1" latinLnBrk="0" hangingPunct="1">
+      <a:defRPr sz="1200" kern="1200">
+        <a:solidFill>
+          <a:schemeClr val="tx1"/>
+        </a:solidFill>
+        <a:latin typeface="+mn-lt"/>
+        <a:ea typeface="+mn-ea"/>
+        <a:cs typeface="+mn-cs"/>
+      </a:defRPr>
+    </a:lvl4pPr>
+    <a:lvl5pPr marL="1828800" algn="l" defTabSz="914400" rtl="0" eaLnBrk="1" latinLnBrk="0" hangingPunct="1">
+      <a:defRPr sz="1200" kern="1200">
+        <a:solidFill>
+          <a:schemeClr val="tx1"/>
+        </a:solidFill>
+        <a:latin typeface="+mn-lt"/>
+        <a:ea typeface="+mn-ea"/>
+        <a:cs typeface="+mn-cs"/>
+      </a:defRPr>
+    </a:lvl5pPr>
+    <a:lvl6pPr marL="2286000" algn="l" defTabSz="914400" rtl="0" eaLnBrk="1" latinLnBrk="0" hangingPunct="1">
+      <a:defRPr sz="1200" kern="1200">
+        <a:solidFill>
+          <a:schemeClr val="tx1"/>
+        </a:solidFill>
+        <a:latin typeface="+mn-lt"/>
+        <a:ea typeface="+mn-ea"/>
+        <a:cs typeface="+mn-cs"/>
+      </a:defRPr>
+    </a:lvl6pPr>
+    <a:lvl7pPr marL="2743200" algn="l" defTabSz="914400" rtl="0" eaLnBrk="1" latinLnBrk="0" hangingPunct="1">
+      <a:defRPr sz="1200" kern="1200">
+        <a:solidFill>
+          <a:schemeClr val="tx1"/>
+        </a:solidFill>
+        <a:latin typeface="+mn-lt"/>
+        <a:ea typeface="+mn-ea"/>
+        <a:cs typeface="+mn-cs"/>
+      </a:defRPr>
+    </a:lvl7pPr>
+    <a:lvl8pPr marL="3200400" algn="l" defTabSz="914400" rtl="0" eaLnBrk="1" latinLnBrk="0" hangingPunct="1">
+      <a:defRPr sz="1200" kern="1200">
+        <a:solidFill>
+          <a:schemeClr val="tx1"/>
+        </a:solidFill>
+        <a:latin typeface="+mn-lt"/>
+        <a:ea typeface="+mn-ea"/>
+        <a:cs typeface="+mn-cs"/>
+      </a:defRPr>
+    </a:lvl8pPr>
+    <a:lvl9pPr marL="3657600" algn="l" defTabSz="914400" rtl="0" eaLnBrk="1" latinLnBrk="0" hangingPunct="1">
+      <a:defRPr sz="1200" kern="1200">
+        <a:solidFill>
+          <a:schemeClr val="tx1"/>
+        </a:solidFill>
+        <a:latin typeface="+mn-lt"/>
+        <a:ea typeface="+mn-ea"/>
+        <a:cs typeface="+mn-cs"/>
+      </a:defRPr>
+    </a:lvl9pPr>
+  </p:notesStyle>
+</p:notesMaster>
+</file>
+
+<file path=ppt/notesSlides/notesSlide1.xml><?xml version="1.0" encoding="utf-8"?>
+<p:notes xmlns:a="http://schemas.openxmlformats.org/drawingml/2006/main" xmlns:r="http://schemas.openxmlformats.org/officeDocument/2006/relationships" xmlns:p="http://schemas.openxmlformats.org/presentationml/2006/main">
+  <p:cSld>
+    <p:spTree>
+      <p:nvGrpSpPr>
+        <p:cNvPr id="1" name=""/>
+        <p:cNvGrpSpPr/>
+        <p:nvPr/>
+      </p:nvGrpSpPr>
+      <p:grpSpPr>
+        <a:xfrm>
+          <a:off x="0" y="0"/>
+          <a:ext cx="0" cy="0"/>
+          <a:chOff x="0" y="0"/>
+          <a:chExt cx="0" cy="0"/>
+        </a:xfrm>
+      </p:grpSpPr>
+      <p:sp>
+        <p:nvSpPr>
+          <p:cNvPr id="2" name="Slide Image Placeholder 1"/>
+          <p:cNvSpPr>
+            <a:spLocks noGrp="1" noRot="1" noChangeAspect="1"/>
+          </p:cNvSpPr>
+          <p:nvPr>
+            <p:ph type="sldImg"/>
+          </p:nvPr>
+        </p:nvSpPr>
+        <p:spPr/>
+      </p:sp>
+      <p:sp>
+        <p:nvSpPr>
+          <p:cNvPr id="3" name="Notes Placeholder 2"/>
+          <p:cNvSpPr>
+            <a:spLocks noGrp="1"/>
+          </p:cNvSpPr>
+          <p:nvPr>
+            <p:ph type="body" idx="1"/>
+          </p:nvPr>
+        </p:nvSpPr>
+        <p:spPr/>
+        <p:txBody>
+          <a:bodyPr/>
+          <a:lstStyle/>
+          <a:p>
+            <a:endParaRPr lang="en-SG" dirty="0"/>
+          </a:p>
+        </p:txBody>
+      </p:sp>
+      <p:sp>
+        <p:nvSpPr>
+          <p:cNvPr id="4" name="Slide Number Placeholder 3"/>
+          <p:cNvSpPr>
+            <a:spLocks noGrp="1"/>
+          </p:cNvSpPr>
+          <p:nvPr>
+            <p:ph type="sldNum" sz="quarter" idx="5"/>
+          </p:nvPr>
+        </p:nvSpPr>
+        <p:spPr/>
+        <p:txBody>
+          <a:bodyPr/>
+          <a:lstStyle/>
+          <a:p>
+            <a:fld id="{36D3BBB4-C4FE-47A6-B9D4-00C7D602B05D}" type="slidenum">
+              <a:rPr lang="en-SG" smtClean="0"/>
+              <a:t>3</a:t>
+            </a:fld>
+            <a:endParaRPr lang="en-SG"/>
+          </a:p>
+        </p:txBody>
+      </p:sp>
+    </p:spTree>
+    <p:extLst>
+      <p:ext uri="{BB962C8B-B14F-4D97-AF65-F5344CB8AC3E}">
+        <p14:creationId xmlns:p14="http://schemas.microsoft.com/office/powerpoint/2010/main" val="703477156"/>
+      </p:ext>
+    </p:extLst>
+  </p:cSld>
+  <p:clrMapOvr>
+    <a:masterClrMapping/>
+  </p:clrMapOvr>
+</p:notes>
+</file>
+
 <file path=ppt/slideLayouts/slideLayout1.xml><?xml version="1.0" encoding="utf-8"?>
 <p:sldLayout xmlns:a="http://schemas.openxmlformats.org/drawingml/2006/main" xmlns:r="http://schemas.openxmlformats.org/officeDocument/2006/relationships" xmlns:p="http://schemas.openxmlformats.org/presentationml/2006/main" type="title" preserve="1">
   <p:cSld name="Title Slide">
@@ -262,7 +701,7 @@
           <a:p>
             <a:fld id="{5BEA1B8F-E5B4-4E7F-AEC3-929E37D0EBCF}" type="datetimeFigureOut">
               <a:rPr lang="en-SG" smtClean="0"/>
-              <a:t>12/3/2026</a:t>
+              <a:t>13/3/2026</a:t>
             </a:fld>
             <a:endParaRPr lang="en-SG"/>
           </a:p>
@@ -462,7 +901,7 @@
           <a:p>
             <a:fld id="{5BEA1B8F-E5B4-4E7F-AEC3-929E37D0EBCF}" type="datetimeFigureOut">
               <a:rPr lang="en-SG" smtClean="0"/>
-              <a:t>12/3/2026</a:t>
+              <a:t>13/3/2026</a:t>
             </a:fld>
             <a:endParaRPr lang="en-SG"/>
           </a:p>
@@ -672,7 +1111,7 @@
           <a:p>
             <a:fld id="{5BEA1B8F-E5B4-4E7F-AEC3-929E37D0EBCF}" type="datetimeFigureOut">
               <a:rPr lang="en-SG" smtClean="0"/>
-              <a:t>12/3/2026</a:t>
+              <a:t>13/3/2026</a:t>
             </a:fld>
             <a:endParaRPr lang="en-SG"/>
           </a:p>
@@ -872,7 +1311,7 @@
           <a:p>
             <a:fld id="{5BEA1B8F-E5B4-4E7F-AEC3-929E37D0EBCF}" type="datetimeFigureOut">
               <a:rPr lang="en-SG" smtClean="0"/>
-              <a:t>12/3/2026</a:t>
+              <a:t>13/3/2026</a:t>
             </a:fld>
             <a:endParaRPr lang="en-SG"/>
           </a:p>
@@ -1148,7 +1587,7 @@
           <a:p>
             <a:fld id="{5BEA1B8F-E5B4-4E7F-AEC3-929E37D0EBCF}" type="datetimeFigureOut">
               <a:rPr lang="en-SG" smtClean="0"/>
-              <a:t>12/3/2026</a:t>
+              <a:t>13/3/2026</a:t>
             </a:fld>
             <a:endParaRPr lang="en-SG"/>
           </a:p>
@@ -1416,7 +1855,7 @@
           <a:p>
             <a:fld id="{5BEA1B8F-E5B4-4E7F-AEC3-929E37D0EBCF}" type="datetimeFigureOut">
               <a:rPr lang="en-SG" smtClean="0"/>
-              <a:t>12/3/2026</a:t>
+              <a:t>13/3/2026</a:t>
             </a:fld>
             <a:endParaRPr lang="en-SG"/>
           </a:p>
@@ -1831,7 +2270,7 @@
           <a:p>
             <a:fld id="{5BEA1B8F-E5B4-4E7F-AEC3-929E37D0EBCF}" type="datetimeFigureOut">
               <a:rPr lang="en-SG" smtClean="0"/>
-              <a:t>12/3/2026</a:t>
+              <a:t>13/3/2026</a:t>
             </a:fld>
             <a:endParaRPr lang="en-SG"/>
           </a:p>
@@ -1973,7 +2412,7 @@
           <a:p>
             <a:fld id="{5BEA1B8F-E5B4-4E7F-AEC3-929E37D0EBCF}" type="datetimeFigureOut">
               <a:rPr lang="en-SG" smtClean="0"/>
-              <a:t>12/3/2026</a:t>
+              <a:t>13/3/2026</a:t>
             </a:fld>
             <a:endParaRPr lang="en-SG"/>
           </a:p>
@@ -2086,7 +2525,7 @@
           <a:p>
             <a:fld id="{5BEA1B8F-E5B4-4E7F-AEC3-929E37D0EBCF}" type="datetimeFigureOut">
               <a:rPr lang="en-SG" smtClean="0"/>
-              <a:t>12/3/2026</a:t>
+              <a:t>13/3/2026</a:t>
             </a:fld>
             <a:endParaRPr lang="en-SG"/>
           </a:p>
@@ -2399,7 +2838,7 @@
           <a:p>
             <a:fld id="{5BEA1B8F-E5B4-4E7F-AEC3-929E37D0EBCF}" type="datetimeFigureOut">
               <a:rPr lang="en-SG" smtClean="0"/>
-              <a:t>12/3/2026</a:t>
+              <a:t>13/3/2026</a:t>
             </a:fld>
             <a:endParaRPr lang="en-SG"/>
           </a:p>
@@ -2688,7 +3127,7 @@
           <a:p>
             <a:fld id="{5BEA1B8F-E5B4-4E7F-AEC3-929E37D0EBCF}" type="datetimeFigureOut">
               <a:rPr lang="en-SG" smtClean="0"/>
-              <a:t>12/3/2026</a:t>
+              <a:t>13/3/2026</a:t>
             </a:fld>
             <a:endParaRPr lang="en-SG"/>
           </a:p>
@@ -2931,7 +3370,7 @@
           <a:p>
             <a:fld id="{5BEA1B8F-E5B4-4E7F-AEC3-929E37D0EBCF}" type="datetimeFigureOut">
               <a:rPr lang="en-SG" smtClean="0"/>
-              <a:t>12/3/2026</a:t>
+              <a:t>13/3/2026</a:t>
             </a:fld>
             <a:endParaRPr lang="en-SG"/>
           </a:p>
@@ -3951,7 +4390,7 @@
         </p:blipFill>
         <p:spPr>
           <a:xfrm>
-            <a:off x="4405433" y="4395912"/>
+            <a:off x="4343537" y="3755224"/>
             <a:ext cx="3217333" cy="1246716"/>
           </a:xfrm>
           <a:prstGeom prst="rect">
@@ -3981,8 +4420,38 @@
         </p:blipFill>
         <p:spPr>
           <a:xfrm>
-            <a:off x="8313518" y="4300349"/>
-            <a:ext cx="3252903" cy="1374351"/>
+            <a:off x="4452666" y="4984009"/>
+            <a:ext cx="2999074" cy="1267108"/>
+          </a:xfrm>
+          <a:prstGeom prst="rect">
+            <a:avLst/>
+          </a:prstGeom>
+        </p:spPr>
+      </p:pic>
+      <p:pic>
+        <p:nvPicPr>
+          <p:cNvPr id="4" name="Picture 3">
+            <a:extLst>
+              <a:ext uri="{FF2B5EF4-FFF2-40B4-BE49-F238E27FC236}">
+                <a16:creationId xmlns:a16="http://schemas.microsoft.com/office/drawing/2014/main" id="{6CEED8AD-9DCC-04F9-FDE6-86E101AF7C9E}"/>
+              </a:ext>
+            </a:extLst>
+          </p:cNvPr>
+          <p:cNvPicPr>
+            <a:picLocks noChangeAspect="1"/>
+          </p:cNvPicPr>
+          <p:nvPr/>
+        </p:nvPicPr>
+        <p:blipFill>
+          <a:blip r:embed="rId8"/>
+          <a:stretch>
+            <a:fillRect/>
+          </a:stretch>
+        </p:blipFill>
+        <p:spPr>
+          <a:xfrm>
+            <a:off x="8313518" y="3755224"/>
+            <a:ext cx="3198617" cy="2533407"/>
           </a:xfrm>
           <a:prstGeom prst="rect">
             <a:avLst/>
@@ -4226,6 +4695,2621 @@
     <p:extLst>
       <p:ext uri="{BB962C8B-B14F-4D97-AF65-F5344CB8AC3E}">
         <p14:creationId xmlns:p14="http://schemas.microsoft.com/office/powerpoint/2010/main" val="2791645031"/>
+      </p:ext>
+    </p:extLst>
+  </p:cSld>
+  <p:clrMapOvr>
+    <a:masterClrMapping/>
+  </p:clrMapOvr>
+</p:sld>
+</file>
+
+<file path=ppt/slides/slide3.xml><?xml version="1.0" encoding="utf-8"?>
+<p:sld xmlns:a="http://schemas.openxmlformats.org/drawingml/2006/main" xmlns:r="http://schemas.openxmlformats.org/officeDocument/2006/relationships" xmlns:p="http://schemas.openxmlformats.org/presentationml/2006/main">
+  <p:cSld>
+    <p:spTree>
+      <p:nvGrpSpPr>
+        <p:cNvPr id="1" name=""/>
+        <p:cNvGrpSpPr/>
+        <p:nvPr/>
+      </p:nvGrpSpPr>
+      <p:grpSpPr>
+        <a:xfrm>
+          <a:off x="0" y="0"/>
+          <a:ext cx="0" cy="0"/>
+          <a:chOff x="0" y="0"/>
+          <a:chExt cx="0" cy="0"/>
+        </a:xfrm>
+      </p:grpSpPr>
+      <p:sp>
+        <p:nvSpPr>
+          <p:cNvPr id="83" name="Rectangle 82">
+            <a:extLst>
+              <a:ext uri="{FF2B5EF4-FFF2-40B4-BE49-F238E27FC236}">
+                <a16:creationId xmlns:a16="http://schemas.microsoft.com/office/drawing/2014/main" id="{1CD9592C-F99C-5F17-9C30-9C5EA18CC5CE}"/>
+              </a:ext>
+            </a:extLst>
+          </p:cNvPr>
+          <p:cNvSpPr/>
+          <p:nvPr/>
+        </p:nvSpPr>
+        <p:spPr>
+          <a:xfrm>
+            <a:off x="779646" y="1222408"/>
+            <a:ext cx="6814687" cy="4379495"/>
+          </a:xfrm>
+          <a:prstGeom prst="rect">
+            <a:avLst/>
+          </a:prstGeom>
+          <a:noFill/>
+          <a:ln>
+            <a:solidFill>
+              <a:schemeClr val="tx2">
+                <a:lumMod val="75000"/>
+                <a:lumOff val="25000"/>
+              </a:schemeClr>
+            </a:solidFill>
+            <a:prstDash val="sysDash"/>
+          </a:ln>
+        </p:spPr>
+        <p:style>
+          <a:lnRef idx="2">
+            <a:schemeClr val="accent1">
+              <a:shade val="15000"/>
+            </a:schemeClr>
+          </a:lnRef>
+          <a:fillRef idx="1">
+            <a:schemeClr val="accent1"/>
+          </a:fillRef>
+          <a:effectRef idx="0">
+            <a:schemeClr val="accent1"/>
+          </a:effectRef>
+          <a:fontRef idx="minor">
+            <a:schemeClr val="lt1"/>
+          </a:fontRef>
+        </p:style>
+        <p:txBody>
+          <a:bodyPr rtlCol="0" anchor="ctr"/>
+          <a:lstStyle/>
+          <a:p>
+            <a:pPr algn="ctr"/>
+            <a:endParaRPr lang="en-SG" dirty="0"/>
+          </a:p>
+        </p:txBody>
+      </p:sp>
+      <p:sp>
+        <p:nvSpPr>
+          <p:cNvPr id="4" name="Rectangle 3">
+            <a:extLst>
+              <a:ext uri="{FF2B5EF4-FFF2-40B4-BE49-F238E27FC236}">
+                <a16:creationId xmlns:a16="http://schemas.microsoft.com/office/drawing/2014/main" id="{0302BAB0-98D4-F006-9063-2DFBB019C993}"/>
+              </a:ext>
+            </a:extLst>
+          </p:cNvPr>
+          <p:cNvSpPr/>
+          <p:nvPr/>
+        </p:nvSpPr>
+        <p:spPr>
+          <a:xfrm>
+            <a:off x="1150799" y="2861946"/>
+            <a:ext cx="2287802" cy="1784089"/>
+          </a:xfrm>
+          <a:prstGeom prst="rect">
+            <a:avLst/>
+          </a:prstGeom>
+          <a:solidFill>
+            <a:schemeClr val="accent6">
+              <a:lumMod val="50000"/>
+            </a:schemeClr>
+          </a:solidFill>
+        </p:spPr>
+        <p:style>
+          <a:lnRef idx="2">
+            <a:schemeClr val="accent1">
+              <a:shade val="15000"/>
+            </a:schemeClr>
+          </a:lnRef>
+          <a:fillRef idx="1">
+            <a:schemeClr val="accent1"/>
+          </a:fillRef>
+          <a:effectRef idx="0">
+            <a:schemeClr val="accent1"/>
+          </a:effectRef>
+          <a:fontRef idx="minor">
+            <a:schemeClr val="lt1"/>
+          </a:fontRef>
+        </p:style>
+        <p:txBody>
+          <a:bodyPr rtlCol="0" anchor="ctr"/>
+          <a:lstStyle/>
+          <a:p>
+            <a:pPr algn="ctr"/>
+            <a:endParaRPr lang="en-SG" dirty="0"/>
+          </a:p>
+        </p:txBody>
+      </p:sp>
+      <p:sp>
+        <p:nvSpPr>
+          <p:cNvPr id="5" name="Rectangle 4">
+            <a:extLst>
+              <a:ext uri="{FF2B5EF4-FFF2-40B4-BE49-F238E27FC236}">
+                <a16:creationId xmlns:a16="http://schemas.microsoft.com/office/drawing/2014/main" id="{98693BB9-E884-60AE-4D75-D47CFB26C11C}"/>
+              </a:ext>
+            </a:extLst>
+          </p:cNvPr>
+          <p:cNvSpPr/>
+          <p:nvPr/>
+        </p:nvSpPr>
+        <p:spPr>
+          <a:xfrm>
+            <a:off x="1019908" y="1736902"/>
+            <a:ext cx="2945700" cy="3229734"/>
+          </a:xfrm>
+          <a:prstGeom prst="rect">
+            <a:avLst/>
+          </a:prstGeom>
+          <a:noFill/>
+        </p:spPr>
+        <p:style>
+          <a:lnRef idx="2">
+            <a:schemeClr val="accent1">
+              <a:shade val="15000"/>
+            </a:schemeClr>
+          </a:lnRef>
+          <a:fillRef idx="1">
+            <a:schemeClr val="accent1"/>
+          </a:fillRef>
+          <a:effectRef idx="0">
+            <a:schemeClr val="accent1"/>
+          </a:effectRef>
+          <a:fontRef idx="minor">
+            <a:schemeClr val="lt1"/>
+          </a:fontRef>
+        </p:style>
+        <p:txBody>
+          <a:bodyPr rtlCol="0" anchor="ctr"/>
+          <a:lstStyle/>
+          <a:p>
+            <a:pPr algn="ctr"/>
+            <a:endParaRPr lang="en-SG"/>
+          </a:p>
+        </p:txBody>
+      </p:sp>
+      <p:pic>
+        <p:nvPicPr>
+          <p:cNvPr id="6" name="Picture 2" descr="DeepSeek Logo and symbol, meaning ...">
+            <a:extLst>
+              <a:ext uri="{FF2B5EF4-FFF2-40B4-BE49-F238E27FC236}">
+                <a16:creationId xmlns:a16="http://schemas.microsoft.com/office/drawing/2014/main" id="{6BE63F29-9723-C50F-A071-BEF6C15A4BEE}"/>
+              </a:ext>
+            </a:extLst>
+          </p:cNvPr>
+          <p:cNvPicPr>
+            <a:picLocks noChangeAspect="1" noChangeArrowheads="1"/>
+          </p:cNvPicPr>
+          <p:nvPr/>
+        </p:nvPicPr>
+        <p:blipFill rotWithShape="1">
+          <a:blip r:embed="rId3">
+            <a:extLst>
+              <a:ext uri="{28A0092B-C50C-407E-A947-70E740481C1C}">
+                <a14:useLocalDpi xmlns:a14="http://schemas.microsoft.com/office/drawing/2010/main" val="0"/>
+              </a:ext>
+            </a:extLst>
+          </a:blip>
+          <a:srcRect t="17745" b="19385"/>
+          <a:stretch/>
+        </p:blipFill>
+        <p:spPr bwMode="auto">
+          <a:xfrm>
+            <a:off x="1276207" y="3799734"/>
+            <a:ext cx="1519097" cy="534829"/>
+          </a:xfrm>
+          <a:prstGeom prst="rect">
+            <a:avLst/>
+          </a:prstGeom>
+          <a:noFill/>
+          <a:ln w="19050">
+            <a:solidFill>
+              <a:schemeClr val="tx1"/>
+            </a:solidFill>
+          </a:ln>
+          <a:extLst>
+            <a:ext uri="{909E8E84-426E-40DD-AFC4-6F175D3DCCD1}">
+              <a14:hiddenFill xmlns:a14="http://schemas.microsoft.com/office/drawing/2010/main">
+                <a:solidFill>
+                  <a:srgbClr val="FFFFFF"/>
+                </a:solidFill>
+              </a14:hiddenFill>
+            </a:ext>
+          </a:extLst>
+        </p:spPr>
+      </p:pic>
+      <p:pic>
+        <p:nvPicPr>
+          <p:cNvPr id="7" name="Picture 6" descr="Run DeepSeek-R1 Locally for Free in Just 3 Minutes! - DEV Community">
+            <a:extLst>
+              <a:ext uri="{FF2B5EF4-FFF2-40B4-BE49-F238E27FC236}">
+                <a16:creationId xmlns:a16="http://schemas.microsoft.com/office/drawing/2014/main" id="{9D8636EF-5C3B-C9B9-0839-968C99677BE1}"/>
+              </a:ext>
+            </a:extLst>
+          </p:cNvPr>
+          <p:cNvPicPr>
+            <a:picLocks noChangeAspect="1" noChangeArrowheads="1"/>
+          </p:cNvPicPr>
+          <p:nvPr/>
+        </p:nvPicPr>
+        <p:blipFill>
+          <a:blip r:embed="rId4">
+            <a:extLst>
+              <a:ext uri="{28A0092B-C50C-407E-A947-70E740481C1C}">
+                <a14:useLocalDpi xmlns:a14="http://schemas.microsoft.com/office/drawing/2010/main" val="0"/>
+              </a:ext>
+            </a:extLst>
+          </a:blip>
+          <a:srcRect/>
+          <a:stretch>
+            <a:fillRect/>
+          </a:stretch>
+        </p:blipFill>
+        <p:spPr bwMode="auto">
+          <a:xfrm>
+            <a:off x="1823238" y="2206244"/>
+            <a:ext cx="1378868" cy="514834"/>
+          </a:xfrm>
+          <a:prstGeom prst="rect">
+            <a:avLst/>
+          </a:prstGeom>
+          <a:noFill/>
+          <a:extLst>
+            <a:ext uri="{909E8E84-426E-40DD-AFC4-6F175D3DCCD1}">
+              <a14:hiddenFill xmlns:a14="http://schemas.microsoft.com/office/drawing/2010/main">
+                <a:solidFill>
+                  <a:srgbClr val="FFFFFF"/>
+                </a:solidFill>
+              </a14:hiddenFill>
+            </a:ext>
+          </a:extLst>
+        </p:spPr>
+      </p:pic>
+      <p:sp>
+        <p:nvSpPr>
+          <p:cNvPr id="10" name="TextBox 9">
+            <a:extLst>
+              <a:ext uri="{FF2B5EF4-FFF2-40B4-BE49-F238E27FC236}">
+                <a16:creationId xmlns:a16="http://schemas.microsoft.com/office/drawing/2014/main" id="{CC9F04B9-88FC-7726-F779-0F2A6CB87E3D}"/>
+              </a:ext>
+            </a:extLst>
+          </p:cNvPr>
+          <p:cNvSpPr txBox="1"/>
+          <p:nvPr/>
+        </p:nvSpPr>
+        <p:spPr>
+          <a:xfrm>
+            <a:off x="1180733" y="4351799"/>
+            <a:ext cx="2324388" cy="276999"/>
+          </a:xfrm>
+          <a:prstGeom prst="rect">
+            <a:avLst/>
+          </a:prstGeom>
+          <a:noFill/>
+        </p:spPr>
+        <p:txBody>
+          <a:bodyPr wrap="square">
+            <a:spAutoFit/>
+          </a:bodyPr>
+          <a:lstStyle/>
+          <a:p>
+            <a:r>
+              <a:rPr lang="en-US" sz="1200" b="1" dirty="0">
+                <a:solidFill>
+                  <a:schemeClr val="bg1"/>
+                </a:solidFill>
+              </a:rPr>
+              <a:t>deepseek-r1-tool-calling:14b </a:t>
+            </a:r>
+            <a:endParaRPr lang="en-SG" sz="1200" b="1" dirty="0">
+              <a:solidFill>
+                <a:schemeClr val="bg1"/>
+              </a:solidFill>
+            </a:endParaRPr>
+          </a:p>
+        </p:txBody>
+      </p:sp>
+      <p:pic>
+        <p:nvPicPr>
+          <p:cNvPr id="12" name="Picture 11">
+            <a:extLst>
+              <a:ext uri="{FF2B5EF4-FFF2-40B4-BE49-F238E27FC236}">
+                <a16:creationId xmlns:a16="http://schemas.microsoft.com/office/drawing/2014/main" id="{22BF3DF9-EC15-C0B8-E574-1A8F4830E952}"/>
+              </a:ext>
+            </a:extLst>
+          </p:cNvPr>
+          <p:cNvPicPr>
+            <a:picLocks noChangeAspect="1"/>
+          </p:cNvPicPr>
+          <p:nvPr/>
+        </p:nvPicPr>
+        <p:blipFill>
+          <a:blip r:embed="rId5"/>
+          <a:stretch>
+            <a:fillRect/>
+          </a:stretch>
+        </p:blipFill>
+        <p:spPr>
+          <a:xfrm>
+            <a:off x="1129203" y="2206244"/>
+            <a:ext cx="561512" cy="558025"/>
+          </a:xfrm>
+          <a:prstGeom prst="rect">
+            <a:avLst/>
+          </a:prstGeom>
+        </p:spPr>
+      </p:pic>
+      <p:sp>
+        <p:nvSpPr>
+          <p:cNvPr id="13" name="TextBox 12">
+            <a:extLst>
+              <a:ext uri="{FF2B5EF4-FFF2-40B4-BE49-F238E27FC236}">
+                <a16:creationId xmlns:a16="http://schemas.microsoft.com/office/drawing/2014/main" id="{CE668883-D7E5-A114-5515-2F0B4FABFE28}"/>
+              </a:ext>
+            </a:extLst>
+          </p:cNvPr>
+          <p:cNvSpPr txBox="1"/>
+          <p:nvPr/>
+        </p:nvSpPr>
+        <p:spPr>
+          <a:xfrm>
+            <a:off x="940303" y="1787005"/>
+            <a:ext cx="3146705" cy="338554"/>
+          </a:xfrm>
+          <a:prstGeom prst="rect">
+            <a:avLst/>
+          </a:prstGeom>
+          <a:noFill/>
+        </p:spPr>
+        <p:txBody>
+          <a:bodyPr wrap="square">
+            <a:spAutoFit/>
+          </a:bodyPr>
+          <a:lstStyle/>
+          <a:p>
+            <a:r>
+              <a:rPr lang="en-US" sz="1600" b="1" dirty="0"/>
+              <a:t>GPU Server or A Gaming Laptop </a:t>
+            </a:r>
+            <a:endParaRPr lang="en-SG" sz="1600" b="1" dirty="0"/>
+          </a:p>
+        </p:txBody>
+      </p:sp>
+      <p:pic>
+        <p:nvPicPr>
+          <p:cNvPr id="15" name="Picture 14">
+            <a:extLst>
+              <a:ext uri="{FF2B5EF4-FFF2-40B4-BE49-F238E27FC236}">
+                <a16:creationId xmlns:a16="http://schemas.microsoft.com/office/drawing/2014/main" id="{5C678BE1-A813-A436-945F-01741597AF66}"/>
+              </a:ext>
+            </a:extLst>
+          </p:cNvPr>
+          <p:cNvPicPr>
+            <a:picLocks noChangeAspect="1"/>
+          </p:cNvPicPr>
+          <p:nvPr/>
+        </p:nvPicPr>
+        <p:blipFill>
+          <a:blip r:embed="rId6"/>
+          <a:stretch>
+            <a:fillRect/>
+          </a:stretch>
+        </p:blipFill>
+        <p:spPr>
+          <a:xfrm>
+            <a:off x="3826169" y="3005434"/>
+            <a:ext cx="368410" cy="361325"/>
+          </a:xfrm>
+          <a:prstGeom prst="rect">
+            <a:avLst/>
+          </a:prstGeom>
+        </p:spPr>
+      </p:pic>
+      <p:pic>
+        <p:nvPicPr>
+          <p:cNvPr id="19" name="Picture 18">
+            <a:extLst>
+              <a:ext uri="{FF2B5EF4-FFF2-40B4-BE49-F238E27FC236}">
+                <a16:creationId xmlns:a16="http://schemas.microsoft.com/office/drawing/2014/main" id="{29ABF061-C942-D852-33FB-ABF513DDF435}"/>
+              </a:ext>
+            </a:extLst>
+          </p:cNvPr>
+          <p:cNvPicPr>
+            <a:picLocks noChangeAspect="1"/>
+          </p:cNvPicPr>
+          <p:nvPr/>
+        </p:nvPicPr>
+        <p:blipFill>
+          <a:blip r:embed="rId7"/>
+          <a:stretch>
+            <a:fillRect/>
+          </a:stretch>
+        </p:blipFill>
+        <p:spPr>
+          <a:xfrm>
+            <a:off x="1311027" y="2978193"/>
+            <a:ext cx="1519097" cy="553135"/>
+          </a:xfrm>
+          <a:prstGeom prst="rect">
+            <a:avLst/>
+          </a:prstGeom>
+          <a:ln w="9525">
+            <a:solidFill>
+              <a:schemeClr val="tx1"/>
+            </a:solidFill>
+          </a:ln>
+        </p:spPr>
+      </p:pic>
+      <p:sp>
+        <p:nvSpPr>
+          <p:cNvPr id="20" name="TextBox 19">
+            <a:extLst>
+              <a:ext uri="{FF2B5EF4-FFF2-40B4-BE49-F238E27FC236}">
+                <a16:creationId xmlns:a16="http://schemas.microsoft.com/office/drawing/2014/main" id="{B47A49B0-D22C-D6BD-F3B9-FB70EB8B8DE5}"/>
+              </a:ext>
+            </a:extLst>
+          </p:cNvPr>
+          <p:cNvSpPr txBox="1"/>
+          <p:nvPr/>
+        </p:nvSpPr>
+        <p:spPr>
+          <a:xfrm>
+            <a:off x="1210667" y="3553420"/>
+            <a:ext cx="2324388" cy="276999"/>
+          </a:xfrm>
+          <a:prstGeom prst="rect">
+            <a:avLst/>
+          </a:prstGeom>
+          <a:noFill/>
+        </p:spPr>
+        <p:txBody>
+          <a:bodyPr wrap="square">
+            <a:spAutoFit/>
+          </a:bodyPr>
+          <a:lstStyle/>
+          <a:p>
+            <a:r>
+              <a:rPr lang="en-US" sz="1200" b="1" dirty="0">
+                <a:solidFill>
+                  <a:schemeClr val="bg1"/>
+                </a:solidFill>
+              </a:rPr>
+              <a:t>deepseek-r1-tool-calling:14b </a:t>
+            </a:r>
+            <a:endParaRPr lang="en-SG" sz="1200" b="1" dirty="0">
+              <a:solidFill>
+                <a:schemeClr val="bg1"/>
+              </a:solidFill>
+            </a:endParaRPr>
+          </a:p>
+        </p:txBody>
+      </p:sp>
+      <p:sp>
+        <p:nvSpPr>
+          <p:cNvPr id="21" name="TextBox 20">
+            <a:extLst>
+              <a:ext uri="{FF2B5EF4-FFF2-40B4-BE49-F238E27FC236}">
+                <a16:creationId xmlns:a16="http://schemas.microsoft.com/office/drawing/2014/main" id="{C74A8DE0-7B07-90AB-C6BD-6B4331F61A9A}"/>
+              </a:ext>
+            </a:extLst>
+          </p:cNvPr>
+          <p:cNvSpPr txBox="1"/>
+          <p:nvPr/>
+        </p:nvSpPr>
+        <p:spPr>
+          <a:xfrm>
+            <a:off x="3667572" y="3429000"/>
+            <a:ext cx="821646" cy="307777"/>
+          </a:xfrm>
+          <a:prstGeom prst="rect">
+            <a:avLst/>
+          </a:prstGeom>
+          <a:noFill/>
+        </p:spPr>
+        <p:txBody>
+          <a:bodyPr wrap="square">
+            <a:spAutoFit/>
+          </a:bodyPr>
+          <a:lstStyle/>
+          <a:p>
+            <a:r>
+              <a:rPr lang="en-US" sz="1400" b="1" dirty="0">
+                <a:solidFill>
+                  <a:schemeClr val="accent1"/>
+                </a:solidFill>
+              </a:rPr>
+              <a:t>Port:22</a:t>
+            </a:r>
+            <a:endParaRPr lang="en-SG" sz="1400" b="1" dirty="0">
+              <a:solidFill>
+                <a:schemeClr val="accent1"/>
+              </a:solidFill>
+            </a:endParaRPr>
+          </a:p>
+        </p:txBody>
+      </p:sp>
+      <p:sp>
+        <p:nvSpPr>
+          <p:cNvPr id="29" name="Rectangle 28">
+            <a:extLst>
+              <a:ext uri="{FF2B5EF4-FFF2-40B4-BE49-F238E27FC236}">
+                <a16:creationId xmlns:a16="http://schemas.microsoft.com/office/drawing/2014/main" id="{8D284230-396C-2278-5F7F-D80A012E52BA}"/>
+              </a:ext>
+            </a:extLst>
+          </p:cNvPr>
+          <p:cNvSpPr/>
+          <p:nvPr/>
+        </p:nvSpPr>
+        <p:spPr>
+          <a:xfrm>
+            <a:off x="3301465" y="3975234"/>
+            <a:ext cx="262544" cy="276999"/>
+          </a:xfrm>
+          <a:prstGeom prst="rect">
+            <a:avLst/>
+          </a:prstGeom>
+          <a:solidFill>
+            <a:srgbClr val="FFC000"/>
+          </a:solidFill>
+        </p:spPr>
+        <p:style>
+          <a:lnRef idx="2">
+            <a:schemeClr val="accent1">
+              <a:shade val="15000"/>
+            </a:schemeClr>
+          </a:lnRef>
+          <a:fillRef idx="1">
+            <a:schemeClr val="accent1"/>
+          </a:fillRef>
+          <a:effectRef idx="0">
+            <a:schemeClr val="accent1"/>
+          </a:effectRef>
+          <a:fontRef idx="minor">
+            <a:schemeClr val="lt1"/>
+          </a:fontRef>
+        </p:style>
+        <p:txBody>
+          <a:bodyPr rtlCol="0" anchor="ctr"/>
+          <a:lstStyle/>
+          <a:p>
+            <a:pPr algn="ctr"/>
+            <a:endParaRPr lang="en-SG"/>
+          </a:p>
+        </p:txBody>
+      </p:sp>
+      <p:cxnSp>
+        <p:nvCxnSpPr>
+          <p:cNvPr id="31" name="Connector: Elbow 30">
+            <a:extLst>
+              <a:ext uri="{FF2B5EF4-FFF2-40B4-BE49-F238E27FC236}">
+                <a16:creationId xmlns:a16="http://schemas.microsoft.com/office/drawing/2014/main" id="{D62F2BA5-DD1A-E6BE-0BA4-D983EA0AEA24}"/>
+              </a:ext>
+            </a:extLst>
+          </p:cNvPr>
+          <p:cNvCxnSpPr>
+            <a:stCxn id="29" idx="3"/>
+            <a:endCxn id="15" idx="1"/>
+          </p:cNvCxnSpPr>
+          <p:nvPr/>
+        </p:nvCxnSpPr>
+        <p:spPr>
+          <a:xfrm flipV="1">
+            <a:off x="3564009" y="3186097"/>
+            <a:ext cx="262160" cy="927637"/>
+          </a:xfrm>
+          <a:prstGeom prst="bentConnector3">
+            <a:avLst/>
+          </a:prstGeom>
+          <a:ln>
+            <a:tailEnd type="triangle"/>
+          </a:ln>
+        </p:spPr>
+        <p:style>
+          <a:lnRef idx="2">
+            <a:schemeClr val="accent1"/>
+          </a:lnRef>
+          <a:fillRef idx="0">
+            <a:schemeClr val="accent1"/>
+          </a:fillRef>
+          <a:effectRef idx="1">
+            <a:schemeClr val="accent1"/>
+          </a:effectRef>
+          <a:fontRef idx="minor">
+            <a:schemeClr val="tx1"/>
+          </a:fontRef>
+        </p:style>
+      </p:cxnSp>
+      <p:sp>
+        <p:nvSpPr>
+          <p:cNvPr id="32" name="TextBox 31">
+            <a:extLst>
+              <a:ext uri="{FF2B5EF4-FFF2-40B4-BE49-F238E27FC236}">
+                <a16:creationId xmlns:a16="http://schemas.microsoft.com/office/drawing/2014/main" id="{FBBA7D10-E73E-932A-2B7F-5E0E50DE3308}"/>
+              </a:ext>
+            </a:extLst>
+          </p:cNvPr>
+          <p:cNvSpPr txBox="1"/>
+          <p:nvPr/>
+        </p:nvSpPr>
+        <p:spPr>
+          <a:xfrm>
+            <a:off x="1480244" y="4673889"/>
+            <a:ext cx="2699759" cy="307777"/>
+          </a:xfrm>
+          <a:prstGeom prst="rect">
+            <a:avLst/>
+          </a:prstGeom>
+          <a:noFill/>
+        </p:spPr>
+        <p:txBody>
+          <a:bodyPr wrap="square">
+            <a:spAutoFit/>
+          </a:bodyPr>
+          <a:lstStyle/>
+          <a:p>
+            <a:r>
+              <a:rPr lang="en-SG" sz="1400" b="1" dirty="0"/>
+              <a:t>Ollama localhost port 11434 </a:t>
+            </a:r>
+          </a:p>
+        </p:txBody>
+      </p:sp>
+      <p:cxnSp>
+        <p:nvCxnSpPr>
+          <p:cNvPr id="34" name="Straight Arrow Connector 33">
+            <a:extLst>
+              <a:ext uri="{FF2B5EF4-FFF2-40B4-BE49-F238E27FC236}">
+                <a16:creationId xmlns:a16="http://schemas.microsoft.com/office/drawing/2014/main" id="{354C959A-998D-1EC8-F43A-5C6483E51F6E}"/>
+              </a:ext>
+            </a:extLst>
+          </p:cNvPr>
+          <p:cNvCxnSpPr/>
+          <p:nvPr/>
+        </p:nvCxnSpPr>
+        <p:spPr>
+          <a:xfrm flipV="1">
+            <a:off x="3564009" y="4351799"/>
+            <a:ext cx="0" cy="322090"/>
+          </a:xfrm>
+          <a:prstGeom prst="straightConnector1">
+            <a:avLst/>
+          </a:prstGeom>
+          <a:ln>
+            <a:tailEnd type="triangle"/>
+          </a:ln>
+        </p:spPr>
+        <p:style>
+          <a:lnRef idx="2">
+            <a:schemeClr val="accent1"/>
+          </a:lnRef>
+          <a:fillRef idx="0">
+            <a:schemeClr val="accent1"/>
+          </a:fillRef>
+          <a:effectRef idx="1">
+            <a:schemeClr val="accent1"/>
+          </a:effectRef>
+          <a:fontRef idx="minor">
+            <a:schemeClr val="tx1"/>
+          </a:fontRef>
+        </p:style>
+      </p:cxnSp>
+      <p:cxnSp>
+        <p:nvCxnSpPr>
+          <p:cNvPr id="36" name="Straight Connector 35">
+            <a:extLst>
+              <a:ext uri="{FF2B5EF4-FFF2-40B4-BE49-F238E27FC236}">
+                <a16:creationId xmlns:a16="http://schemas.microsoft.com/office/drawing/2014/main" id="{6B8A9578-9624-8D17-4AE0-69B9CA2B4A25}"/>
+              </a:ext>
+            </a:extLst>
+          </p:cNvPr>
+          <p:cNvCxnSpPr>
+            <a:stCxn id="15" idx="3"/>
+          </p:cNvCxnSpPr>
+          <p:nvPr/>
+        </p:nvCxnSpPr>
+        <p:spPr>
+          <a:xfrm flipV="1">
+            <a:off x="4194579" y="3186096"/>
+            <a:ext cx="945312" cy="1"/>
+          </a:xfrm>
+          <a:prstGeom prst="line">
+            <a:avLst/>
+          </a:prstGeom>
+        </p:spPr>
+        <p:style>
+          <a:lnRef idx="2">
+            <a:schemeClr val="accent1"/>
+          </a:lnRef>
+          <a:fillRef idx="0">
+            <a:schemeClr val="accent1"/>
+          </a:fillRef>
+          <a:effectRef idx="1">
+            <a:schemeClr val="accent1"/>
+          </a:effectRef>
+          <a:fontRef idx="minor">
+            <a:schemeClr val="tx1"/>
+          </a:fontRef>
+        </p:style>
+      </p:cxnSp>
+      <p:pic>
+        <p:nvPicPr>
+          <p:cNvPr id="38" name="Picture 37">
+            <a:extLst>
+              <a:ext uri="{FF2B5EF4-FFF2-40B4-BE49-F238E27FC236}">
+                <a16:creationId xmlns:a16="http://schemas.microsoft.com/office/drawing/2014/main" id="{572D62A7-0573-DAFF-3A66-08158A65EC0D}"/>
+              </a:ext>
+            </a:extLst>
+          </p:cNvPr>
+          <p:cNvPicPr>
+            <a:picLocks noChangeAspect="1"/>
+          </p:cNvPicPr>
+          <p:nvPr/>
+        </p:nvPicPr>
+        <p:blipFill>
+          <a:blip r:embed="rId8"/>
+          <a:stretch>
+            <a:fillRect/>
+          </a:stretch>
+        </p:blipFill>
+        <p:spPr>
+          <a:xfrm>
+            <a:off x="5139891" y="2920673"/>
+            <a:ext cx="890533" cy="751231"/>
+          </a:xfrm>
+          <a:prstGeom prst="rect">
+            <a:avLst/>
+          </a:prstGeom>
+          <a:ln w="19050">
+            <a:solidFill>
+              <a:schemeClr val="tx1"/>
+            </a:solidFill>
+          </a:ln>
+        </p:spPr>
+      </p:pic>
+      <p:sp>
+        <p:nvSpPr>
+          <p:cNvPr id="39" name="TextBox 38">
+            <a:extLst>
+              <a:ext uri="{FF2B5EF4-FFF2-40B4-BE49-F238E27FC236}">
+                <a16:creationId xmlns:a16="http://schemas.microsoft.com/office/drawing/2014/main" id="{15B47C1E-9541-36F2-0013-47DC645901AC}"/>
+              </a:ext>
+            </a:extLst>
+          </p:cNvPr>
+          <p:cNvSpPr txBox="1"/>
+          <p:nvPr/>
+        </p:nvSpPr>
+        <p:spPr>
+          <a:xfrm>
+            <a:off x="4362538" y="2613050"/>
+            <a:ext cx="1667886" cy="523220"/>
+          </a:xfrm>
+          <a:prstGeom prst="rect">
+            <a:avLst/>
+          </a:prstGeom>
+          <a:noFill/>
+        </p:spPr>
+        <p:txBody>
+          <a:bodyPr wrap="square">
+            <a:spAutoFit/>
+          </a:bodyPr>
+          <a:lstStyle/>
+          <a:p>
+            <a:r>
+              <a:rPr lang="en-SG" sz="1400" b="1" dirty="0"/>
+              <a:t>Ethernet Router or Switch </a:t>
+            </a:r>
+          </a:p>
+        </p:txBody>
+      </p:sp>
+      <p:sp>
+        <p:nvSpPr>
+          <p:cNvPr id="40" name="Rectangle 39">
+            <a:extLst>
+              <a:ext uri="{FF2B5EF4-FFF2-40B4-BE49-F238E27FC236}">
+                <a16:creationId xmlns:a16="http://schemas.microsoft.com/office/drawing/2014/main" id="{9DDA7419-251C-9BC4-F95A-14B5DD0FDB13}"/>
+              </a:ext>
+            </a:extLst>
+          </p:cNvPr>
+          <p:cNvSpPr/>
+          <p:nvPr/>
+        </p:nvSpPr>
+        <p:spPr>
+          <a:xfrm>
+            <a:off x="5139891" y="4113734"/>
+            <a:ext cx="1940574" cy="1353415"/>
+          </a:xfrm>
+          <a:prstGeom prst="rect">
+            <a:avLst/>
+          </a:prstGeom>
+          <a:noFill/>
+        </p:spPr>
+        <p:style>
+          <a:lnRef idx="2">
+            <a:schemeClr val="accent1">
+              <a:shade val="15000"/>
+            </a:schemeClr>
+          </a:lnRef>
+          <a:fillRef idx="1">
+            <a:schemeClr val="accent1"/>
+          </a:fillRef>
+          <a:effectRef idx="0">
+            <a:schemeClr val="accent1"/>
+          </a:effectRef>
+          <a:fontRef idx="minor">
+            <a:schemeClr val="lt1"/>
+          </a:fontRef>
+        </p:style>
+        <p:txBody>
+          <a:bodyPr rtlCol="0" anchor="ctr"/>
+          <a:lstStyle/>
+          <a:p>
+            <a:pPr algn="ctr"/>
+            <a:endParaRPr lang="en-SG"/>
+          </a:p>
+        </p:txBody>
+      </p:sp>
+      <p:sp>
+        <p:nvSpPr>
+          <p:cNvPr id="41" name="TextBox 40">
+            <a:extLst>
+              <a:ext uri="{FF2B5EF4-FFF2-40B4-BE49-F238E27FC236}">
+                <a16:creationId xmlns:a16="http://schemas.microsoft.com/office/drawing/2014/main" id="{134A836C-34B3-9172-3E85-4F8C08BD9618}"/>
+              </a:ext>
+            </a:extLst>
+          </p:cNvPr>
+          <p:cNvSpPr txBox="1"/>
+          <p:nvPr/>
+        </p:nvSpPr>
+        <p:spPr>
+          <a:xfrm>
+            <a:off x="5722011" y="3695348"/>
+            <a:ext cx="1872322" cy="461665"/>
+          </a:xfrm>
+          <a:prstGeom prst="rect">
+            <a:avLst/>
+          </a:prstGeom>
+          <a:noFill/>
+        </p:spPr>
+        <p:txBody>
+          <a:bodyPr wrap="square">
+            <a:spAutoFit/>
+          </a:bodyPr>
+          <a:lstStyle/>
+          <a:p>
+            <a:r>
+              <a:rPr lang="en-SG" sz="1200" b="1" dirty="0"/>
+              <a:t>Internal network User’s compute server </a:t>
+            </a:r>
+          </a:p>
+        </p:txBody>
+      </p:sp>
+      <p:pic>
+        <p:nvPicPr>
+          <p:cNvPr id="43" name="Picture 42">
+            <a:extLst>
+              <a:ext uri="{FF2B5EF4-FFF2-40B4-BE49-F238E27FC236}">
+                <a16:creationId xmlns:a16="http://schemas.microsoft.com/office/drawing/2014/main" id="{6CB5AD96-1645-FB6F-4D98-7FB8864934D9}"/>
+              </a:ext>
+            </a:extLst>
+          </p:cNvPr>
+          <p:cNvPicPr>
+            <a:picLocks noChangeAspect="1"/>
+          </p:cNvPicPr>
+          <p:nvPr/>
+        </p:nvPicPr>
+        <p:blipFill>
+          <a:blip r:embed="rId9"/>
+          <a:stretch>
+            <a:fillRect/>
+          </a:stretch>
+        </p:blipFill>
+        <p:spPr>
+          <a:xfrm>
+            <a:off x="5216739" y="4573363"/>
+            <a:ext cx="1332727" cy="616954"/>
+          </a:xfrm>
+          <a:prstGeom prst="rect">
+            <a:avLst/>
+          </a:prstGeom>
+        </p:spPr>
+      </p:pic>
+      <p:pic>
+        <p:nvPicPr>
+          <p:cNvPr id="44" name="Picture 43">
+            <a:extLst>
+              <a:ext uri="{FF2B5EF4-FFF2-40B4-BE49-F238E27FC236}">
+                <a16:creationId xmlns:a16="http://schemas.microsoft.com/office/drawing/2014/main" id="{25C9EAB1-AB3C-2B24-9539-F1A63242AA80}"/>
+              </a:ext>
+            </a:extLst>
+          </p:cNvPr>
+          <p:cNvPicPr>
+            <a:picLocks noChangeAspect="1"/>
+          </p:cNvPicPr>
+          <p:nvPr/>
+        </p:nvPicPr>
+        <p:blipFill>
+          <a:blip r:embed="rId6"/>
+          <a:stretch>
+            <a:fillRect/>
+          </a:stretch>
+        </p:blipFill>
+        <p:spPr>
+          <a:xfrm>
+            <a:off x="5416289" y="4042001"/>
+            <a:ext cx="345194" cy="338555"/>
+          </a:xfrm>
+          <a:prstGeom prst="rect">
+            <a:avLst/>
+          </a:prstGeom>
+        </p:spPr>
+      </p:pic>
+      <p:cxnSp>
+        <p:nvCxnSpPr>
+          <p:cNvPr id="45" name="Straight Arrow Connector 44">
+            <a:extLst>
+              <a:ext uri="{FF2B5EF4-FFF2-40B4-BE49-F238E27FC236}">
+                <a16:creationId xmlns:a16="http://schemas.microsoft.com/office/drawing/2014/main" id="{CEB16D34-BBB3-CE21-53E5-E28A11ACA69D}"/>
+              </a:ext>
+            </a:extLst>
+          </p:cNvPr>
+          <p:cNvCxnSpPr>
+            <a:cxnSpLocks/>
+            <a:stCxn id="38" idx="2"/>
+            <a:endCxn id="44" idx="0"/>
+          </p:cNvCxnSpPr>
+          <p:nvPr/>
+        </p:nvCxnSpPr>
+        <p:spPr>
+          <a:xfrm>
+            <a:off x="5585158" y="3671904"/>
+            <a:ext cx="3728" cy="370097"/>
+          </a:xfrm>
+          <a:prstGeom prst="straightConnector1">
+            <a:avLst/>
+          </a:prstGeom>
+          <a:ln>
+            <a:tailEnd type="triangle"/>
+          </a:ln>
+        </p:spPr>
+        <p:style>
+          <a:lnRef idx="2">
+            <a:schemeClr val="accent1"/>
+          </a:lnRef>
+          <a:fillRef idx="0">
+            <a:schemeClr val="accent1"/>
+          </a:fillRef>
+          <a:effectRef idx="1">
+            <a:schemeClr val="accent1"/>
+          </a:effectRef>
+          <a:fontRef idx="minor">
+            <a:schemeClr val="tx1"/>
+          </a:fontRef>
+        </p:style>
+      </p:cxnSp>
+      <p:cxnSp>
+        <p:nvCxnSpPr>
+          <p:cNvPr id="49" name="Connector: Elbow 48">
+            <a:extLst>
+              <a:ext uri="{FF2B5EF4-FFF2-40B4-BE49-F238E27FC236}">
+                <a16:creationId xmlns:a16="http://schemas.microsoft.com/office/drawing/2014/main" id="{7DABAEDA-D314-47D4-5FEB-A2C01D74F7E1}"/>
+              </a:ext>
+            </a:extLst>
+          </p:cNvPr>
+          <p:cNvCxnSpPr>
+            <a:cxnSpLocks/>
+            <a:stCxn id="44" idx="3"/>
+            <a:endCxn id="43" idx="3"/>
+          </p:cNvCxnSpPr>
+          <p:nvPr/>
+        </p:nvCxnSpPr>
+        <p:spPr>
+          <a:xfrm>
+            <a:off x="5761483" y="4211279"/>
+            <a:ext cx="787983" cy="670561"/>
+          </a:xfrm>
+          <a:prstGeom prst="bentConnector3">
+            <a:avLst>
+              <a:gd name="adj1" fmla="val 129011"/>
+            </a:avLst>
+          </a:prstGeom>
+          <a:ln>
+            <a:tailEnd type="triangle"/>
+          </a:ln>
+        </p:spPr>
+        <p:style>
+          <a:lnRef idx="2">
+            <a:schemeClr val="accent1"/>
+          </a:lnRef>
+          <a:fillRef idx="0">
+            <a:schemeClr val="accent1"/>
+          </a:fillRef>
+          <a:effectRef idx="1">
+            <a:schemeClr val="accent1"/>
+          </a:effectRef>
+          <a:fontRef idx="minor">
+            <a:schemeClr val="tx1"/>
+          </a:fontRef>
+        </p:style>
+      </p:cxnSp>
+      <p:sp>
+        <p:nvSpPr>
+          <p:cNvPr id="54" name="TextBox 53">
+            <a:extLst>
+              <a:ext uri="{FF2B5EF4-FFF2-40B4-BE49-F238E27FC236}">
+                <a16:creationId xmlns:a16="http://schemas.microsoft.com/office/drawing/2014/main" id="{5D313020-4215-7ED2-7872-5B02038C46E8}"/>
+              </a:ext>
+            </a:extLst>
+          </p:cNvPr>
+          <p:cNvSpPr txBox="1"/>
+          <p:nvPr/>
+        </p:nvSpPr>
+        <p:spPr>
+          <a:xfrm>
+            <a:off x="5741782" y="4188567"/>
+            <a:ext cx="1377473" cy="430887"/>
+          </a:xfrm>
+          <a:prstGeom prst="rect">
+            <a:avLst/>
+          </a:prstGeom>
+          <a:noFill/>
+        </p:spPr>
+        <p:txBody>
+          <a:bodyPr wrap="square">
+            <a:spAutoFit/>
+          </a:bodyPr>
+          <a:lstStyle/>
+          <a:p>
+            <a:r>
+              <a:rPr lang="en-SG" sz="1100" b="1" dirty="0"/>
+              <a:t>Forward port 11434 to localhost </a:t>
+            </a:r>
+          </a:p>
+        </p:txBody>
+      </p:sp>
+      <p:sp>
+        <p:nvSpPr>
+          <p:cNvPr id="55" name="TextBox 54">
+            <a:extLst>
+              <a:ext uri="{FF2B5EF4-FFF2-40B4-BE49-F238E27FC236}">
+                <a16:creationId xmlns:a16="http://schemas.microsoft.com/office/drawing/2014/main" id="{0EE05B9A-804A-1297-9EC5-BE84FB77DA55}"/>
+              </a:ext>
+            </a:extLst>
+          </p:cNvPr>
+          <p:cNvSpPr txBox="1"/>
+          <p:nvPr/>
+        </p:nvSpPr>
+        <p:spPr>
+          <a:xfrm>
+            <a:off x="5139891" y="5174845"/>
+            <a:ext cx="1601444" cy="307777"/>
+          </a:xfrm>
+          <a:prstGeom prst="rect">
+            <a:avLst/>
+          </a:prstGeom>
+          <a:noFill/>
+        </p:spPr>
+        <p:txBody>
+          <a:bodyPr wrap="square">
+            <a:spAutoFit/>
+          </a:bodyPr>
+          <a:lstStyle/>
+          <a:p>
+            <a:r>
+              <a:rPr lang="en-SG" sz="1400" b="1" dirty="0" err="1"/>
+              <a:t>OpenClaw</a:t>
+            </a:r>
+            <a:r>
+              <a:rPr lang="en-SG" sz="1400" b="1" dirty="0"/>
+              <a:t> Agent</a:t>
+            </a:r>
+          </a:p>
+        </p:txBody>
+      </p:sp>
+      <p:sp>
+        <p:nvSpPr>
+          <p:cNvPr id="58" name="Rectangle 57">
+            <a:extLst>
+              <a:ext uri="{FF2B5EF4-FFF2-40B4-BE49-F238E27FC236}">
+                <a16:creationId xmlns:a16="http://schemas.microsoft.com/office/drawing/2014/main" id="{19BED5D3-76CC-88C6-5C12-1EEA7A196C44}"/>
+              </a:ext>
+            </a:extLst>
+          </p:cNvPr>
+          <p:cNvSpPr/>
+          <p:nvPr/>
+        </p:nvSpPr>
+        <p:spPr>
+          <a:xfrm>
+            <a:off x="7053085" y="2920673"/>
+            <a:ext cx="1193778" cy="746531"/>
+          </a:xfrm>
+          <a:prstGeom prst="rect">
+            <a:avLst/>
+          </a:prstGeom>
+          <a:solidFill>
+            <a:schemeClr val="bg1"/>
+          </a:solidFill>
+        </p:spPr>
+        <p:style>
+          <a:lnRef idx="2">
+            <a:schemeClr val="accent1">
+              <a:shade val="15000"/>
+            </a:schemeClr>
+          </a:lnRef>
+          <a:fillRef idx="1">
+            <a:schemeClr val="accent1"/>
+          </a:fillRef>
+          <a:effectRef idx="0">
+            <a:schemeClr val="accent1"/>
+          </a:effectRef>
+          <a:fontRef idx="minor">
+            <a:schemeClr val="lt1"/>
+          </a:fontRef>
+        </p:style>
+        <p:txBody>
+          <a:bodyPr rtlCol="0" anchor="ctr"/>
+          <a:lstStyle/>
+          <a:p>
+            <a:pPr algn="ctr"/>
+            <a:endParaRPr lang="en-SG"/>
+          </a:p>
+        </p:txBody>
+      </p:sp>
+      <p:pic>
+        <p:nvPicPr>
+          <p:cNvPr id="59" name="Picture 58">
+            <a:extLst>
+              <a:ext uri="{FF2B5EF4-FFF2-40B4-BE49-F238E27FC236}">
+                <a16:creationId xmlns:a16="http://schemas.microsoft.com/office/drawing/2014/main" id="{2C49C16D-616E-CAC9-ECD2-1A1E826E9400}"/>
+              </a:ext>
+            </a:extLst>
+          </p:cNvPr>
+          <p:cNvPicPr>
+            <a:picLocks noChangeAspect="1"/>
+          </p:cNvPicPr>
+          <p:nvPr/>
+        </p:nvPicPr>
+        <p:blipFill>
+          <a:blip r:embed="rId6"/>
+          <a:stretch>
+            <a:fillRect/>
+          </a:stretch>
+        </p:blipFill>
+        <p:spPr>
+          <a:xfrm>
+            <a:off x="6858186" y="3085376"/>
+            <a:ext cx="368410" cy="361325"/>
+          </a:xfrm>
+          <a:prstGeom prst="rect">
+            <a:avLst/>
+          </a:prstGeom>
+        </p:spPr>
+      </p:pic>
+      <p:pic>
+        <p:nvPicPr>
+          <p:cNvPr id="60" name="Picture 59">
+            <a:extLst>
+              <a:ext uri="{FF2B5EF4-FFF2-40B4-BE49-F238E27FC236}">
+                <a16:creationId xmlns:a16="http://schemas.microsoft.com/office/drawing/2014/main" id="{62560C64-BACF-F01F-6BDD-878A8EDAE270}"/>
+              </a:ext>
+            </a:extLst>
+          </p:cNvPr>
+          <p:cNvPicPr>
+            <a:picLocks noChangeAspect="1"/>
+          </p:cNvPicPr>
+          <p:nvPr/>
+        </p:nvPicPr>
+        <p:blipFill>
+          <a:blip r:embed="rId6"/>
+          <a:stretch>
+            <a:fillRect/>
+          </a:stretch>
+        </p:blipFill>
+        <p:spPr>
+          <a:xfrm>
+            <a:off x="8090626" y="3074097"/>
+            <a:ext cx="368410" cy="361325"/>
+          </a:xfrm>
+          <a:prstGeom prst="rect">
+            <a:avLst/>
+          </a:prstGeom>
+        </p:spPr>
+      </p:pic>
+      <p:cxnSp>
+        <p:nvCxnSpPr>
+          <p:cNvPr id="61" name="Straight Connector 60">
+            <a:extLst>
+              <a:ext uri="{FF2B5EF4-FFF2-40B4-BE49-F238E27FC236}">
+                <a16:creationId xmlns:a16="http://schemas.microsoft.com/office/drawing/2014/main" id="{A28D9777-571A-B8F9-168C-C12E0D6FD04E}"/>
+              </a:ext>
+            </a:extLst>
+          </p:cNvPr>
+          <p:cNvCxnSpPr>
+            <a:cxnSpLocks/>
+            <a:stCxn id="38" idx="3"/>
+            <a:endCxn id="59" idx="1"/>
+          </p:cNvCxnSpPr>
+          <p:nvPr/>
+        </p:nvCxnSpPr>
+        <p:spPr>
+          <a:xfrm flipV="1">
+            <a:off x="6030424" y="3266039"/>
+            <a:ext cx="827762" cy="0"/>
+          </a:xfrm>
+          <a:prstGeom prst="line">
+            <a:avLst/>
+          </a:prstGeom>
+        </p:spPr>
+        <p:style>
+          <a:lnRef idx="2">
+            <a:schemeClr val="accent1"/>
+          </a:lnRef>
+          <a:fillRef idx="0">
+            <a:schemeClr val="accent1"/>
+          </a:fillRef>
+          <a:effectRef idx="1">
+            <a:schemeClr val="accent1"/>
+          </a:effectRef>
+          <a:fontRef idx="minor">
+            <a:schemeClr val="tx1"/>
+          </a:fontRef>
+        </p:style>
+      </p:cxnSp>
+      <p:sp>
+        <p:nvSpPr>
+          <p:cNvPr id="64" name="TextBox 63">
+            <a:extLst>
+              <a:ext uri="{FF2B5EF4-FFF2-40B4-BE49-F238E27FC236}">
+                <a16:creationId xmlns:a16="http://schemas.microsoft.com/office/drawing/2014/main" id="{D47FD01B-0509-9391-5002-884B37719B37}"/>
+              </a:ext>
+            </a:extLst>
+          </p:cNvPr>
+          <p:cNvSpPr txBox="1"/>
+          <p:nvPr/>
+        </p:nvSpPr>
+        <p:spPr>
+          <a:xfrm>
+            <a:off x="7100279" y="2216746"/>
+            <a:ext cx="1145929" cy="738664"/>
+          </a:xfrm>
+          <a:prstGeom prst="rect">
+            <a:avLst/>
+          </a:prstGeom>
+          <a:noFill/>
+        </p:spPr>
+        <p:txBody>
+          <a:bodyPr wrap="square">
+            <a:spAutoFit/>
+          </a:bodyPr>
+          <a:lstStyle/>
+          <a:p>
+            <a:r>
+              <a:rPr lang="en-SG" sz="1400" b="1" dirty="0"/>
+              <a:t>Gateway or Jump host or firewall</a:t>
+            </a:r>
+          </a:p>
+        </p:txBody>
+      </p:sp>
+      <p:pic>
+        <p:nvPicPr>
+          <p:cNvPr id="68" name="Graphic 67" descr="Server with solid fill">
+            <a:extLst>
+              <a:ext uri="{FF2B5EF4-FFF2-40B4-BE49-F238E27FC236}">
+                <a16:creationId xmlns:a16="http://schemas.microsoft.com/office/drawing/2014/main" id="{A0DFEF42-E886-B898-8696-076B0A08D496}"/>
+              </a:ext>
+            </a:extLst>
+          </p:cNvPr>
+          <p:cNvPicPr>
+            <a:picLocks noChangeAspect="1"/>
+          </p:cNvPicPr>
+          <p:nvPr/>
+        </p:nvPicPr>
+        <p:blipFill>
+          <a:blip r:embed="rId10">
+            <a:extLst>
+              <a:ext uri="{96DAC541-7B7A-43D3-8B79-37D633B846F1}">
+                <asvg:svgBlip xmlns:asvg="http://schemas.microsoft.com/office/drawing/2016/SVG/main" r:embed="rId11"/>
+              </a:ext>
+            </a:extLst>
+          </a:blip>
+          <a:stretch>
+            <a:fillRect/>
+          </a:stretch>
+        </p:blipFill>
+        <p:spPr>
+          <a:xfrm>
+            <a:off x="7357629" y="3044790"/>
+            <a:ext cx="538098" cy="538098"/>
+          </a:xfrm>
+          <a:prstGeom prst="rect">
+            <a:avLst/>
+          </a:prstGeom>
+        </p:spPr>
+      </p:pic>
+      <p:pic>
+        <p:nvPicPr>
+          <p:cNvPr id="70" name="Graphic 69" descr="Laptop with solid fill">
+            <a:extLst>
+              <a:ext uri="{FF2B5EF4-FFF2-40B4-BE49-F238E27FC236}">
+                <a16:creationId xmlns:a16="http://schemas.microsoft.com/office/drawing/2014/main" id="{FEFE2EB1-D7EE-45CF-C805-72D3B833B8B6}"/>
+              </a:ext>
+            </a:extLst>
+          </p:cNvPr>
+          <p:cNvPicPr>
+            <a:picLocks noChangeAspect="1"/>
+          </p:cNvPicPr>
+          <p:nvPr/>
+        </p:nvPicPr>
+        <p:blipFill>
+          <a:blip r:embed="rId12">
+            <a:extLst>
+              <a:ext uri="{96DAC541-7B7A-43D3-8B79-37D633B846F1}">
+                <asvg:svgBlip xmlns:asvg="http://schemas.microsoft.com/office/drawing/2016/SVG/main" r:embed="rId13"/>
+              </a:ext>
+            </a:extLst>
+          </a:blip>
+          <a:stretch>
+            <a:fillRect/>
+          </a:stretch>
+        </p:blipFill>
+        <p:spPr>
+          <a:xfrm>
+            <a:off x="5416289" y="1338166"/>
+            <a:ext cx="1435131" cy="1435131"/>
+          </a:xfrm>
+          <a:prstGeom prst="rect">
+            <a:avLst/>
+          </a:prstGeom>
+        </p:spPr>
+      </p:pic>
+      <p:pic>
+        <p:nvPicPr>
+          <p:cNvPr id="71" name="Picture 70">
+            <a:extLst>
+              <a:ext uri="{FF2B5EF4-FFF2-40B4-BE49-F238E27FC236}">
+                <a16:creationId xmlns:a16="http://schemas.microsoft.com/office/drawing/2014/main" id="{57899095-44F4-3786-80D4-B9A00B256295}"/>
+              </a:ext>
+            </a:extLst>
+          </p:cNvPr>
+          <p:cNvPicPr>
+            <a:picLocks noChangeAspect="1"/>
+          </p:cNvPicPr>
+          <p:nvPr/>
+        </p:nvPicPr>
+        <p:blipFill>
+          <a:blip r:embed="rId9"/>
+          <a:stretch>
+            <a:fillRect/>
+          </a:stretch>
+        </p:blipFill>
+        <p:spPr>
+          <a:xfrm>
+            <a:off x="5757755" y="1831429"/>
+            <a:ext cx="734007" cy="339791"/>
+          </a:xfrm>
+          <a:prstGeom prst="rect">
+            <a:avLst/>
+          </a:prstGeom>
+        </p:spPr>
+      </p:pic>
+      <p:sp>
+        <p:nvSpPr>
+          <p:cNvPr id="72" name="TextBox 71">
+            <a:extLst>
+              <a:ext uri="{FF2B5EF4-FFF2-40B4-BE49-F238E27FC236}">
+                <a16:creationId xmlns:a16="http://schemas.microsoft.com/office/drawing/2014/main" id="{E05237BE-E778-FE13-80EB-5808D39A16FA}"/>
+              </a:ext>
+            </a:extLst>
+          </p:cNvPr>
+          <p:cNvSpPr txBox="1"/>
+          <p:nvPr/>
+        </p:nvSpPr>
+        <p:spPr>
+          <a:xfrm>
+            <a:off x="5139891" y="1215952"/>
+            <a:ext cx="2378797" cy="461665"/>
+          </a:xfrm>
+          <a:prstGeom prst="rect">
+            <a:avLst/>
+          </a:prstGeom>
+          <a:noFill/>
+        </p:spPr>
+        <p:txBody>
+          <a:bodyPr wrap="square">
+            <a:spAutoFit/>
+          </a:bodyPr>
+          <a:lstStyle/>
+          <a:p>
+            <a:r>
+              <a:rPr lang="en-SG" sz="1200" b="1" dirty="0"/>
+              <a:t>Internal Network User’s working Laptop with </a:t>
+            </a:r>
+            <a:r>
+              <a:rPr lang="en-SG" sz="1200" b="1" dirty="0" err="1"/>
+              <a:t>OpenClaw</a:t>
+            </a:r>
+            <a:r>
+              <a:rPr lang="en-SG" sz="1200" b="1" dirty="0"/>
+              <a:t> </a:t>
+            </a:r>
+          </a:p>
+        </p:txBody>
+      </p:sp>
+      <p:pic>
+        <p:nvPicPr>
+          <p:cNvPr id="74" name="Graphic 73" descr="Wi-Fi with solid fill">
+            <a:extLst>
+              <a:ext uri="{FF2B5EF4-FFF2-40B4-BE49-F238E27FC236}">
+                <a16:creationId xmlns:a16="http://schemas.microsoft.com/office/drawing/2014/main" id="{FB810B55-3861-422A-904D-721440ABE735}"/>
+              </a:ext>
+            </a:extLst>
+          </p:cNvPr>
+          <p:cNvPicPr>
+            <a:picLocks noChangeAspect="1"/>
+          </p:cNvPicPr>
+          <p:nvPr/>
+        </p:nvPicPr>
+        <p:blipFill>
+          <a:blip r:embed="rId14">
+            <a:extLst>
+              <a:ext uri="{96DAC541-7B7A-43D3-8B79-37D633B846F1}">
+                <asvg:svgBlip xmlns:asvg="http://schemas.microsoft.com/office/drawing/2016/SVG/main" r:embed="rId15"/>
+              </a:ext>
+            </a:extLst>
+          </a:blip>
+          <a:stretch>
+            <a:fillRect/>
+          </a:stretch>
+        </p:blipFill>
+        <p:spPr>
+          <a:xfrm>
+            <a:off x="6263627" y="2402249"/>
+            <a:ext cx="457200" cy="457200"/>
+          </a:xfrm>
+          <a:prstGeom prst="rect">
+            <a:avLst/>
+          </a:prstGeom>
+        </p:spPr>
+      </p:pic>
+      <p:cxnSp>
+        <p:nvCxnSpPr>
+          <p:cNvPr id="76" name="Connector: Elbow 75">
+            <a:extLst>
+              <a:ext uri="{FF2B5EF4-FFF2-40B4-BE49-F238E27FC236}">
+                <a16:creationId xmlns:a16="http://schemas.microsoft.com/office/drawing/2014/main" id="{08F9F792-B149-3B90-4DF7-286406BFFD12}"/>
+              </a:ext>
+            </a:extLst>
+          </p:cNvPr>
+          <p:cNvCxnSpPr>
+            <a:cxnSpLocks/>
+            <a:endCxn id="74" idx="2"/>
+          </p:cNvCxnSpPr>
+          <p:nvPr/>
+        </p:nvCxnSpPr>
+        <p:spPr>
+          <a:xfrm flipV="1">
+            <a:off x="6051454" y="2859449"/>
+            <a:ext cx="440773" cy="203357"/>
+          </a:xfrm>
+          <a:prstGeom prst="bentConnector2">
+            <a:avLst/>
+          </a:prstGeom>
+        </p:spPr>
+        <p:style>
+          <a:lnRef idx="2">
+            <a:schemeClr val="accent1"/>
+          </a:lnRef>
+          <a:fillRef idx="0">
+            <a:schemeClr val="accent1"/>
+          </a:fillRef>
+          <a:effectRef idx="1">
+            <a:schemeClr val="accent1"/>
+          </a:effectRef>
+          <a:fontRef idx="minor">
+            <a:schemeClr val="tx1"/>
+          </a:fontRef>
+        </p:style>
+      </p:cxnSp>
+      <p:pic>
+        <p:nvPicPr>
+          <p:cNvPr id="84" name="Graphic 83" descr="Server with solid fill">
+            <a:extLst>
+              <a:ext uri="{FF2B5EF4-FFF2-40B4-BE49-F238E27FC236}">
+                <a16:creationId xmlns:a16="http://schemas.microsoft.com/office/drawing/2014/main" id="{BC9F50DA-7C05-73C2-35CB-928A2C33EB45}"/>
+              </a:ext>
+            </a:extLst>
+          </p:cNvPr>
+          <p:cNvPicPr>
+            <a:picLocks noChangeAspect="1"/>
+          </p:cNvPicPr>
+          <p:nvPr/>
+        </p:nvPicPr>
+        <p:blipFill>
+          <a:blip r:embed="rId16">
+            <a:extLst>
+              <a:ext uri="{96DAC541-7B7A-43D3-8B79-37D633B846F1}">
+                <asvg:svgBlip xmlns:asvg="http://schemas.microsoft.com/office/drawing/2016/SVG/main" r:embed="rId17"/>
+              </a:ext>
+            </a:extLst>
+          </a:blip>
+          <a:stretch>
+            <a:fillRect/>
+          </a:stretch>
+        </p:blipFill>
+        <p:spPr>
+          <a:xfrm>
+            <a:off x="6529174" y="4891206"/>
+            <a:ext cx="538098" cy="538098"/>
+          </a:xfrm>
+          <a:prstGeom prst="rect">
+            <a:avLst/>
+          </a:prstGeom>
+        </p:spPr>
+      </p:pic>
+      <p:sp>
+        <p:nvSpPr>
+          <p:cNvPr id="87" name="Cloud 86">
+            <a:extLst>
+              <a:ext uri="{FF2B5EF4-FFF2-40B4-BE49-F238E27FC236}">
+                <a16:creationId xmlns:a16="http://schemas.microsoft.com/office/drawing/2014/main" id="{855CAE7E-AB7C-3A47-1F13-0F8EFA5E71B7}"/>
+              </a:ext>
+            </a:extLst>
+          </p:cNvPr>
+          <p:cNvSpPr/>
+          <p:nvPr/>
+        </p:nvSpPr>
+        <p:spPr>
+          <a:xfrm>
+            <a:off x="8744554" y="2798545"/>
+            <a:ext cx="1414914" cy="912428"/>
+          </a:xfrm>
+          <a:prstGeom prst="cloud">
+            <a:avLst/>
+          </a:prstGeom>
+        </p:spPr>
+        <p:style>
+          <a:lnRef idx="2">
+            <a:schemeClr val="accent1">
+              <a:shade val="15000"/>
+            </a:schemeClr>
+          </a:lnRef>
+          <a:fillRef idx="1">
+            <a:schemeClr val="accent1"/>
+          </a:fillRef>
+          <a:effectRef idx="0">
+            <a:schemeClr val="accent1"/>
+          </a:effectRef>
+          <a:fontRef idx="minor">
+            <a:schemeClr val="lt1"/>
+          </a:fontRef>
+        </p:style>
+        <p:txBody>
+          <a:bodyPr rtlCol="0" anchor="ctr"/>
+          <a:lstStyle/>
+          <a:p>
+            <a:pPr algn="ctr"/>
+            <a:r>
+              <a:rPr lang="en-SG" sz="1600" b="1" dirty="0"/>
+              <a:t>Internet</a:t>
+            </a:r>
+          </a:p>
+        </p:txBody>
+      </p:sp>
+      <p:cxnSp>
+        <p:nvCxnSpPr>
+          <p:cNvPr id="88" name="Straight Connector 87">
+            <a:extLst>
+              <a:ext uri="{FF2B5EF4-FFF2-40B4-BE49-F238E27FC236}">
+                <a16:creationId xmlns:a16="http://schemas.microsoft.com/office/drawing/2014/main" id="{81900574-9911-9F6D-BBCE-277436D8769B}"/>
+              </a:ext>
+            </a:extLst>
+          </p:cNvPr>
+          <p:cNvCxnSpPr>
+            <a:cxnSpLocks/>
+            <a:stCxn id="60" idx="3"/>
+            <a:endCxn id="87" idx="2"/>
+          </p:cNvCxnSpPr>
+          <p:nvPr/>
+        </p:nvCxnSpPr>
+        <p:spPr>
+          <a:xfrm flipV="1">
+            <a:off x="8459036" y="3254759"/>
+            <a:ext cx="289907" cy="1"/>
+          </a:xfrm>
+          <a:prstGeom prst="line">
+            <a:avLst/>
+          </a:prstGeom>
+        </p:spPr>
+        <p:style>
+          <a:lnRef idx="2">
+            <a:schemeClr val="accent1"/>
+          </a:lnRef>
+          <a:fillRef idx="0">
+            <a:schemeClr val="accent1"/>
+          </a:fillRef>
+          <a:effectRef idx="1">
+            <a:schemeClr val="accent1"/>
+          </a:effectRef>
+          <a:fontRef idx="minor">
+            <a:schemeClr val="tx1"/>
+          </a:fontRef>
+        </p:style>
+      </p:cxnSp>
+      <p:pic>
+        <p:nvPicPr>
+          <p:cNvPr id="94" name="Graphic 93" descr="Laptop with solid fill">
+            <a:extLst>
+              <a:ext uri="{FF2B5EF4-FFF2-40B4-BE49-F238E27FC236}">
+                <a16:creationId xmlns:a16="http://schemas.microsoft.com/office/drawing/2014/main" id="{D659782B-86A5-A82B-0A81-9781D32AE134}"/>
+              </a:ext>
+            </a:extLst>
+          </p:cNvPr>
+          <p:cNvPicPr>
+            <a:picLocks noChangeAspect="1"/>
+          </p:cNvPicPr>
+          <p:nvPr/>
+        </p:nvPicPr>
+        <p:blipFill>
+          <a:blip r:embed="rId12">
+            <a:extLst>
+              <a:ext uri="{96DAC541-7B7A-43D3-8B79-37D633B846F1}">
+                <asvg:svgBlip xmlns:asvg="http://schemas.microsoft.com/office/drawing/2016/SVG/main" r:embed="rId13"/>
+              </a:ext>
+            </a:extLst>
+          </a:blip>
+          <a:stretch>
+            <a:fillRect/>
+          </a:stretch>
+        </p:blipFill>
+        <p:spPr>
+          <a:xfrm>
+            <a:off x="8971762" y="1069439"/>
+            <a:ext cx="1435131" cy="1435131"/>
+          </a:xfrm>
+          <a:prstGeom prst="rect">
+            <a:avLst/>
+          </a:prstGeom>
+        </p:spPr>
+      </p:pic>
+      <p:pic>
+        <p:nvPicPr>
+          <p:cNvPr id="95" name="Picture 94">
+            <a:extLst>
+              <a:ext uri="{FF2B5EF4-FFF2-40B4-BE49-F238E27FC236}">
+                <a16:creationId xmlns:a16="http://schemas.microsoft.com/office/drawing/2014/main" id="{2DBD923A-75A4-2AEC-2BBB-5141900FFCDC}"/>
+              </a:ext>
+            </a:extLst>
+          </p:cNvPr>
+          <p:cNvPicPr>
+            <a:picLocks noChangeAspect="1"/>
+          </p:cNvPicPr>
+          <p:nvPr/>
+        </p:nvPicPr>
+        <p:blipFill>
+          <a:blip r:embed="rId9"/>
+          <a:stretch>
+            <a:fillRect/>
+          </a:stretch>
+        </p:blipFill>
+        <p:spPr>
+          <a:xfrm>
+            <a:off x="9313228" y="1562702"/>
+            <a:ext cx="734007" cy="339791"/>
+          </a:xfrm>
+          <a:prstGeom prst="rect">
+            <a:avLst/>
+          </a:prstGeom>
+        </p:spPr>
+      </p:pic>
+      <p:sp>
+        <p:nvSpPr>
+          <p:cNvPr id="96" name="TextBox 95">
+            <a:extLst>
+              <a:ext uri="{FF2B5EF4-FFF2-40B4-BE49-F238E27FC236}">
+                <a16:creationId xmlns:a16="http://schemas.microsoft.com/office/drawing/2014/main" id="{B3EA3182-6855-87D8-0726-25F2811B36A5}"/>
+              </a:ext>
+            </a:extLst>
+          </p:cNvPr>
+          <p:cNvSpPr txBox="1"/>
+          <p:nvPr/>
+        </p:nvSpPr>
+        <p:spPr>
+          <a:xfrm>
+            <a:off x="8329000" y="869255"/>
+            <a:ext cx="2378797" cy="461665"/>
+          </a:xfrm>
+          <a:prstGeom prst="rect">
+            <a:avLst/>
+          </a:prstGeom>
+          <a:noFill/>
+        </p:spPr>
+        <p:txBody>
+          <a:bodyPr wrap="square">
+            <a:spAutoFit/>
+          </a:bodyPr>
+          <a:lstStyle/>
+          <a:p>
+            <a:r>
+              <a:rPr lang="en-SG" sz="1200" b="1" dirty="0"/>
+              <a:t>External Network User’s working Laptop with </a:t>
+            </a:r>
+            <a:r>
+              <a:rPr lang="en-SG" sz="1200" b="1" dirty="0" err="1"/>
+              <a:t>OpenClaw</a:t>
+            </a:r>
+            <a:r>
+              <a:rPr lang="en-SG" sz="1200" b="1" dirty="0"/>
+              <a:t> </a:t>
+            </a:r>
+          </a:p>
+        </p:txBody>
+      </p:sp>
+      <p:cxnSp>
+        <p:nvCxnSpPr>
+          <p:cNvPr id="97" name="Connector: Elbow 96">
+            <a:extLst>
+              <a:ext uri="{FF2B5EF4-FFF2-40B4-BE49-F238E27FC236}">
+                <a16:creationId xmlns:a16="http://schemas.microsoft.com/office/drawing/2014/main" id="{D4251948-BE9B-5F99-70FA-F94DD2040A76}"/>
+              </a:ext>
+            </a:extLst>
+          </p:cNvPr>
+          <p:cNvCxnSpPr>
+            <a:cxnSpLocks/>
+            <a:stCxn id="87" idx="3"/>
+          </p:cNvCxnSpPr>
+          <p:nvPr/>
+        </p:nvCxnSpPr>
+        <p:spPr>
+          <a:xfrm rot="5400000" flipH="1" flipV="1">
+            <a:off x="9240893" y="2402280"/>
+            <a:ext cx="659552" cy="237316"/>
+          </a:xfrm>
+          <a:prstGeom prst="bentConnector3">
+            <a:avLst>
+              <a:gd name="adj1" fmla="val 50000"/>
+            </a:avLst>
+          </a:prstGeom>
+        </p:spPr>
+        <p:style>
+          <a:lnRef idx="2">
+            <a:schemeClr val="accent1"/>
+          </a:lnRef>
+          <a:fillRef idx="0">
+            <a:schemeClr val="accent1"/>
+          </a:fillRef>
+          <a:effectRef idx="1">
+            <a:schemeClr val="accent1"/>
+          </a:effectRef>
+          <a:fontRef idx="minor">
+            <a:schemeClr val="tx1"/>
+          </a:fontRef>
+        </p:style>
+      </p:cxnSp>
+      <p:pic>
+        <p:nvPicPr>
+          <p:cNvPr id="100" name="Picture 99">
+            <a:extLst>
+              <a:ext uri="{FF2B5EF4-FFF2-40B4-BE49-F238E27FC236}">
+                <a16:creationId xmlns:a16="http://schemas.microsoft.com/office/drawing/2014/main" id="{81888F5F-EC8F-C0F0-383D-55E6B2D5D541}"/>
+              </a:ext>
+            </a:extLst>
+          </p:cNvPr>
+          <p:cNvPicPr>
+            <a:picLocks noChangeAspect="1"/>
+          </p:cNvPicPr>
+          <p:nvPr/>
+        </p:nvPicPr>
+        <p:blipFill>
+          <a:blip r:embed="rId18"/>
+          <a:stretch>
+            <a:fillRect/>
+          </a:stretch>
+        </p:blipFill>
+        <p:spPr>
+          <a:xfrm>
+            <a:off x="9139229" y="4333484"/>
+            <a:ext cx="538869" cy="737558"/>
+          </a:xfrm>
+          <a:prstGeom prst="rect">
+            <a:avLst/>
+          </a:prstGeom>
+        </p:spPr>
+      </p:pic>
+      <p:pic>
+        <p:nvPicPr>
+          <p:cNvPr id="101" name="Graphic 100" descr="User with solid fill">
+            <a:extLst>
+              <a:ext uri="{FF2B5EF4-FFF2-40B4-BE49-F238E27FC236}">
+                <a16:creationId xmlns:a16="http://schemas.microsoft.com/office/drawing/2014/main" id="{AA16C974-93B7-8D4B-E347-5DD831E79D1F}"/>
+              </a:ext>
+            </a:extLst>
+          </p:cNvPr>
+          <p:cNvPicPr>
+            <a:picLocks noChangeAspect="1"/>
+          </p:cNvPicPr>
+          <p:nvPr/>
+        </p:nvPicPr>
+        <p:blipFill>
+          <a:blip r:embed="rId19">
+            <a:extLst>
+              <a:ext uri="{96DAC541-7B7A-43D3-8B79-37D633B846F1}">
+                <asvg:svgBlip xmlns:asvg="http://schemas.microsoft.com/office/drawing/2016/SVG/main" r:embed="rId20"/>
+              </a:ext>
+            </a:extLst>
+          </a:blip>
+          <a:stretch>
+            <a:fillRect/>
+          </a:stretch>
+        </p:blipFill>
+        <p:spPr>
+          <a:xfrm>
+            <a:off x="9817676" y="4389894"/>
+            <a:ext cx="683583" cy="683583"/>
+          </a:xfrm>
+          <a:prstGeom prst="rect">
+            <a:avLst/>
+          </a:prstGeom>
+        </p:spPr>
+      </p:pic>
+      <p:sp>
+        <p:nvSpPr>
+          <p:cNvPr id="102" name="TextBox 101">
+            <a:extLst>
+              <a:ext uri="{FF2B5EF4-FFF2-40B4-BE49-F238E27FC236}">
+                <a16:creationId xmlns:a16="http://schemas.microsoft.com/office/drawing/2014/main" id="{BBEBDEDB-86AA-739B-D8E7-2344C4669921}"/>
+              </a:ext>
+            </a:extLst>
+          </p:cNvPr>
+          <p:cNvSpPr txBox="1"/>
+          <p:nvPr/>
+        </p:nvSpPr>
+        <p:spPr>
+          <a:xfrm>
+            <a:off x="7848066" y="3657106"/>
+            <a:ext cx="821646" cy="307777"/>
+          </a:xfrm>
+          <a:prstGeom prst="rect">
+            <a:avLst/>
+          </a:prstGeom>
+          <a:noFill/>
+        </p:spPr>
+        <p:txBody>
+          <a:bodyPr wrap="square">
+            <a:spAutoFit/>
+          </a:bodyPr>
+          <a:lstStyle/>
+          <a:p>
+            <a:r>
+              <a:rPr lang="en-US" sz="1400" b="1" dirty="0">
+                <a:solidFill>
+                  <a:schemeClr val="accent1"/>
+                </a:solidFill>
+              </a:rPr>
+              <a:t>Port:22</a:t>
+            </a:r>
+            <a:endParaRPr lang="en-SG" sz="1400" b="1" dirty="0">
+              <a:solidFill>
+                <a:schemeClr val="accent1"/>
+              </a:solidFill>
+            </a:endParaRPr>
+          </a:p>
+        </p:txBody>
+      </p:sp>
+      <p:cxnSp>
+        <p:nvCxnSpPr>
+          <p:cNvPr id="103" name="Straight Connector 102">
+            <a:extLst>
+              <a:ext uri="{FF2B5EF4-FFF2-40B4-BE49-F238E27FC236}">
+                <a16:creationId xmlns:a16="http://schemas.microsoft.com/office/drawing/2014/main" id="{C84ACAA2-2EA3-CF94-3CE0-965C1A68867A}"/>
+              </a:ext>
+            </a:extLst>
+          </p:cNvPr>
+          <p:cNvCxnSpPr>
+            <a:cxnSpLocks/>
+            <a:endCxn id="100" idx="0"/>
+          </p:cNvCxnSpPr>
+          <p:nvPr/>
+        </p:nvCxnSpPr>
+        <p:spPr>
+          <a:xfrm>
+            <a:off x="9408663" y="3708112"/>
+            <a:ext cx="1" cy="625372"/>
+          </a:xfrm>
+          <a:prstGeom prst="line">
+            <a:avLst/>
+          </a:prstGeom>
+        </p:spPr>
+        <p:style>
+          <a:lnRef idx="2">
+            <a:schemeClr val="accent1"/>
+          </a:lnRef>
+          <a:fillRef idx="0">
+            <a:schemeClr val="accent1"/>
+          </a:fillRef>
+          <a:effectRef idx="1">
+            <a:schemeClr val="accent1"/>
+          </a:effectRef>
+          <a:fontRef idx="minor">
+            <a:schemeClr val="tx1"/>
+          </a:fontRef>
+        </p:style>
+      </p:cxnSp>
+      <p:sp>
+        <p:nvSpPr>
+          <p:cNvPr id="106" name="TextBox 105">
+            <a:extLst>
+              <a:ext uri="{FF2B5EF4-FFF2-40B4-BE49-F238E27FC236}">
+                <a16:creationId xmlns:a16="http://schemas.microsoft.com/office/drawing/2014/main" id="{A3908EFB-A976-81D4-C564-5ED255809C75}"/>
+              </a:ext>
+            </a:extLst>
+          </p:cNvPr>
+          <p:cNvSpPr txBox="1"/>
+          <p:nvPr/>
+        </p:nvSpPr>
+        <p:spPr>
+          <a:xfrm>
+            <a:off x="8476127" y="5101879"/>
+            <a:ext cx="2477422" cy="461665"/>
+          </a:xfrm>
+          <a:prstGeom prst="rect">
+            <a:avLst/>
+          </a:prstGeom>
+          <a:noFill/>
+        </p:spPr>
+        <p:txBody>
+          <a:bodyPr wrap="square">
+            <a:spAutoFit/>
+          </a:bodyPr>
+          <a:lstStyle/>
+          <a:p>
+            <a:r>
+              <a:rPr lang="en-SG" sz="1200" b="1" dirty="0"/>
+              <a:t>User’s Mobile App such as WhatsApp, Telegram, WeChat</a:t>
+            </a:r>
+          </a:p>
+        </p:txBody>
+      </p:sp>
+      <p:sp>
+        <p:nvSpPr>
+          <p:cNvPr id="107" name="TextBox 106">
+            <a:extLst>
+              <a:ext uri="{FF2B5EF4-FFF2-40B4-BE49-F238E27FC236}">
+                <a16:creationId xmlns:a16="http://schemas.microsoft.com/office/drawing/2014/main" id="{CCBFB7DD-0E37-50BA-7F4F-303FBB7EC71D}"/>
+              </a:ext>
+            </a:extLst>
+          </p:cNvPr>
+          <p:cNvSpPr txBox="1"/>
+          <p:nvPr/>
+        </p:nvSpPr>
+        <p:spPr>
+          <a:xfrm>
+            <a:off x="803828" y="1282861"/>
+            <a:ext cx="2038819" cy="338554"/>
+          </a:xfrm>
+          <a:prstGeom prst="rect">
+            <a:avLst/>
+          </a:prstGeom>
+          <a:noFill/>
+        </p:spPr>
+        <p:txBody>
+          <a:bodyPr wrap="square">
+            <a:spAutoFit/>
+          </a:bodyPr>
+          <a:lstStyle/>
+          <a:p>
+            <a:r>
+              <a:rPr lang="en-SG" sz="1600" b="1" dirty="0">
+                <a:solidFill>
+                  <a:schemeClr val="tx2">
+                    <a:lumMod val="75000"/>
+                    <a:lumOff val="25000"/>
+                  </a:schemeClr>
+                </a:solidFill>
+              </a:rPr>
+              <a:t>Internal Network</a:t>
+            </a:r>
+          </a:p>
+        </p:txBody>
+      </p:sp>
+      <p:cxnSp>
+        <p:nvCxnSpPr>
+          <p:cNvPr id="109" name="Straight Arrow Connector 108">
+            <a:extLst>
+              <a:ext uri="{FF2B5EF4-FFF2-40B4-BE49-F238E27FC236}">
+                <a16:creationId xmlns:a16="http://schemas.microsoft.com/office/drawing/2014/main" id="{226FE320-037C-20B2-46A0-15F074767E21}"/>
+              </a:ext>
+            </a:extLst>
+          </p:cNvPr>
+          <p:cNvCxnSpPr/>
+          <p:nvPr/>
+        </p:nvCxnSpPr>
+        <p:spPr>
+          <a:xfrm>
+            <a:off x="9280325" y="2247176"/>
+            <a:ext cx="0" cy="547523"/>
+          </a:xfrm>
+          <a:prstGeom prst="straightConnector1">
+            <a:avLst/>
+          </a:prstGeom>
+          <a:ln>
+            <a:solidFill>
+              <a:schemeClr val="accent2">
+                <a:lumMod val="75000"/>
+              </a:schemeClr>
+            </a:solidFill>
+            <a:prstDash val="sysDash"/>
+            <a:tailEnd type="triangle"/>
+          </a:ln>
+        </p:spPr>
+        <p:style>
+          <a:lnRef idx="2">
+            <a:schemeClr val="accent1"/>
+          </a:lnRef>
+          <a:fillRef idx="0">
+            <a:schemeClr val="accent1"/>
+          </a:fillRef>
+          <a:effectRef idx="1">
+            <a:schemeClr val="accent1"/>
+          </a:effectRef>
+          <a:fontRef idx="minor">
+            <a:schemeClr val="tx1"/>
+          </a:fontRef>
+        </p:style>
+      </p:cxnSp>
+      <p:cxnSp>
+        <p:nvCxnSpPr>
+          <p:cNvPr id="110" name="Straight Arrow Connector 109">
+            <a:extLst>
+              <a:ext uri="{FF2B5EF4-FFF2-40B4-BE49-F238E27FC236}">
+                <a16:creationId xmlns:a16="http://schemas.microsoft.com/office/drawing/2014/main" id="{DEA84341-B69D-2829-179C-C93E5FA45918}"/>
+              </a:ext>
+            </a:extLst>
+          </p:cNvPr>
+          <p:cNvCxnSpPr>
+            <a:cxnSpLocks/>
+          </p:cNvCxnSpPr>
+          <p:nvPr/>
+        </p:nvCxnSpPr>
+        <p:spPr>
+          <a:xfrm flipH="1" flipV="1">
+            <a:off x="8753011" y="2790908"/>
+            <a:ext cx="472045" cy="0"/>
+          </a:xfrm>
+          <a:prstGeom prst="straightConnector1">
+            <a:avLst/>
+          </a:prstGeom>
+          <a:ln>
+            <a:solidFill>
+              <a:schemeClr val="accent2">
+                <a:lumMod val="75000"/>
+              </a:schemeClr>
+            </a:solidFill>
+            <a:prstDash val="sysDash"/>
+            <a:tailEnd type="triangle"/>
+          </a:ln>
+        </p:spPr>
+        <p:style>
+          <a:lnRef idx="2">
+            <a:schemeClr val="accent1"/>
+          </a:lnRef>
+          <a:fillRef idx="0">
+            <a:schemeClr val="accent1"/>
+          </a:fillRef>
+          <a:effectRef idx="1">
+            <a:schemeClr val="accent1"/>
+          </a:effectRef>
+          <a:fontRef idx="minor">
+            <a:schemeClr val="tx1"/>
+          </a:fontRef>
+        </p:style>
+      </p:cxnSp>
+      <p:cxnSp>
+        <p:nvCxnSpPr>
+          <p:cNvPr id="115" name="Straight Arrow Connector 114">
+            <a:extLst>
+              <a:ext uri="{FF2B5EF4-FFF2-40B4-BE49-F238E27FC236}">
+                <a16:creationId xmlns:a16="http://schemas.microsoft.com/office/drawing/2014/main" id="{F713C23B-858A-CDB6-B1F9-C2DF209B338E}"/>
+              </a:ext>
+            </a:extLst>
+          </p:cNvPr>
+          <p:cNvCxnSpPr>
+            <a:cxnSpLocks/>
+          </p:cNvCxnSpPr>
+          <p:nvPr/>
+        </p:nvCxnSpPr>
+        <p:spPr>
+          <a:xfrm>
+            <a:off x="8721485" y="2798545"/>
+            <a:ext cx="0" cy="337725"/>
+          </a:xfrm>
+          <a:prstGeom prst="straightConnector1">
+            <a:avLst/>
+          </a:prstGeom>
+          <a:ln>
+            <a:solidFill>
+              <a:schemeClr val="accent2">
+                <a:lumMod val="75000"/>
+              </a:schemeClr>
+            </a:solidFill>
+            <a:prstDash val="sysDash"/>
+            <a:tailEnd type="triangle"/>
+          </a:ln>
+        </p:spPr>
+        <p:style>
+          <a:lnRef idx="2">
+            <a:schemeClr val="accent1"/>
+          </a:lnRef>
+          <a:fillRef idx="0">
+            <a:schemeClr val="accent1"/>
+          </a:fillRef>
+          <a:effectRef idx="1">
+            <a:schemeClr val="accent1"/>
+          </a:effectRef>
+          <a:fontRef idx="minor">
+            <a:schemeClr val="tx1"/>
+          </a:fontRef>
+        </p:style>
+      </p:cxnSp>
+      <p:cxnSp>
+        <p:nvCxnSpPr>
+          <p:cNvPr id="118" name="Straight Arrow Connector 117">
+            <a:extLst>
+              <a:ext uri="{FF2B5EF4-FFF2-40B4-BE49-F238E27FC236}">
+                <a16:creationId xmlns:a16="http://schemas.microsoft.com/office/drawing/2014/main" id="{7943C0E3-CD5E-A5CB-451B-845DA18A79F4}"/>
+              </a:ext>
+            </a:extLst>
+          </p:cNvPr>
+          <p:cNvCxnSpPr>
+            <a:cxnSpLocks/>
+          </p:cNvCxnSpPr>
+          <p:nvPr/>
+        </p:nvCxnSpPr>
+        <p:spPr>
+          <a:xfrm flipH="1">
+            <a:off x="8433138" y="3136270"/>
+            <a:ext cx="257478" cy="0"/>
+          </a:xfrm>
+          <a:prstGeom prst="straightConnector1">
+            <a:avLst/>
+          </a:prstGeom>
+          <a:ln>
+            <a:solidFill>
+              <a:schemeClr val="accent2">
+                <a:lumMod val="75000"/>
+              </a:schemeClr>
+            </a:solidFill>
+            <a:prstDash val="sysDash"/>
+            <a:tailEnd type="triangle"/>
+          </a:ln>
+        </p:spPr>
+        <p:style>
+          <a:lnRef idx="2">
+            <a:schemeClr val="accent1"/>
+          </a:lnRef>
+          <a:fillRef idx="0">
+            <a:schemeClr val="accent1"/>
+          </a:fillRef>
+          <a:effectRef idx="1">
+            <a:schemeClr val="accent1"/>
+          </a:effectRef>
+          <a:fontRef idx="minor">
+            <a:schemeClr val="tx1"/>
+          </a:fontRef>
+        </p:style>
+      </p:cxnSp>
+      <p:cxnSp>
+        <p:nvCxnSpPr>
+          <p:cNvPr id="121" name="Straight Arrow Connector 120">
+            <a:extLst>
+              <a:ext uri="{FF2B5EF4-FFF2-40B4-BE49-F238E27FC236}">
+                <a16:creationId xmlns:a16="http://schemas.microsoft.com/office/drawing/2014/main" id="{4C8E9F42-0F0F-9DA8-BAAF-85B96848FDB6}"/>
+              </a:ext>
+            </a:extLst>
+          </p:cNvPr>
+          <p:cNvCxnSpPr>
+            <a:cxnSpLocks/>
+          </p:cNvCxnSpPr>
+          <p:nvPr/>
+        </p:nvCxnSpPr>
+        <p:spPr>
+          <a:xfrm flipH="1">
+            <a:off x="6133854" y="3377475"/>
+            <a:ext cx="652798" cy="0"/>
+          </a:xfrm>
+          <a:prstGeom prst="straightConnector1">
+            <a:avLst/>
+          </a:prstGeom>
+          <a:ln>
+            <a:solidFill>
+              <a:schemeClr val="accent2">
+                <a:lumMod val="75000"/>
+              </a:schemeClr>
+            </a:solidFill>
+            <a:prstDash val="sysDash"/>
+            <a:tailEnd type="triangle"/>
+          </a:ln>
+        </p:spPr>
+        <p:style>
+          <a:lnRef idx="2">
+            <a:schemeClr val="accent1"/>
+          </a:lnRef>
+          <a:fillRef idx="0">
+            <a:schemeClr val="accent1"/>
+          </a:fillRef>
+          <a:effectRef idx="1">
+            <a:schemeClr val="accent1"/>
+          </a:effectRef>
+          <a:fontRef idx="minor">
+            <a:schemeClr val="tx1"/>
+          </a:fontRef>
+        </p:style>
+      </p:cxnSp>
+      <p:cxnSp>
+        <p:nvCxnSpPr>
+          <p:cNvPr id="123" name="Straight Arrow Connector 122">
+            <a:extLst>
+              <a:ext uri="{FF2B5EF4-FFF2-40B4-BE49-F238E27FC236}">
+                <a16:creationId xmlns:a16="http://schemas.microsoft.com/office/drawing/2014/main" id="{8648042D-4015-A446-3CB5-061E406B2A0F}"/>
+              </a:ext>
+            </a:extLst>
+          </p:cNvPr>
+          <p:cNvCxnSpPr>
+            <a:cxnSpLocks/>
+          </p:cNvCxnSpPr>
+          <p:nvPr/>
+        </p:nvCxnSpPr>
+        <p:spPr>
+          <a:xfrm flipV="1">
+            <a:off x="5464416" y="3736777"/>
+            <a:ext cx="0" cy="258976"/>
+          </a:xfrm>
+          <a:prstGeom prst="straightConnector1">
+            <a:avLst/>
+          </a:prstGeom>
+          <a:ln>
+            <a:solidFill>
+              <a:schemeClr val="accent2">
+                <a:lumMod val="75000"/>
+              </a:schemeClr>
+            </a:solidFill>
+            <a:prstDash val="sysDash"/>
+            <a:tailEnd type="triangle"/>
+          </a:ln>
+        </p:spPr>
+        <p:style>
+          <a:lnRef idx="2">
+            <a:schemeClr val="accent1"/>
+          </a:lnRef>
+          <a:fillRef idx="0">
+            <a:schemeClr val="accent1"/>
+          </a:fillRef>
+          <a:effectRef idx="1">
+            <a:schemeClr val="accent1"/>
+          </a:effectRef>
+          <a:fontRef idx="minor">
+            <a:schemeClr val="tx1"/>
+          </a:fontRef>
+        </p:style>
+      </p:cxnSp>
+      <p:cxnSp>
+        <p:nvCxnSpPr>
+          <p:cNvPr id="125" name="Straight Arrow Connector 124">
+            <a:extLst>
+              <a:ext uri="{FF2B5EF4-FFF2-40B4-BE49-F238E27FC236}">
+                <a16:creationId xmlns:a16="http://schemas.microsoft.com/office/drawing/2014/main" id="{5CF3EA1F-E971-30EE-867A-F832864FEE8A}"/>
+              </a:ext>
+            </a:extLst>
+          </p:cNvPr>
+          <p:cNvCxnSpPr>
+            <a:cxnSpLocks/>
+          </p:cNvCxnSpPr>
+          <p:nvPr/>
+        </p:nvCxnSpPr>
+        <p:spPr>
+          <a:xfrm flipH="1">
+            <a:off x="4219117" y="3351769"/>
+            <a:ext cx="728268" cy="0"/>
+          </a:xfrm>
+          <a:prstGeom prst="straightConnector1">
+            <a:avLst/>
+          </a:prstGeom>
+          <a:ln>
+            <a:solidFill>
+              <a:schemeClr val="accent2">
+                <a:lumMod val="75000"/>
+              </a:schemeClr>
+            </a:solidFill>
+            <a:prstDash val="sysDash"/>
+            <a:tailEnd type="triangle"/>
+          </a:ln>
+        </p:spPr>
+        <p:style>
+          <a:lnRef idx="2">
+            <a:schemeClr val="accent1"/>
+          </a:lnRef>
+          <a:fillRef idx="0">
+            <a:schemeClr val="accent1"/>
+          </a:fillRef>
+          <a:effectRef idx="1">
+            <a:schemeClr val="accent1"/>
+          </a:effectRef>
+          <a:fontRef idx="minor">
+            <a:schemeClr val="tx1"/>
+          </a:fontRef>
+        </p:style>
+      </p:cxnSp>
+      <p:cxnSp>
+        <p:nvCxnSpPr>
+          <p:cNvPr id="127" name="Straight Arrow Connector 126">
+            <a:extLst>
+              <a:ext uri="{FF2B5EF4-FFF2-40B4-BE49-F238E27FC236}">
+                <a16:creationId xmlns:a16="http://schemas.microsoft.com/office/drawing/2014/main" id="{8CD645B5-0586-7485-BDEE-0E85BA08304E}"/>
+              </a:ext>
+            </a:extLst>
+          </p:cNvPr>
+          <p:cNvCxnSpPr>
+            <a:cxnSpLocks/>
+          </p:cNvCxnSpPr>
+          <p:nvPr/>
+        </p:nvCxnSpPr>
+        <p:spPr>
+          <a:xfrm flipH="1">
+            <a:off x="6314659" y="2535816"/>
+            <a:ext cx="0" cy="375976"/>
+          </a:xfrm>
+          <a:prstGeom prst="straightConnector1">
+            <a:avLst/>
+          </a:prstGeom>
+          <a:ln>
+            <a:solidFill>
+              <a:schemeClr val="accent2">
+                <a:lumMod val="75000"/>
+              </a:schemeClr>
+            </a:solidFill>
+            <a:prstDash val="sysDash"/>
+            <a:tailEnd type="triangle"/>
+          </a:ln>
+        </p:spPr>
+        <p:style>
+          <a:lnRef idx="2">
+            <a:schemeClr val="accent1"/>
+          </a:lnRef>
+          <a:fillRef idx="0">
+            <a:schemeClr val="accent1"/>
+          </a:fillRef>
+          <a:effectRef idx="1">
+            <a:schemeClr val="accent1"/>
+          </a:effectRef>
+          <a:fontRef idx="minor">
+            <a:schemeClr val="tx1"/>
+          </a:fontRef>
+        </p:style>
+      </p:cxnSp>
+      <p:cxnSp>
+        <p:nvCxnSpPr>
+          <p:cNvPr id="130" name="Straight Arrow Connector 129">
+            <a:extLst>
+              <a:ext uri="{FF2B5EF4-FFF2-40B4-BE49-F238E27FC236}">
+                <a16:creationId xmlns:a16="http://schemas.microsoft.com/office/drawing/2014/main" id="{E12E0E73-72CB-D3C5-6626-9BA4196185AA}"/>
+              </a:ext>
+            </a:extLst>
+          </p:cNvPr>
+          <p:cNvCxnSpPr>
+            <a:cxnSpLocks/>
+          </p:cNvCxnSpPr>
+          <p:nvPr/>
+        </p:nvCxnSpPr>
+        <p:spPr>
+          <a:xfrm flipH="1" flipV="1">
+            <a:off x="6096000" y="2951842"/>
+            <a:ext cx="219942" cy="0"/>
+          </a:xfrm>
+          <a:prstGeom prst="straightConnector1">
+            <a:avLst/>
+          </a:prstGeom>
+          <a:ln>
+            <a:solidFill>
+              <a:schemeClr val="accent2">
+                <a:lumMod val="75000"/>
+              </a:schemeClr>
+            </a:solidFill>
+            <a:prstDash val="sysDash"/>
+            <a:tailEnd type="triangle"/>
+          </a:ln>
+        </p:spPr>
+        <p:style>
+          <a:lnRef idx="2">
+            <a:schemeClr val="accent1"/>
+          </a:lnRef>
+          <a:fillRef idx="0">
+            <a:schemeClr val="accent1"/>
+          </a:fillRef>
+          <a:effectRef idx="1">
+            <a:schemeClr val="accent1"/>
+          </a:effectRef>
+          <a:fontRef idx="minor">
+            <a:schemeClr val="tx1"/>
+          </a:fontRef>
+        </p:style>
+      </p:cxnSp>
+      <p:cxnSp>
+        <p:nvCxnSpPr>
+          <p:cNvPr id="134" name="Straight Arrow Connector 133">
+            <a:extLst>
+              <a:ext uri="{FF2B5EF4-FFF2-40B4-BE49-F238E27FC236}">
+                <a16:creationId xmlns:a16="http://schemas.microsoft.com/office/drawing/2014/main" id="{FB7E5BA8-1F83-AFAE-BABE-CFFFD83793AA}"/>
+              </a:ext>
+            </a:extLst>
+          </p:cNvPr>
+          <p:cNvCxnSpPr>
+            <a:cxnSpLocks/>
+          </p:cNvCxnSpPr>
+          <p:nvPr/>
+        </p:nvCxnSpPr>
+        <p:spPr>
+          <a:xfrm flipH="1">
+            <a:off x="1143258" y="5214349"/>
+            <a:ext cx="385466" cy="0"/>
+          </a:xfrm>
+          <a:prstGeom prst="straightConnector1">
+            <a:avLst/>
+          </a:prstGeom>
+          <a:ln>
+            <a:solidFill>
+              <a:schemeClr val="accent2">
+                <a:lumMod val="75000"/>
+              </a:schemeClr>
+            </a:solidFill>
+            <a:prstDash val="sysDash"/>
+            <a:tailEnd type="triangle"/>
+          </a:ln>
+        </p:spPr>
+        <p:style>
+          <a:lnRef idx="2">
+            <a:schemeClr val="accent1"/>
+          </a:lnRef>
+          <a:fillRef idx="0">
+            <a:schemeClr val="accent1"/>
+          </a:fillRef>
+          <a:effectRef idx="1">
+            <a:schemeClr val="accent1"/>
+          </a:effectRef>
+          <a:fontRef idx="minor">
+            <a:schemeClr val="tx1"/>
+          </a:fontRef>
+        </p:style>
+      </p:cxnSp>
+      <p:sp>
+        <p:nvSpPr>
+          <p:cNvPr id="136" name="TextBox 135">
+            <a:extLst>
+              <a:ext uri="{FF2B5EF4-FFF2-40B4-BE49-F238E27FC236}">
+                <a16:creationId xmlns:a16="http://schemas.microsoft.com/office/drawing/2014/main" id="{CFACF121-D0A0-B399-2C74-F538002EE800}"/>
+              </a:ext>
+            </a:extLst>
+          </p:cNvPr>
+          <p:cNvSpPr txBox="1"/>
+          <p:nvPr/>
+        </p:nvSpPr>
+        <p:spPr>
+          <a:xfrm>
+            <a:off x="1544230" y="5056533"/>
+            <a:ext cx="3042866" cy="276999"/>
+          </a:xfrm>
+          <a:prstGeom prst="rect">
+            <a:avLst/>
+          </a:prstGeom>
+          <a:noFill/>
+        </p:spPr>
+        <p:txBody>
+          <a:bodyPr wrap="square">
+            <a:spAutoFit/>
+          </a:bodyPr>
+          <a:lstStyle/>
+          <a:p>
+            <a:r>
+              <a:rPr lang="en-SG" sz="1200" b="1" dirty="0">
+                <a:solidFill>
+                  <a:schemeClr val="accent2">
+                    <a:lumMod val="75000"/>
+                  </a:schemeClr>
+                </a:solidFill>
+              </a:rPr>
+              <a:t>Port Forwarded </a:t>
+            </a:r>
+            <a:r>
+              <a:rPr lang="en-SG" sz="1200" b="1" dirty="0" err="1">
+                <a:solidFill>
+                  <a:schemeClr val="accent2">
+                    <a:lumMod val="75000"/>
+                  </a:schemeClr>
+                </a:solidFill>
+              </a:rPr>
+              <a:t>OpenClaw</a:t>
+            </a:r>
+            <a:r>
+              <a:rPr lang="en-SG" sz="1200" b="1" dirty="0">
+                <a:solidFill>
+                  <a:schemeClr val="accent2">
+                    <a:lumMod val="75000"/>
+                  </a:schemeClr>
+                </a:solidFill>
+              </a:rPr>
+              <a:t> API call to LLM </a:t>
+            </a:r>
+          </a:p>
+        </p:txBody>
+      </p:sp>
+    </p:spTree>
+    <p:extLst>
+      <p:ext uri="{BB962C8B-B14F-4D97-AF65-F5344CB8AC3E}">
+        <p14:creationId xmlns:p14="http://schemas.microsoft.com/office/powerpoint/2010/main" val="3743561555"/>
+      </p:ext>
+    </p:extLst>
+  </p:cSld>
+  <p:clrMapOvr>
+    <a:masterClrMapping/>
+  </p:clrMapOvr>
+</p:sld>
+</file>
+
+<file path=ppt/slides/slide4.xml><?xml version="1.0" encoding="utf-8"?>
+<p:sld xmlns:a="http://schemas.openxmlformats.org/drawingml/2006/main" xmlns:r="http://schemas.openxmlformats.org/officeDocument/2006/relationships" xmlns:p="http://schemas.openxmlformats.org/presentationml/2006/main">
+  <p:cSld>
+    <p:spTree>
+      <p:nvGrpSpPr>
+        <p:cNvPr id="1" name=""/>
+        <p:cNvGrpSpPr/>
+        <p:nvPr/>
+      </p:nvGrpSpPr>
+      <p:grpSpPr>
+        <a:xfrm>
+          <a:off x="0" y="0"/>
+          <a:ext cx="0" cy="0"/>
+          <a:chOff x="0" y="0"/>
+          <a:chExt cx="0" cy="0"/>
+        </a:xfrm>
+      </p:grpSpPr>
+      <p:pic>
+        <p:nvPicPr>
+          <p:cNvPr id="5" name="Picture 4">
+            <a:extLst>
+              <a:ext uri="{FF2B5EF4-FFF2-40B4-BE49-F238E27FC236}">
+                <a16:creationId xmlns:a16="http://schemas.microsoft.com/office/drawing/2014/main" id="{17CC5D2E-DADF-8393-043C-8850DEC8BE9E}"/>
+              </a:ext>
+            </a:extLst>
+          </p:cNvPr>
+          <p:cNvPicPr>
+            <a:picLocks noChangeAspect="1"/>
+          </p:cNvPicPr>
+          <p:nvPr/>
+        </p:nvPicPr>
+        <p:blipFill>
+          <a:blip r:embed="rId2"/>
+          <a:stretch>
+            <a:fillRect/>
+          </a:stretch>
+        </p:blipFill>
+        <p:spPr>
+          <a:xfrm>
+            <a:off x="3415047" y="2452809"/>
+            <a:ext cx="5361905" cy="1952381"/>
+          </a:xfrm>
+          <a:prstGeom prst="rect">
+            <a:avLst/>
+          </a:prstGeom>
+        </p:spPr>
+      </p:pic>
+    </p:spTree>
+    <p:extLst>
+      <p:ext uri="{BB962C8B-B14F-4D97-AF65-F5344CB8AC3E}">
+        <p14:creationId xmlns:p14="http://schemas.microsoft.com/office/powerpoint/2010/main" val="442582796"/>
       </p:ext>
     </p:extLst>
   </p:cSld>
@@ -4548,4 +7632,319 @@
     </a:ext>
   </a:extLst>
 </a:theme>
+</file>
+
+<file path=ppt/theme/theme2.xml><?xml version="1.0" encoding="utf-8"?>
+<a:theme xmlns:a="http://schemas.openxmlformats.org/drawingml/2006/main" name="Office Theme">
+  <a:themeElements>
+    <a:clrScheme name="Office">
+      <a:dk1>
+        <a:sysClr val="windowText" lastClr="000000"/>
+      </a:dk1>
+      <a:lt1>
+        <a:sysClr val="window" lastClr="FFFFFF"/>
+      </a:lt1>
+      <a:dk2>
+        <a:srgbClr val="0E2841"/>
+      </a:dk2>
+      <a:lt2>
+        <a:srgbClr val="E8E8E8"/>
+      </a:lt2>
+      <a:accent1>
+        <a:srgbClr val="156082"/>
+      </a:accent1>
+      <a:accent2>
+        <a:srgbClr val="E97132"/>
+      </a:accent2>
+      <a:accent3>
+        <a:srgbClr val="196B24"/>
+      </a:accent3>
+      <a:accent4>
+        <a:srgbClr val="0F9ED5"/>
+      </a:accent4>
+      <a:accent5>
+        <a:srgbClr val="A02B93"/>
+      </a:accent5>
+      <a:accent6>
+        <a:srgbClr val="4EA72E"/>
+      </a:accent6>
+      <a:hlink>
+        <a:srgbClr val="467886"/>
+      </a:hlink>
+      <a:folHlink>
+        <a:srgbClr val="96607D"/>
+      </a:folHlink>
+    </a:clrScheme>
+    <a:fontScheme name="Office">
+      <a:majorFont>
+        <a:latin typeface="Aptos Display" panose="02110004020202020204"/>
+        <a:ea typeface=""/>
+        <a:cs typeface=""/>
+        <a:font script="Jpan" typeface="游ゴシック Light"/>
+        <a:font script="Hang" typeface="맑은 고딕"/>
+        <a:font script="Hans" typeface="等线 Light"/>
+        <a:font script="Hant" typeface="新細明體"/>
+        <a:font script="Arab" typeface="Times New Roman"/>
+        <a:font script="Hebr" typeface="Times New Roman"/>
+        <a:font script="Thai" typeface="Angsana New"/>
+        <a:font script="Ethi" typeface="Nyala"/>
+        <a:font script="Beng" typeface="Vrinda"/>
+        <a:font script="Gujr" typeface="Shruti"/>
+        <a:font script="Khmr" typeface="MoolBoran"/>
+        <a:font script="Knda" typeface="Tunga"/>
+        <a:font script="Guru" typeface="Raavi"/>
+        <a:font script="Cans" typeface="Euphemia"/>
+        <a:font script="Cher" typeface="Plantagenet Cherokee"/>
+        <a:font script="Yiii" typeface="Microsoft Yi Baiti"/>
+        <a:font script="Tibt" typeface="Microsoft Himalaya"/>
+        <a:font script="Thaa" typeface="MV Boli"/>
+        <a:font script="Deva" typeface="Mangal"/>
+        <a:font script="Telu" typeface="Gautami"/>
+        <a:font script="Taml" typeface="Latha"/>
+        <a:font script="Syrc" typeface="Estrangelo Edessa"/>
+        <a:font script="Orya" typeface="Kalinga"/>
+        <a:font script="Mlym" typeface="Kartika"/>
+        <a:font script="Laoo" typeface="DokChampa"/>
+        <a:font script="Sinh" typeface="Iskoola Pota"/>
+        <a:font script="Mong" typeface="Mongolian Baiti"/>
+        <a:font script="Viet" typeface="Times New Roman"/>
+        <a:font script="Uigh" typeface="Microsoft Uighur"/>
+        <a:font script="Geor" typeface="Sylfaen"/>
+        <a:font script="Armn" typeface="Arial"/>
+        <a:font script="Bugi" typeface="Leelawadee UI"/>
+        <a:font script="Bopo" typeface="Microsoft JhengHei"/>
+        <a:font script="Java" typeface="Javanese Text"/>
+        <a:font script="Lisu" typeface="Segoe UI"/>
+        <a:font script="Mymr" typeface="Myanmar Text"/>
+        <a:font script="Nkoo" typeface="Ebrima"/>
+        <a:font script="Olck" typeface="Nirmala UI"/>
+        <a:font script="Osma" typeface="Ebrima"/>
+        <a:font script="Phag" typeface="Phagspa"/>
+        <a:font script="Syrn" typeface="Estrangelo Edessa"/>
+        <a:font script="Syrj" typeface="Estrangelo Edessa"/>
+        <a:font script="Syre" typeface="Estrangelo Edessa"/>
+        <a:font script="Sora" typeface="Nirmala UI"/>
+        <a:font script="Tale" typeface="Microsoft Tai Le"/>
+        <a:font script="Talu" typeface="Microsoft New Tai Lue"/>
+        <a:font script="Tfng" typeface="Ebrima"/>
+      </a:majorFont>
+      <a:minorFont>
+        <a:latin typeface="Aptos" panose="02110004020202020204"/>
+        <a:ea typeface=""/>
+        <a:cs typeface=""/>
+        <a:font script="Jpan" typeface="游ゴシック"/>
+        <a:font script="Hang" typeface="맑은 고딕"/>
+        <a:font script="Hans" typeface="等线"/>
+        <a:font script="Hant" typeface="新細明體"/>
+        <a:font script="Arab" typeface="Arial"/>
+        <a:font script="Hebr" typeface="Arial"/>
+        <a:font script="Thai" typeface="Cordia New"/>
+        <a:font script="Ethi" typeface="Nyala"/>
+        <a:font script="Beng" typeface="Vrinda"/>
+        <a:font script="Gujr" typeface="Shruti"/>
+        <a:font script="Khmr" typeface="DaunPenh"/>
+        <a:font script="Knda" typeface="Tunga"/>
+        <a:font script="Guru" typeface="Raavi"/>
+        <a:font script="Cans" typeface="Euphemia"/>
+        <a:font script="Cher" typeface="Plantagenet Cherokee"/>
+        <a:font script="Yiii" typeface="Microsoft Yi Baiti"/>
+        <a:font script="Tibt" typeface="Microsoft Himalaya"/>
+        <a:font script="Thaa" typeface="MV Boli"/>
+        <a:font script="Deva" typeface="Mangal"/>
+        <a:font script="Telu" typeface="Gautami"/>
+        <a:font script="Taml" typeface="Latha"/>
+        <a:font script="Syrc" typeface="Estrangelo Edessa"/>
+        <a:font script="Orya" typeface="Kalinga"/>
+        <a:font script="Mlym" typeface="Kartika"/>
+        <a:font script="Laoo" typeface="DokChampa"/>
+        <a:font script="Sinh" typeface="Iskoola Pota"/>
+        <a:font script="Mong" typeface="Mongolian Baiti"/>
+        <a:font script="Viet" typeface="Arial"/>
+        <a:font script="Uigh" typeface="Microsoft Uighur"/>
+        <a:font script="Geor" typeface="Sylfaen"/>
+        <a:font script="Armn" typeface="Arial"/>
+        <a:font script="Bugi" typeface="Leelawadee UI"/>
+        <a:font script="Bopo" typeface="Microsoft JhengHei"/>
+        <a:font script="Java" typeface="Javanese Text"/>
+        <a:font script="Lisu" typeface="Segoe UI"/>
+        <a:font script="Mymr" typeface="Myanmar Text"/>
+        <a:font script="Nkoo" typeface="Ebrima"/>
+        <a:font script="Olck" typeface="Nirmala UI"/>
+        <a:font script="Osma" typeface="Ebrima"/>
+        <a:font script="Phag" typeface="Phagspa"/>
+        <a:font script="Syrn" typeface="Estrangelo Edessa"/>
+        <a:font script="Syrj" typeface="Estrangelo Edessa"/>
+        <a:font script="Syre" typeface="Estrangelo Edessa"/>
+        <a:font script="Sora" typeface="Nirmala UI"/>
+        <a:font script="Tale" typeface="Microsoft Tai Le"/>
+        <a:font script="Talu" typeface="Microsoft New Tai Lue"/>
+        <a:font script="Tfng" typeface="Ebrima"/>
+      </a:minorFont>
+    </a:fontScheme>
+    <a:fmtScheme name="Office">
+      <a:fillStyleLst>
+        <a:solidFill>
+          <a:schemeClr val="phClr"/>
+        </a:solidFill>
+        <a:gradFill rotWithShape="1">
+          <a:gsLst>
+            <a:gs pos="0">
+              <a:schemeClr val="phClr">
+                <a:lumMod val="110000"/>
+                <a:satMod val="105000"/>
+                <a:tint val="67000"/>
+              </a:schemeClr>
+            </a:gs>
+            <a:gs pos="50000">
+              <a:schemeClr val="phClr">
+                <a:lumMod val="105000"/>
+                <a:satMod val="103000"/>
+                <a:tint val="73000"/>
+              </a:schemeClr>
+            </a:gs>
+            <a:gs pos="100000">
+              <a:schemeClr val="phClr">
+                <a:lumMod val="105000"/>
+                <a:satMod val="109000"/>
+                <a:tint val="81000"/>
+              </a:schemeClr>
+            </a:gs>
+          </a:gsLst>
+          <a:lin ang="5400000" scaled="0"/>
+        </a:gradFill>
+        <a:gradFill rotWithShape="1">
+          <a:gsLst>
+            <a:gs pos="0">
+              <a:schemeClr val="phClr">
+                <a:satMod val="103000"/>
+                <a:lumMod val="102000"/>
+                <a:tint val="94000"/>
+              </a:schemeClr>
+            </a:gs>
+            <a:gs pos="50000">
+              <a:schemeClr val="phClr">
+                <a:satMod val="110000"/>
+                <a:lumMod val="100000"/>
+                <a:shade val="100000"/>
+              </a:schemeClr>
+            </a:gs>
+            <a:gs pos="100000">
+              <a:schemeClr val="phClr">
+                <a:lumMod val="99000"/>
+                <a:satMod val="120000"/>
+                <a:shade val="78000"/>
+              </a:schemeClr>
+            </a:gs>
+          </a:gsLst>
+          <a:lin ang="5400000" scaled="0"/>
+        </a:gradFill>
+      </a:fillStyleLst>
+      <a:lnStyleLst>
+        <a:ln w="12700" cap="flat" cmpd="sng" algn="ctr">
+          <a:solidFill>
+            <a:schemeClr val="phClr"/>
+          </a:solidFill>
+          <a:prstDash val="solid"/>
+          <a:miter lim="800000"/>
+        </a:ln>
+        <a:ln w="19050" cap="flat" cmpd="sng" algn="ctr">
+          <a:solidFill>
+            <a:schemeClr val="phClr"/>
+          </a:solidFill>
+          <a:prstDash val="solid"/>
+          <a:miter lim="800000"/>
+        </a:ln>
+        <a:ln w="25400" cap="flat" cmpd="sng" algn="ctr">
+          <a:solidFill>
+            <a:schemeClr val="phClr"/>
+          </a:solidFill>
+          <a:prstDash val="solid"/>
+          <a:miter lim="800000"/>
+        </a:ln>
+      </a:lnStyleLst>
+      <a:effectStyleLst>
+        <a:effectStyle>
+          <a:effectLst/>
+        </a:effectStyle>
+        <a:effectStyle>
+          <a:effectLst/>
+        </a:effectStyle>
+        <a:effectStyle>
+          <a:effectLst>
+            <a:outerShdw blurRad="57150" dist="19050" dir="5400000" algn="ctr" rotWithShape="0">
+              <a:srgbClr val="000000">
+                <a:alpha val="63000"/>
+              </a:srgbClr>
+            </a:outerShdw>
+          </a:effectLst>
+        </a:effectStyle>
+      </a:effectStyleLst>
+      <a:bgFillStyleLst>
+        <a:solidFill>
+          <a:schemeClr val="phClr"/>
+        </a:solidFill>
+        <a:solidFill>
+          <a:schemeClr val="phClr">
+            <a:tint val="95000"/>
+            <a:satMod val="170000"/>
+          </a:schemeClr>
+        </a:solidFill>
+        <a:gradFill rotWithShape="1">
+          <a:gsLst>
+            <a:gs pos="0">
+              <a:schemeClr val="phClr">
+                <a:tint val="93000"/>
+                <a:satMod val="150000"/>
+                <a:shade val="98000"/>
+                <a:lumMod val="102000"/>
+              </a:schemeClr>
+            </a:gs>
+            <a:gs pos="50000">
+              <a:schemeClr val="phClr">
+                <a:tint val="98000"/>
+                <a:satMod val="130000"/>
+                <a:shade val="90000"/>
+                <a:lumMod val="103000"/>
+              </a:schemeClr>
+            </a:gs>
+            <a:gs pos="100000">
+              <a:schemeClr val="phClr">
+                <a:shade val="63000"/>
+                <a:satMod val="120000"/>
+              </a:schemeClr>
+            </a:gs>
+          </a:gsLst>
+          <a:lin ang="5400000" scaled="0"/>
+        </a:gradFill>
+      </a:bgFillStyleLst>
+    </a:fmtScheme>
+  </a:themeElements>
+  <a:objectDefaults>
+    <a:lnDef>
+      <a:spPr/>
+      <a:bodyPr/>
+      <a:lstStyle/>
+      <a:style>
+        <a:lnRef idx="2">
+          <a:schemeClr val="accent1"/>
+        </a:lnRef>
+        <a:fillRef idx="0">
+          <a:schemeClr val="accent1"/>
+        </a:fillRef>
+        <a:effectRef idx="1">
+          <a:schemeClr val="accent1"/>
+        </a:effectRef>
+        <a:fontRef idx="minor">
+          <a:schemeClr val="tx1"/>
+        </a:fontRef>
+      </a:style>
+    </a:lnDef>
+  </a:objectDefaults>
+  <a:extraClrSchemeLst/>
+  <a:extLst>
+    <a:ext uri="{05A4C25C-085E-4340-85A3-A5531E510DB2}">
+      <thm15:themeFamily xmlns:thm15="http://schemas.microsoft.com/office/thememl/2012/main" name="Office Theme" id="{2E142A2C-CD16-42D6-873A-C26D2A0506FA}" vid="{1BDDFF52-6CD6-40A5-AB3C-68EB2F1E4D0A}"/>
+    </a:ext>
+  </a:extLst>
+</a:theme>
 </file>
</xml_diff>

<commit_message>
update the summary section and design document.
</commit_message>
<xml_diff>
--- a/Articles/5_OpenclawWithDeepSeek/img/designDoc.pptx
+++ b/Articles/5_OpenclawWithDeepSeek/img/designDoc.pptx
@@ -5,13 +5,14 @@
     <p:sldMasterId id="2147483648" r:id="rId1"/>
   </p:sldMasterIdLst>
   <p:notesMasterIdLst>
-    <p:notesMasterId r:id="rId6"/>
+    <p:notesMasterId r:id="rId7"/>
   </p:notesMasterIdLst>
   <p:sldIdLst>
     <p:sldId id="256" r:id="rId2"/>
     <p:sldId id="257" r:id="rId3"/>
     <p:sldId id="258" r:id="rId4"/>
-    <p:sldId id="259" r:id="rId5"/>
+    <p:sldId id="260" r:id="rId5"/>
+    <p:sldId id="259" r:id="rId6"/>
   </p:sldIdLst>
   <p:sldSz cx="12192000" cy="6858000"/>
   <p:notesSz cx="6858000" cy="9144000"/>
@@ -200,7 +201,7 @@
           <a:p>
             <a:fld id="{5FD7CF5F-CA5D-4CC3-AFB2-C100E3D4BFD0}" type="datetimeFigureOut">
               <a:rPr lang="en-SG" smtClean="0"/>
-              <a:t>13/3/2026</a:t>
+              <a:t>16/3/2026</a:t>
             </a:fld>
             <a:endParaRPr lang="en-SG"/>
           </a:p>
@@ -552,6 +553,114 @@
 </p:notes>
 </file>
 
+<file path=ppt/notesSlides/notesSlide2.xml><?xml version="1.0" encoding="utf-8"?>
+<p:notes xmlns:a="http://schemas.openxmlformats.org/drawingml/2006/main" xmlns:r="http://schemas.openxmlformats.org/officeDocument/2006/relationships" xmlns:p="http://schemas.openxmlformats.org/presentationml/2006/main">
+  <p:cSld>
+    <p:spTree>
+      <p:nvGrpSpPr>
+        <p:cNvPr id="1" name="">
+          <a:extLst>
+            <a:ext uri="{FF2B5EF4-FFF2-40B4-BE49-F238E27FC236}">
+              <a16:creationId xmlns:a16="http://schemas.microsoft.com/office/drawing/2014/main" id="{8BBF04CD-F5BE-AE7F-6DCF-A85D8AF316ED}"/>
+            </a:ext>
+          </a:extLst>
+        </p:cNvPr>
+        <p:cNvGrpSpPr/>
+        <p:nvPr/>
+      </p:nvGrpSpPr>
+      <p:grpSpPr>
+        <a:xfrm>
+          <a:off x="0" y="0"/>
+          <a:ext cx="0" cy="0"/>
+          <a:chOff x="0" y="0"/>
+          <a:chExt cx="0" cy="0"/>
+        </a:xfrm>
+      </p:grpSpPr>
+      <p:sp>
+        <p:nvSpPr>
+          <p:cNvPr id="2" name="Slide Image Placeholder 1">
+            <a:extLst>
+              <a:ext uri="{FF2B5EF4-FFF2-40B4-BE49-F238E27FC236}">
+                <a16:creationId xmlns:a16="http://schemas.microsoft.com/office/drawing/2014/main" id="{DD096FD9-48A0-2A3D-D663-68145E86BADE}"/>
+              </a:ext>
+            </a:extLst>
+          </p:cNvPr>
+          <p:cNvSpPr>
+            <a:spLocks noGrp="1" noRot="1" noChangeAspect="1"/>
+          </p:cNvSpPr>
+          <p:nvPr>
+            <p:ph type="sldImg"/>
+          </p:nvPr>
+        </p:nvSpPr>
+        <p:spPr/>
+      </p:sp>
+      <p:sp>
+        <p:nvSpPr>
+          <p:cNvPr id="3" name="Notes Placeholder 2">
+            <a:extLst>
+              <a:ext uri="{FF2B5EF4-FFF2-40B4-BE49-F238E27FC236}">
+                <a16:creationId xmlns:a16="http://schemas.microsoft.com/office/drawing/2014/main" id="{28A3D94D-57EC-29DF-083B-4C08888DBCEA}"/>
+              </a:ext>
+            </a:extLst>
+          </p:cNvPr>
+          <p:cNvSpPr>
+            <a:spLocks noGrp="1"/>
+          </p:cNvSpPr>
+          <p:nvPr>
+            <p:ph type="body" idx="1"/>
+          </p:nvPr>
+        </p:nvSpPr>
+        <p:spPr/>
+        <p:txBody>
+          <a:bodyPr/>
+          <a:lstStyle/>
+          <a:p>
+            <a:endParaRPr lang="en-SG" dirty="0"/>
+          </a:p>
+        </p:txBody>
+      </p:sp>
+      <p:sp>
+        <p:nvSpPr>
+          <p:cNvPr id="4" name="Slide Number Placeholder 3">
+            <a:extLst>
+              <a:ext uri="{FF2B5EF4-FFF2-40B4-BE49-F238E27FC236}">
+                <a16:creationId xmlns:a16="http://schemas.microsoft.com/office/drawing/2014/main" id="{FC56673E-26CB-4168-9B75-EBAA688508B0}"/>
+              </a:ext>
+            </a:extLst>
+          </p:cNvPr>
+          <p:cNvSpPr>
+            <a:spLocks noGrp="1"/>
+          </p:cNvSpPr>
+          <p:nvPr>
+            <p:ph type="sldNum" sz="quarter" idx="5"/>
+          </p:nvPr>
+        </p:nvSpPr>
+        <p:spPr/>
+        <p:txBody>
+          <a:bodyPr/>
+          <a:lstStyle/>
+          <a:p>
+            <a:fld id="{36D3BBB4-C4FE-47A6-B9D4-00C7D602B05D}" type="slidenum">
+              <a:rPr lang="en-SG" smtClean="0"/>
+              <a:t>4</a:t>
+            </a:fld>
+            <a:endParaRPr lang="en-SG"/>
+          </a:p>
+        </p:txBody>
+      </p:sp>
+    </p:spTree>
+    <p:extLst>
+      <p:ext uri="{BB962C8B-B14F-4D97-AF65-F5344CB8AC3E}">
+        <p14:creationId xmlns:p14="http://schemas.microsoft.com/office/powerpoint/2010/main" val="477036025"/>
+      </p:ext>
+    </p:extLst>
+  </p:cSld>
+  <p:clrMapOvr>
+    <a:masterClrMapping/>
+  </p:clrMapOvr>
+</p:notes>
+</file>
+
 <file path=ppt/slideLayouts/slideLayout1.xml><?xml version="1.0" encoding="utf-8"?>
 <p:sldLayout xmlns:a="http://schemas.openxmlformats.org/drawingml/2006/main" xmlns:r="http://schemas.openxmlformats.org/officeDocument/2006/relationships" xmlns:p="http://schemas.openxmlformats.org/presentationml/2006/main" type="title" preserve="1">
   <p:cSld name="Title Slide">
@@ -701,7 +810,7 @@
           <a:p>
             <a:fld id="{5BEA1B8F-E5B4-4E7F-AEC3-929E37D0EBCF}" type="datetimeFigureOut">
               <a:rPr lang="en-SG" smtClean="0"/>
-              <a:t>13/3/2026</a:t>
+              <a:t>16/3/2026</a:t>
             </a:fld>
             <a:endParaRPr lang="en-SG"/>
           </a:p>
@@ -901,7 +1010,7 @@
           <a:p>
             <a:fld id="{5BEA1B8F-E5B4-4E7F-AEC3-929E37D0EBCF}" type="datetimeFigureOut">
               <a:rPr lang="en-SG" smtClean="0"/>
-              <a:t>13/3/2026</a:t>
+              <a:t>16/3/2026</a:t>
             </a:fld>
             <a:endParaRPr lang="en-SG"/>
           </a:p>
@@ -1111,7 +1220,7 @@
           <a:p>
             <a:fld id="{5BEA1B8F-E5B4-4E7F-AEC3-929E37D0EBCF}" type="datetimeFigureOut">
               <a:rPr lang="en-SG" smtClean="0"/>
-              <a:t>13/3/2026</a:t>
+              <a:t>16/3/2026</a:t>
             </a:fld>
             <a:endParaRPr lang="en-SG"/>
           </a:p>
@@ -1311,7 +1420,7 @@
           <a:p>
             <a:fld id="{5BEA1B8F-E5B4-4E7F-AEC3-929E37D0EBCF}" type="datetimeFigureOut">
               <a:rPr lang="en-SG" smtClean="0"/>
-              <a:t>13/3/2026</a:t>
+              <a:t>16/3/2026</a:t>
             </a:fld>
             <a:endParaRPr lang="en-SG"/>
           </a:p>
@@ -1587,7 +1696,7 @@
           <a:p>
             <a:fld id="{5BEA1B8F-E5B4-4E7F-AEC3-929E37D0EBCF}" type="datetimeFigureOut">
               <a:rPr lang="en-SG" smtClean="0"/>
-              <a:t>13/3/2026</a:t>
+              <a:t>16/3/2026</a:t>
             </a:fld>
             <a:endParaRPr lang="en-SG"/>
           </a:p>
@@ -1855,7 +1964,7 @@
           <a:p>
             <a:fld id="{5BEA1B8F-E5B4-4E7F-AEC3-929E37D0EBCF}" type="datetimeFigureOut">
               <a:rPr lang="en-SG" smtClean="0"/>
-              <a:t>13/3/2026</a:t>
+              <a:t>16/3/2026</a:t>
             </a:fld>
             <a:endParaRPr lang="en-SG"/>
           </a:p>
@@ -2270,7 +2379,7 @@
           <a:p>
             <a:fld id="{5BEA1B8F-E5B4-4E7F-AEC3-929E37D0EBCF}" type="datetimeFigureOut">
               <a:rPr lang="en-SG" smtClean="0"/>
-              <a:t>13/3/2026</a:t>
+              <a:t>16/3/2026</a:t>
             </a:fld>
             <a:endParaRPr lang="en-SG"/>
           </a:p>
@@ -2412,7 +2521,7 @@
           <a:p>
             <a:fld id="{5BEA1B8F-E5B4-4E7F-AEC3-929E37D0EBCF}" type="datetimeFigureOut">
               <a:rPr lang="en-SG" smtClean="0"/>
-              <a:t>13/3/2026</a:t>
+              <a:t>16/3/2026</a:t>
             </a:fld>
             <a:endParaRPr lang="en-SG"/>
           </a:p>
@@ -2525,7 +2634,7 @@
           <a:p>
             <a:fld id="{5BEA1B8F-E5B4-4E7F-AEC3-929E37D0EBCF}" type="datetimeFigureOut">
               <a:rPr lang="en-SG" smtClean="0"/>
-              <a:t>13/3/2026</a:t>
+              <a:t>16/3/2026</a:t>
             </a:fld>
             <a:endParaRPr lang="en-SG"/>
           </a:p>
@@ -2838,7 +2947,7 @@
           <a:p>
             <a:fld id="{5BEA1B8F-E5B4-4E7F-AEC3-929E37D0EBCF}" type="datetimeFigureOut">
               <a:rPr lang="en-SG" smtClean="0"/>
-              <a:t>13/3/2026</a:t>
+              <a:t>16/3/2026</a:t>
             </a:fld>
             <a:endParaRPr lang="en-SG"/>
           </a:p>
@@ -3127,7 +3236,7 @@
           <a:p>
             <a:fld id="{5BEA1B8F-E5B4-4E7F-AEC3-929E37D0EBCF}" type="datetimeFigureOut">
               <a:rPr lang="en-SG" smtClean="0"/>
-              <a:t>13/3/2026</a:t>
+              <a:t>16/3/2026</a:t>
             </a:fld>
             <a:endParaRPr lang="en-SG"/>
           </a:p>
@@ -3370,7 +3479,7 @@
           <a:p>
             <a:fld id="{5BEA1B8F-E5B4-4E7F-AEC3-929E37D0EBCF}" type="datetimeFigureOut">
               <a:rPr lang="en-SG" smtClean="0"/>
-              <a:t>13/3/2026</a:t>
+              <a:t>16/3/2026</a:t>
             </a:fld>
             <a:endParaRPr lang="en-SG"/>
           </a:p>
@@ -7260,6 +7369,2934 @@
 </file>
 
 <file path=ppt/slides/slide4.xml><?xml version="1.0" encoding="utf-8"?>
+<p:sld xmlns:a="http://schemas.openxmlformats.org/drawingml/2006/main" xmlns:r="http://schemas.openxmlformats.org/officeDocument/2006/relationships" xmlns:p="http://schemas.openxmlformats.org/presentationml/2006/main">
+  <p:cSld>
+    <p:spTree>
+      <p:nvGrpSpPr>
+        <p:cNvPr id="1" name="">
+          <a:extLst>
+            <a:ext uri="{FF2B5EF4-FFF2-40B4-BE49-F238E27FC236}">
+              <a16:creationId xmlns:a16="http://schemas.microsoft.com/office/drawing/2014/main" id="{238DAFB0-D136-9C42-367E-32E383A34815}"/>
+            </a:ext>
+          </a:extLst>
+        </p:cNvPr>
+        <p:cNvGrpSpPr/>
+        <p:nvPr/>
+      </p:nvGrpSpPr>
+      <p:grpSpPr>
+        <a:xfrm>
+          <a:off x="0" y="0"/>
+          <a:ext cx="0" cy="0"/>
+          <a:chOff x="0" y="0"/>
+          <a:chExt cx="0" cy="0"/>
+        </a:xfrm>
+      </p:grpSpPr>
+      <p:sp>
+        <p:nvSpPr>
+          <p:cNvPr id="35" name="Rectangle 34">
+            <a:extLst>
+              <a:ext uri="{FF2B5EF4-FFF2-40B4-BE49-F238E27FC236}">
+                <a16:creationId xmlns:a16="http://schemas.microsoft.com/office/drawing/2014/main" id="{60EABFDF-2A21-7DB6-5529-E7C48A749A12}"/>
+              </a:ext>
+            </a:extLst>
+          </p:cNvPr>
+          <p:cNvSpPr/>
+          <p:nvPr/>
+        </p:nvSpPr>
+        <p:spPr>
+          <a:xfrm>
+            <a:off x="535863" y="433136"/>
+            <a:ext cx="11255084" cy="6102417"/>
+          </a:xfrm>
+          <a:prstGeom prst="rect">
+            <a:avLst/>
+          </a:prstGeom>
+          <a:solidFill>
+            <a:schemeClr val="bg1">
+              <a:lumMod val="95000"/>
+            </a:schemeClr>
+          </a:solidFill>
+          <a:ln w="12700">
+            <a:solidFill>
+              <a:schemeClr val="tx2">
+                <a:lumMod val="75000"/>
+                <a:lumOff val="25000"/>
+              </a:schemeClr>
+            </a:solidFill>
+            <a:prstDash val="sysDash"/>
+          </a:ln>
+        </p:spPr>
+        <p:style>
+          <a:lnRef idx="2">
+            <a:schemeClr val="accent1">
+              <a:shade val="15000"/>
+            </a:schemeClr>
+          </a:lnRef>
+          <a:fillRef idx="1">
+            <a:schemeClr val="accent1"/>
+          </a:fillRef>
+          <a:effectRef idx="0">
+            <a:schemeClr val="accent1"/>
+          </a:effectRef>
+          <a:fontRef idx="minor">
+            <a:schemeClr val="lt1"/>
+          </a:fontRef>
+        </p:style>
+        <p:txBody>
+          <a:bodyPr rtlCol="0" anchor="ctr"/>
+          <a:lstStyle/>
+          <a:p>
+            <a:pPr algn="ctr"/>
+            <a:endParaRPr lang="en-SG" dirty="0"/>
+          </a:p>
+        </p:txBody>
+      </p:sp>
+      <p:sp>
+        <p:nvSpPr>
+          <p:cNvPr id="83" name="Rectangle 82">
+            <a:extLst>
+              <a:ext uri="{FF2B5EF4-FFF2-40B4-BE49-F238E27FC236}">
+                <a16:creationId xmlns:a16="http://schemas.microsoft.com/office/drawing/2014/main" id="{F03E8147-3BE0-220B-3444-5E757F1A54B9}"/>
+              </a:ext>
+            </a:extLst>
+          </p:cNvPr>
+          <p:cNvSpPr/>
+          <p:nvPr/>
+        </p:nvSpPr>
+        <p:spPr>
+          <a:xfrm>
+            <a:off x="779646" y="1905803"/>
+            <a:ext cx="6814687" cy="4379495"/>
+          </a:xfrm>
+          <a:prstGeom prst="rect">
+            <a:avLst/>
+          </a:prstGeom>
+          <a:noFill/>
+          <a:ln>
+            <a:solidFill>
+              <a:schemeClr val="tx2">
+                <a:lumMod val="75000"/>
+                <a:lumOff val="25000"/>
+              </a:schemeClr>
+            </a:solidFill>
+            <a:prstDash val="sysDash"/>
+          </a:ln>
+        </p:spPr>
+        <p:style>
+          <a:lnRef idx="2">
+            <a:schemeClr val="accent1">
+              <a:shade val="15000"/>
+            </a:schemeClr>
+          </a:lnRef>
+          <a:fillRef idx="1">
+            <a:schemeClr val="accent1"/>
+          </a:fillRef>
+          <a:effectRef idx="0">
+            <a:schemeClr val="accent1"/>
+          </a:effectRef>
+          <a:fontRef idx="minor">
+            <a:schemeClr val="lt1"/>
+          </a:fontRef>
+        </p:style>
+        <p:txBody>
+          <a:bodyPr rtlCol="0" anchor="ctr"/>
+          <a:lstStyle/>
+          <a:p>
+            <a:pPr algn="ctr"/>
+            <a:endParaRPr lang="en-SG" dirty="0"/>
+          </a:p>
+        </p:txBody>
+      </p:sp>
+      <p:sp>
+        <p:nvSpPr>
+          <p:cNvPr id="4" name="Rectangle 3">
+            <a:extLst>
+              <a:ext uri="{FF2B5EF4-FFF2-40B4-BE49-F238E27FC236}">
+                <a16:creationId xmlns:a16="http://schemas.microsoft.com/office/drawing/2014/main" id="{B44A7829-84D8-5B0C-218C-7BF8A4AA9919}"/>
+              </a:ext>
+            </a:extLst>
+          </p:cNvPr>
+          <p:cNvSpPr/>
+          <p:nvPr/>
+        </p:nvSpPr>
+        <p:spPr>
+          <a:xfrm>
+            <a:off x="1150799" y="3545341"/>
+            <a:ext cx="2287802" cy="1784089"/>
+          </a:xfrm>
+          <a:prstGeom prst="rect">
+            <a:avLst/>
+          </a:prstGeom>
+          <a:solidFill>
+            <a:schemeClr val="accent6">
+              <a:lumMod val="50000"/>
+            </a:schemeClr>
+          </a:solidFill>
+        </p:spPr>
+        <p:style>
+          <a:lnRef idx="2">
+            <a:schemeClr val="accent1">
+              <a:shade val="15000"/>
+            </a:schemeClr>
+          </a:lnRef>
+          <a:fillRef idx="1">
+            <a:schemeClr val="accent1"/>
+          </a:fillRef>
+          <a:effectRef idx="0">
+            <a:schemeClr val="accent1"/>
+          </a:effectRef>
+          <a:fontRef idx="minor">
+            <a:schemeClr val="lt1"/>
+          </a:fontRef>
+        </p:style>
+        <p:txBody>
+          <a:bodyPr rtlCol="0" anchor="ctr"/>
+          <a:lstStyle/>
+          <a:p>
+            <a:pPr algn="ctr"/>
+            <a:endParaRPr lang="en-SG" dirty="0"/>
+          </a:p>
+        </p:txBody>
+      </p:sp>
+      <p:sp>
+        <p:nvSpPr>
+          <p:cNvPr id="5" name="Rectangle 4">
+            <a:extLst>
+              <a:ext uri="{FF2B5EF4-FFF2-40B4-BE49-F238E27FC236}">
+                <a16:creationId xmlns:a16="http://schemas.microsoft.com/office/drawing/2014/main" id="{35BA73FC-D291-A17F-13B4-1D4897D34D5F}"/>
+              </a:ext>
+            </a:extLst>
+          </p:cNvPr>
+          <p:cNvSpPr/>
+          <p:nvPr/>
+        </p:nvSpPr>
+        <p:spPr>
+          <a:xfrm>
+            <a:off x="1019908" y="2420297"/>
+            <a:ext cx="2945700" cy="3229734"/>
+          </a:xfrm>
+          <a:prstGeom prst="rect">
+            <a:avLst/>
+          </a:prstGeom>
+          <a:noFill/>
+        </p:spPr>
+        <p:style>
+          <a:lnRef idx="2">
+            <a:schemeClr val="accent1">
+              <a:shade val="15000"/>
+            </a:schemeClr>
+          </a:lnRef>
+          <a:fillRef idx="1">
+            <a:schemeClr val="accent1"/>
+          </a:fillRef>
+          <a:effectRef idx="0">
+            <a:schemeClr val="accent1"/>
+          </a:effectRef>
+          <a:fontRef idx="minor">
+            <a:schemeClr val="lt1"/>
+          </a:fontRef>
+        </p:style>
+        <p:txBody>
+          <a:bodyPr rtlCol="0" anchor="ctr"/>
+          <a:lstStyle/>
+          <a:p>
+            <a:pPr algn="ctr"/>
+            <a:endParaRPr lang="en-SG"/>
+          </a:p>
+        </p:txBody>
+      </p:sp>
+      <p:pic>
+        <p:nvPicPr>
+          <p:cNvPr id="6" name="Picture 2" descr="DeepSeek Logo and symbol, meaning ...">
+            <a:extLst>
+              <a:ext uri="{FF2B5EF4-FFF2-40B4-BE49-F238E27FC236}">
+                <a16:creationId xmlns:a16="http://schemas.microsoft.com/office/drawing/2014/main" id="{DF725BB4-E3C8-A65D-7F5E-B16A81FCB532}"/>
+              </a:ext>
+            </a:extLst>
+          </p:cNvPr>
+          <p:cNvPicPr>
+            <a:picLocks noChangeAspect="1" noChangeArrowheads="1"/>
+          </p:cNvPicPr>
+          <p:nvPr/>
+        </p:nvPicPr>
+        <p:blipFill rotWithShape="1">
+          <a:blip r:embed="rId3">
+            <a:extLst>
+              <a:ext uri="{28A0092B-C50C-407E-A947-70E740481C1C}">
+                <a14:useLocalDpi xmlns:a14="http://schemas.microsoft.com/office/drawing/2010/main" val="0"/>
+              </a:ext>
+            </a:extLst>
+          </a:blip>
+          <a:srcRect t="17745" b="19385"/>
+          <a:stretch/>
+        </p:blipFill>
+        <p:spPr bwMode="auto">
+          <a:xfrm>
+            <a:off x="1276207" y="4483129"/>
+            <a:ext cx="1519097" cy="534829"/>
+          </a:xfrm>
+          <a:prstGeom prst="rect">
+            <a:avLst/>
+          </a:prstGeom>
+          <a:noFill/>
+          <a:ln w="19050">
+            <a:solidFill>
+              <a:schemeClr val="tx1"/>
+            </a:solidFill>
+          </a:ln>
+          <a:extLst>
+            <a:ext uri="{909E8E84-426E-40DD-AFC4-6F175D3DCCD1}">
+              <a14:hiddenFill xmlns:a14="http://schemas.microsoft.com/office/drawing/2010/main">
+                <a:solidFill>
+                  <a:srgbClr val="FFFFFF"/>
+                </a:solidFill>
+              </a14:hiddenFill>
+            </a:ext>
+          </a:extLst>
+        </p:spPr>
+      </p:pic>
+      <p:pic>
+        <p:nvPicPr>
+          <p:cNvPr id="7" name="Picture 6" descr="Run DeepSeek-R1 Locally for Free in Just 3 Minutes! - DEV Community">
+            <a:extLst>
+              <a:ext uri="{FF2B5EF4-FFF2-40B4-BE49-F238E27FC236}">
+                <a16:creationId xmlns:a16="http://schemas.microsoft.com/office/drawing/2014/main" id="{F2390E63-6FD5-8CBB-0466-AEB7ACB1E79D}"/>
+              </a:ext>
+            </a:extLst>
+          </p:cNvPr>
+          <p:cNvPicPr>
+            <a:picLocks noChangeAspect="1" noChangeArrowheads="1"/>
+          </p:cNvPicPr>
+          <p:nvPr/>
+        </p:nvPicPr>
+        <p:blipFill>
+          <a:blip r:embed="rId4">
+            <a:extLst>
+              <a:ext uri="{28A0092B-C50C-407E-A947-70E740481C1C}">
+                <a14:useLocalDpi xmlns:a14="http://schemas.microsoft.com/office/drawing/2010/main" val="0"/>
+              </a:ext>
+            </a:extLst>
+          </a:blip>
+          <a:srcRect/>
+          <a:stretch>
+            <a:fillRect/>
+          </a:stretch>
+        </p:blipFill>
+        <p:spPr bwMode="auto">
+          <a:xfrm>
+            <a:off x="1823238" y="2889639"/>
+            <a:ext cx="1378868" cy="514834"/>
+          </a:xfrm>
+          <a:prstGeom prst="rect">
+            <a:avLst/>
+          </a:prstGeom>
+          <a:noFill/>
+          <a:extLst>
+            <a:ext uri="{909E8E84-426E-40DD-AFC4-6F175D3DCCD1}">
+              <a14:hiddenFill xmlns:a14="http://schemas.microsoft.com/office/drawing/2010/main">
+                <a:solidFill>
+                  <a:srgbClr val="FFFFFF"/>
+                </a:solidFill>
+              </a14:hiddenFill>
+            </a:ext>
+          </a:extLst>
+        </p:spPr>
+      </p:pic>
+      <p:sp>
+        <p:nvSpPr>
+          <p:cNvPr id="10" name="TextBox 9">
+            <a:extLst>
+              <a:ext uri="{FF2B5EF4-FFF2-40B4-BE49-F238E27FC236}">
+                <a16:creationId xmlns:a16="http://schemas.microsoft.com/office/drawing/2014/main" id="{32D247C7-CF32-FC81-9C87-E50B35E4B054}"/>
+              </a:ext>
+            </a:extLst>
+          </p:cNvPr>
+          <p:cNvSpPr txBox="1"/>
+          <p:nvPr/>
+        </p:nvSpPr>
+        <p:spPr>
+          <a:xfrm>
+            <a:off x="1180733" y="5035194"/>
+            <a:ext cx="2324388" cy="276999"/>
+          </a:xfrm>
+          <a:prstGeom prst="rect">
+            <a:avLst/>
+          </a:prstGeom>
+          <a:noFill/>
+        </p:spPr>
+        <p:txBody>
+          <a:bodyPr wrap="square">
+            <a:spAutoFit/>
+          </a:bodyPr>
+          <a:lstStyle/>
+          <a:p>
+            <a:r>
+              <a:rPr lang="en-US" sz="1200" b="1" dirty="0">
+                <a:solidFill>
+                  <a:schemeClr val="bg1"/>
+                </a:solidFill>
+              </a:rPr>
+              <a:t>deepseek-r1-tool-calling:14b </a:t>
+            </a:r>
+            <a:endParaRPr lang="en-SG" sz="1200" b="1" dirty="0">
+              <a:solidFill>
+                <a:schemeClr val="bg1"/>
+              </a:solidFill>
+            </a:endParaRPr>
+          </a:p>
+        </p:txBody>
+      </p:sp>
+      <p:pic>
+        <p:nvPicPr>
+          <p:cNvPr id="12" name="Picture 11">
+            <a:extLst>
+              <a:ext uri="{FF2B5EF4-FFF2-40B4-BE49-F238E27FC236}">
+                <a16:creationId xmlns:a16="http://schemas.microsoft.com/office/drawing/2014/main" id="{B884A93D-87C7-98F1-E2A6-FD3D8BBE3BB3}"/>
+              </a:ext>
+            </a:extLst>
+          </p:cNvPr>
+          <p:cNvPicPr>
+            <a:picLocks noChangeAspect="1"/>
+          </p:cNvPicPr>
+          <p:nvPr/>
+        </p:nvPicPr>
+        <p:blipFill>
+          <a:blip r:embed="rId5"/>
+          <a:stretch>
+            <a:fillRect/>
+          </a:stretch>
+        </p:blipFill>
+        <p:spPr>
+          <a:xfrm>
+            <a:off x="1129203" y="2889639"/>
+            <a:ext cx="561512" cy="558025"/>
+          </a:xfrm>
+          <a:prstGeom prst="rect">
+            <a:avLst/>
+          </a:prstGeom>
+        </p:spPr>
+      </p:pic>
+      <p:sp>
+        <p:nvSpPr>
+          <p:cNvPr id="13" name="TextBox 12">
+            <a:extLst>
+              <a:ext uri="{FF2B5EF4-FFF2-40B4-BE49-F238E27FC236}">
+                <a16:creationId xmlns:a16="http://schemas.microsoft.com/office/drawing/2014/main" id="{7F7A13E3-6E9F-51EF-10D3-DAA2F492AE45}"/>
+              </a:ext>
+            </a:extLst>
+          </p:cNvPr>
+          <p:cNvSpPr txBox="1"/>
+          <p:nvPr/>
+        </p:nvSpPr>
+        <p:spPr>
+          <a:xfrm>
+            <a:off x="940303" y="2470400"/>
+            <a:ext cx="3146705" cy="338554"/>
+          </a:xfrm>
+          <a:prstGeom prst="rect">
+            <a:avLst/>
+          </a:prstGeom>
+          <a:noFill/>
+        </p:spPr>
+        <p:txBody>
+          <a:bodyPr wrap="square">
+            <a:spAutoFit/>
+          </a:bodyPr>
+          <a:lstStyle/>
+          <a:p>
+            <a:r>
+              <a:rPr lang="en-US" sz="1600" b="1" dirty="0"/>
+              <a:t>GPU Server or A Gaming Laptop </a:t>
+            </a:r>
+            <a:endParaRPr lang="en-SG" sz="1600" b="1" dirty="0"/>
+          </a:p>
+        </p:txBody>
+      </p:sp>
+      <p:pic>
+        <p:nvPicPr>
+          <p:cNvPr id="15" name="Picture 14">
+            <a:extLst>
+              <a:ext uri="{FF2B5EF4-FFF2-40B4-BE49-F238E27FC236}">
+                <a16:creationId xmlns:a16="http://schemas.microsoft.com/office/drawing/2014/main" id="{982815F1-4867-CC71-F6B1-4CEBAF9AAC7F}"/>
+              </a:ext>
+            </a:extLst>
+          </p:cNvPr>
+          <p:cNvPicPr>
+            <a:picLocks noChangeAspect="1"/>
+          </p:cNvPicPr>
+          <p:nvPr/>
+        </p:nvPicPr>
+        <p:blipFill>
+          <a:blip r:embed="rId6"/>
+          <a:stretch>
+            <a:fillRect/>
+          </a:stretch>
+        </p:blipFill>
+        <p:spPr>
+          <a:xfrm>
+            <a:off x="3826169" y="3688829"/>
+            <a:ext cx="368410" cy="361325"/>
+          </a:xfrm>
+          <a:prstGeom prst="rect">
+            <a:avLst/>
+          </a:prstGeom>
+        </p:spPr>
+      </p:pic>
+      <p:pic>
+        <p:nvPicPr>
+          <p:cNvPr id="19" name="Picture 18">
+            <a:extLst>
+              <a:ext uri="{FF2B5EF4-FFF2-40B4-BE49-F238E27FC236}">
+                <a16:creationId xmlns:a16="http://schemas.microsoft.com/office/drawing/2014/main" id="{7F487A2F-1095-C84D-230D-21A7ECB28647}"/>
+              </a:ext>
+            </a:extLst>
+          </p:cNvPr>
+          <p:cNvPicPr>
+            <a:picLocks noChangeAspect="1"/>
+          </p:cNvPicPr>
+          <p:nvPr/>
+        </p:nvPicPr>
+        <p:blipFill>
+          <a:blip r:embed="rId7"/>
+          <a:stretch>
+            <a:fillRect/>
+          </a:stretch>
+        </p:blipFill>
+        <p:spPr>
+          <a:xfrm>
+            <a:off x="1311027" y="3661588"/>
+            <a:ext cx="1519097" cy="553135"/>
+          </a:xfrm>
+          <a:prstGeom prst="rect">
+            <a:avLst/>
+          </a:prstGeom>
+          <a:ln w="9525">
+            <a:solidFill>
+              <a:schemeClr val="tx1"/>
+            </a:solidFill>
+          </a:ln>
+        </p:spPr>
+      </p:pic>
+      <p:sp>
+        <p:nvSpPr>
+          <p:cNvPr id="20" name="TextBox 19">
+            <a:extLst>
+              <a:ext uri="{FF2B5EF4-FFF2-40B4-BE49-F238E27FC236}">
+                <a16:creationId xmlns:a16="http://schemas.microsoft.com/office/drawing/2014/main" id="{F5FC22F0-43B2-B14F-33E7-298D820DA7FB}"/>
+              </a:ext>
+            </a:extLst>
+          </p:cNvPr>
+          <p:cNvSpPr txBox="1"/>
+          <p:nvPr/>
+        </p:nvSpPr>
+        <p:spPr>
+          <a:xfrm>
+            <a:off x="1210667" y="4236815"/>
+            <a:ext cx="2324388" cy="276999"/>
+          </a:xfrm>
+          <a:prstGeom prst="rect">
+            <a:avLst/>
+          </a:prstGeom>
+          <a:noFill/>
+        </p:spPr>
+        <p:txBody>
+          <a:bodyPr wrap="square">
+            <a:spAutoFit/>
+          </a:bodyPr>
+          <a:lstStyle/>
+          <a:p>
+            <a:r>
+              <a:rPr lang="en-US" sz="1200" b="1" dirty="0">
+                <a:solidFill>
+                  <a:schemeClr val="bg1"/>
+                </a:solidFill>
+              </a:rPr>
+              <a:t>deepseek-r1-tool-calling:14b </a:t>
+            </a:r>
+            <a:endParaRPr lang="en-SG" sz="1200" b="1" dirty="0">
+              <a:solidFill>
+                <a:schemeClr val="bg1"/>
+              </a:solidFill>
+            </a:endParaRPr>
+          </a:p>
+        </p:txBody>
+      </p:sp>
+      <p:sp>
+        <p:nvSpPr>
+          <p:cNvPr id="21" name="TextBox 20">
+            <a:extLst>
+              <a:ext uri="{FF2B5EF4-FFF2-40B4-BE49-F238E27FC236}">
+                <a16:creationId xmlns:a16="http://schemas.microsoft.com/office/drawing/2014/main" id="{6564F2EC-4EB0-9BE7-1F8D-0056A1D90C7D}"/>
+              </a:ext>
+            </a:extLst>
+          </p:cNvPr>
+          <p:cNvSpPr txBox="1"/>
+          <p:nvPr/>
+        </p:nvSpPr>
+        <p:spPr>
+          <a:xfrm>
+            <a:off x="3667572" y="4112395"/>
+            <a:ext cx="821646" cy="307777"/>
+          </a:xfrm>
+          <a:prstGeom prst="rect">
+            <a:avLst/>
+          </a:prstGeom>
+          <a:noFill/>
+        </p:spPr>
+        <p:txBody>
+          <a:bodyPr wrap="square">
+            <a:spAutoFit/>
+          </a:bodyPr>
+          <a:lstStyle/>
+          <a:p>
+            <a:r>
+              <a:rPr lang="en-US" sz="1400" b="1" dirty="0">
+                <a:solidFill>
+                  <a:schemeClr val="accent1"/>
+                </a:solidFill>
+              </a:rPr>
+              <a:t>Port:22</a:t>
+            </a:r>
+            <a:endParaRPr lang="en-SG" sz="1400" b="1" dirty="0">
+              <a:solidFill>
+                <a:schemeClr val="accent1"/>
+              </a:solidFill>
+            </a:endParaRPr>
+          </a:p>
+        </p:txBody>
+      </p:sp>
+      <p:sp>
+        <p:nvSpPr>
+          <p:cNvPr id="29" name="Rectangle 28">
+            <a:extLst>
+              <a:ext uri="{FF2B5EF4-FFF2-40B4-BE49-F238E27FC236}">
+                <a16:creationId xmlns:a16="http://schemas.microsoft.com/office/drawing/2014/main" id="{AC6FCDBD-A95C-8EC9-3C62-CC8CD2A9F5E1}"/>
+              </a:ext>
+            </a:extLst>
+          </p:cNvPr>
+          <p:cNvSpPr/>
+          <p:nvPr/>
+        </p:nvSpPr>
+        <p:spPr>
+          <a:xfrm>
+            <a:off x="3301465" y="4658629"/>
+            <a:ext cx="262544" cy="276999"/>
+          </a:xfrm>
+          <a:prstGeom prst="rect">
+            <a:avLst/>
+          </a:prstGeom>
+          <a:solidFill>
+            <a:srgbClr val="FFC000"/>
+          </a:solidFill>
+        </p:spPr>
+        <p:style>
+          <a:lnRef idx="2">
+            <a:schemeClr val="accent1">
+              <a:shade val="15000"/>
+            </a:schemeClr>
+          </a:lnRef>
+          <a:fillRef idx="1">
+            <a:schemeClr val="accent1"/>
+          </a:fillRef>
+          <a:effectRef idx="0">
+            <a:schemeClr val="accent1"/>
+          </a:effectRef>
+          <a:fontRef idx="minor">
+            <a:schemeClr val="lt1"/>
+          </a:fontRef>
+        </p:style>
+        <p:txBody>
+          <a:bodyPr rtlCol="0" anchor="ctr"/>
+          <a:lstStyle/>
+          <a:p>
+            <a:pPr algn="ctr"/>
+            <a:endParaRPr lang="en-SG"/>
+          </a:p>
+        </p:txBody>
+      </p:sp>
+      <p:cxnSp>
+        <p:nvCxnSpPr>
+          <p:cNvPr id="31" name="Connector: Elbow 30">
+            <a:extLst>
+              <a:ext uri="{FF2B5EF4-FFF2-40B4-BE49-F238E27FC236}">
+                <a16:creationId xmlns:a16="http://schemas.microsoft.com/office/drawing/2014/main" id="{5DE732F0-B60D-032C-A2ED-4FD22B6C7CF1}"/>
+              </a:ext>
+            </a:extLst>
+          </p:cNvPr>
+          <p:cNvCxnSpPr>
+            <a:stCxn id="29" idx="3"/>
+            <a:endCxn id="15" idx="1"/>
+          </p:cNvCxnSpPr>
+          <p:nvPr/>
+        </p:nvCxnSpPr>
+        <p:spPr>
+          <a:xfrm flipV="1">
+            <a:off x="3564009" y="3869492"/>
+            <a:ext cx="262160" cy="927637"/>
+          </a:xfrm>
+          <a:prstGeom prst="bentConnector3">
+            <a:avLst/>
+          </a:prstGeom>
+          <a:ln>
+            <a:tailEnd type="triangle"/>
+          </a:ln>
+        </p:spPr>
+        <p:style>
+          <a:lnRef idx="2">
+            <a:schemeClr val="accent1"/>
+          </a:lnRef>
+          <a:fillRef idx="0">
+            <a:schemeClr val="accent1"/>
+          </a:fillRef>
+          <a:effectRef idx="1">
+            <a:schemeClr val="accent1"/>
+          </a:effectRef>
+          <a:fontRef idx="minor">
+            <a:schemeClr val="tx1"/>
+          </a:fontRef>
+        </p:style>
+      </p:cxnSp>
+      <p:sp>
+        <p:nvSpPr>
+          <p:cNvPr id="32" name="TextBox 31">
+            <a:extLst>
+              <a:ext uri="{FF2B5EF4-FFF2-40B4-BE49-F238E27FC236}">
+                <a16:creationId xmlns:a16="http://schemas.microsoft.com/office/drawing/2014/main" id="{18DF315D-46A7-D4B3-1FCA-3AA50E24FFFB}"/>
+              </a:ext>
+            </a:extLst>
+          </p:cNvPr>
+          <p:cNvSpPr txBox="1"/>
+          <p:nvPr/>
+        </p:nvSpPr>
+        <p:spPr>
+          <a:xfrm>
+            <a:off x="1480244" y="5357284"/>
+            <a:ext cx="2699759" cy="307777"/>
+          </a:xfrm>
+          <a:prstGeom prst="rect">
+            <a:avLst/>
+          </a:prstGeom>
+          <a:noFill/>
+        </p:spPr>
+        <p:txBody>
+          <a:bodyPr wrap="square">
+            <a:spAutoFit/>
+          </a:bodyPr>
+          <a:lstStyle/>
+          <a:p>
+            <a:r>
+              <a:rPr lang="en-SG" sz="1400" b="1" dirty="0"/>
+              <a:t>Ollama localhost port 11434 </a:t>
+            </a:r>
+          </a:p>
+        </p:txBody>
+      </p:sp>
+      <p:cxnSp>
+        <p:nvCxnSpPr>
+          <p:cNvPr id="34" name="Straight Arrow Connector 33">
+            <a:extLst>
+              <a:ext uri="{FF2B5EF4-FFF2-40B4-BE49-F238E27FC236}">
+                <a16:creationId xmlns:a16="http://schemas.microsoft.com/office/drawing/2014/main" id="{FC0F353C-1AC5-1750-F4C8-89C797261944}"/>
+              </a:ext>
+            </a:extLst>
+          </p:cNvPr>
+          <p:cNvCxnSpPr/>
+          <p:nvPr/>
+        </p:nvCxnSpPr>
+        <p:spPr>
+          <a:xfrm flipV="1">
+            <a:off x="3564009" y="5035194"/>
+            <a:ext cx="0" cy="322090"/>
+          </a:xfrm>
+          <a:prstGeom prst="straightConnector1">
+            <a:avLst/>
+          </a:prstGeom>
+          <a:ln>
+            <a:tailEnd type="triangle"/>
+          </a:ln>
+        </p:spPr>
+        <p:style>
+          <a:lnRef idx="2">
+            <a:schemeClr val="accent1"/>
+          </a:lnRef>
+          <a:fillRef idx="0">
+            <a:schemeClr val="accent1"/>
+          </a:fillRef>
+          <a:effectRef idx="1">
+            <a:schemeClr val="accent1"/>
+          </a:effectRef>
+          <a:fontRef idx="minor">
+            <a:schemeClr val="tx1"/>
+          </a:fontRef>
+        </p:style>
+      </p:cxnSp>
+      <p:cxnSp>
+        <p:nvCxnSpPr>
+          <p:cNvPr id="36" name="Straight Connector 35">
+            <a:extLst>
+              <a:ext uri="{FF2B5EF4-FFF2-40B4-BE49-F238E27FC236}">
+                <a16:creationId xmlns:a16="http://schemas.microsoft.com/office/drawing/2014/main" id="{C4DF2FE5-0ABA-CC5F-1CB4-2CDC638D082E}"/>
+              </a:ext>
+            </a:extLst>
+          </p:cNvPr>
+          <p:cNvCxnSpPr>
+            <a:stCxn id="15" idx="3"/>
+          </p:cNvCxnSpPr>
+          <p:nvPr/>
+        </p:nvCxnSpPr>
+        <p:spPr>
+          <a:xfrm flipV="1">
+            <a:off x="4194579" y="3869491"/>
+            <a:ext cx="945312" cy="1"/>
+          </a:xfrm>
+          <a:prstGeom prst="line">
+            <a:avLst/>
+          </a:prstGeom>
+        </p:spPr>
+        <p:style>
+          <a:lnRef idx="2">
+            <a:schemeClr val="accent1"/>
+          </a:lnRef>
+          <a:fillRef idx="0">
+            <a:schemeClr val="accent1"/>
+          </a:fillRef>
+          <a:effectRef idx="1">
+            <a:schemeClr val="accent1"/>
+          </a:effectRef>
+          <a:fontRef idx="minor">
+            <a:schemeClr val="tx1"/>
+          </a:fontRef>
+        </p:style>
+      </p:cxnSp>
+      <p:pic>
+        <p:nvPicPr>
+          <p:cNvPr id="38" name="Picture 37">
+            <a:extLst>
+              <a:ext uri="{FF2B5EF4-FFF2-40B4-BE49-F238E27FC236}">
+                <a16:creationId xmlns:a16="http://schemas.microsoft.com/office/drawing/2014/main" id="{9E5D3FB8-103A-6097-DAE0-E51BC2E861ED}"/>
+              </a:ext>
+            </a:extLst>
+          </p:cNvPr>
+          <p:cNvPicPr>
+            <a:picLocks noChangeAspect="1"/>
+          </p:cNvPicPr>
+          <p:nvPr/>
+        </p:nvPicPr>
+        <p:blipFill>
+          <a:blip r:embed="rId8"/>
+          <a:stretch>
+            <a:fillRect/>
+          </a:stretch>
+        </p:blipFill>
+        <p:spPr>
+          <a:xfrm>
+            <a:off x="5139891" y="3604068"/>
+            <a:ext cx="890533" cy="751231"/>
+          </a:xfrm>
+          <a:prstGeom prst="rect">
+            <a:avLst/>
+          </a:prstGeom>
+          <a:ln w="19050">
+            <a:solidFill>
+              <a:schemeClr val="tx1"/>
+            </a:solidFill>
+          </a:ln>
+        </p:spPr>
+      </p:pic>
+      <p:sp>
+        <p:nvSpPr>
+          <p:cNvPr id="39" name="TextBox 38">
+            <a:extLst>
+              <a:ext uri="{FF2B5EF4-FFF2-40B4-BE49-F238E27FC236}">
+                <a16:creationId xmlns:a16="http://schemas.microsoft.com/office/drawing/2014/main" id="{AE0EAF55-07BD-1E37-EB6F-2AD86D1EB1BC}"/>
+              </a:ext>
+            </a:extLst>
+          </p:cNvPr>
+          <p:cNvSpPr txBox="1"/>
+          <p:nvPr/>
+        </p:nvSpPr>
+        <p:spPr>
+          <a:xfrm>
+            <a:off x="4362538" y="3296445"/>
+            <a:ext cx="1667886" cy="523220"/>
+          </a:xfrm>
+          <a:prstGeom prst="rect">
+            <a:avLst/>
+          </a:prstGeom>
+          <a:noFill/>
+        </p:spPr>
+        <p:txBody>
+          <a:bodyPr wrap="square">
+            <a:spAutoFit/>
+          </a:bodyPr>
+          <a:lstStyle/>
+          <a:p>
+            <a:r>
+              <a:rPr lang="en-SG" sz="1400" b="1" dirty="0"/>
+              <a:t>Ethernet Router or Switch </a:t>
+            </a:r>
+          </a:p>
+        </p:txBody>
+      </p:sp>
+      <p:sp>
+        <p:nvSpPr>
+          <p:cNvPr id="40" name="Rectangle 39">
+            <a:extLst>
+              <a:ext uri="{FF2B5EF4-FFF2-40B4-BE49-F238E27FC236}">
+                <a16:creationId xmlns:a16="http://schemas.microsoft.com/office/drawing/2014/main" id="{AF97F865-09D6-0C19-7BA4-E36B60A788F9}"/>
+              </a:ext>
+            </a:extLst>
+          </p:cNvPr>
+          <p:cNvSpPr/>
+          <p:nvPr/>
+        </p:nvSpPr>
+        <p:spPr>
+          <a:xfrm>
+            <a:off x="5139891" y="4797129"/>
+            <a:ext cx="1940574" cy="1353415"/>
+          </a:xfrm>
+          <a:prstGeom prst="rect">
+            <a:avLst/>
+          </a:prstGeom>
+          <a:noFill/>
+        </p:spPr>
+        <p:style>
+          <a:lnRef idx="2">
+            <a:schemeClr val="accent1">
+              <a:shade val="15000"/>
+            </a:schemeClr>
+          </a:lnRef>
+          <a:fillRef idx="1">
+            <a:schemeClr val="accent1"/>
+          </a:fillRef>
+          <a:effectRef idx="0">
+            <a:schemeClr val="accent1"/>
+          </a:effectRef>
+          <a:fontRef idx="minor">
+            <a:schemeClr val="lt1"/>
+          </a:fontRef>
+        </p:style>
+        <p:txBody>
+          <a:bodyPr rtlCol="0" anchor="ctr"/>
+          <a:lstStyle/>
+          <a:p>
+            <a:pPr algn="ctr"/>
+            <a:endParaRPr lang="en-SG"/>
+          </a:p>
+        </p:txBody>
+      </p:sp>
+      <p:sp>
+        <p:nvSpPr>
+          <p:cNvPr id="41" name="TextBox 40">
+            <a:extLst>
+              <a:ext uri="{FF2B5EF4-FFF2-40B4-BE49-F238E27FC236}">
+                <a16:creationId xmlns:a16="http://schemas.microsoft.com/office/drawing/2014/main" id="{F6E435CA-8804-DE04-DA09-5AFD4B64D511}"/>
+              </a:ext>
+            </a:extLst>
+          </p:cNvPr>
+          <p:cNvSpPr txBox="1"/>
+          <p:nvPr/>
+        </p:nvSpPr>
+        <p:spPr>
+          <a:xfrm>
+            <a:off x="5722011" y="4378743"/>
+            <a:ext cx="1872322" cy="461665"/>
+          </a:xfrm>
+          <a:prstGeom prst="rect">
+            <a:avLst/>
+          </a:prstGeom>
+          <a:noFill/>
+        </p:spPr>
+        <p:txBody>
+          <a:bodyPr wrap="square">
+            <a:spAutoFit/>
+          </a:bodyPr>
+          <a:lstStyle/>
+          <a:p>
+            <a:r>
+              <a:rPr lang="en-SG" sz="1200" b="1" dirty="0"/>
+              <a:t>Internal network User’s compute server </a:t>
+            </a:r>
+          </a:p>
+        </p:txBody>
+      </p:sp>
+      <p:pic>
+        <p:nvPicPr>
+          <p:cNvPr id="43" name="Picture 42">
+            <a:extLst>
+              <a:ext uri="{FF2B5EF4-FFF2-40B4-BE49-F238E27FC236}">
+                <a16:creationId xmlns:a16="http://schemas.microsoft.com/office/drawing/2014/main" id="{7FF71989-D230-6671-91DB-F31B5B121BEB}"/>
+              </a:ext>
+            </a:extLst>
+          </p:cNvPr>
+          <p:cNvPicPr>
+            <a:picLocks noChangeAspect="1"/>
+          </p:cNvPicPr>
+          <p:nvPr/>
+        </p:nvPicPr>
+        <p:blipFill>
+          <a:blip r:embed="rId9"/>
+          <a:stretch>
+            <a:fillRect/>
+          </a:stretch>
+        </p:blipFill>
+        <p:spPr>
+          <a:xfrm>
+            <a:off x="5216739" y="5256758"/>
+            <a:ext cx="1332727" cy="616954"/>
+          </a:xfrm>
+          <a:prstGeom prst="rect">
+            <a:avLst/>
+          </a:prstGeom>
+        </p:spPr>
+      </p:pic>
+      <p:pic>
+        <p:nvPicPr>
+          <p:cNvPr id="44" name="Picture 43">
+            <a:extLst>
+              <a:ext uri="{FF2B5EF4-FFF2-40B4-BE49-F238E27FC236}">
+                <a16:creationId xmlns:a16="http://schemas.microsoft.com/office/drawing/2014/main" id="{F1682F51-2308-45AA-FBE0-44CC05CA3268}"/>
+              </a:ext>
+            </a:extLst>
+          </p:cNvPr>
+          <p:cNvPicPr>
+            <a:picLocks noChangeAspect="1"/>
+          </p:cNvPicPr>
+          <p:nvPr/>
+        </p:nvPicPr>
+        <p:blipFill>
+          <a:blip r:embed="rId6"/>
+          <a:stretch>
+            <a:fillRect/>
+          </a:stretch>
+        </p:blipFill>
+        <p:spPr>
+          <a:xfrm>
+            <a:off x="5416289" y="4725396"/>
+            <a:ext cx="345194" cy="338555"/>
+          </a:xfrm>
+          <a:prstGeom prst="rect">
+            <a:avLst/>
+          </a:prstGeom>
+        </p:spPr>
+      </p:pic>
+      <p:cxnSp>
+        <p:nvCxnSpPr>
+          <p:cNvPr id="45" name="Straight Arrow Connector 44">
+            <a:extLst>
+              <a:ext uri="{FF2B5EF4-FFF2-40B4-BE49-F238E27FC236}">
+                <a16:creationId xmlns:a16="http://schemas.microsoft.com/office/drawing/2014/main" id="{365404C3-2D15-8304-69F1-5159DAA529C3}"/>
+              </a:ext>
+            </a:extLst>
+          </p:cNvPr>
+          <p:cNvCxnSpPr>
+            <a:cxnSpLocks/>
+            <a:stCxn id="38" idx="2"/>
+            <a:endCxn id="44" idx="0"/>
+          </p:cNvCxnSpPr>
+          <p:nvPr/>
+        </p:nvCxnSpPr>
+        <p:spPr>
+          <a:xfrm>
+            <a:off x="5585158" y="4355299"/>
+            <a:ext cx="3728" cy="370097"/>
+          </a:xfrm>
+          <a:prstGeom prst="straightConnector1">
+            <a:avLst/>
+          </a:prstGeom>
+          <a:ln>
+            <a:tailEnd type="triangle"/>
+          </a:ln>
+        </p:spPr>
+        <p:style>
+          <a:lnRef idx="2">
+            <a:schemeClr val="accent1"/>
+          </a:lnRef>
+          <a:fillRef idx="0">
+            <a:schemeClr val="accent1"/>
+          </a:fillRef>
+          <a:effectRef idx="1">
+            <a:schemeClr val="accent1"/>
+          </a:effectRef>
+          <a:fontRef idx="minor">
+            <a:schemeClr val="tx1"/>
+          </a:fontRef>
+        </p:style>
+      </p:cxnSp>
+      <p:cxnSp>
+        <p:nvCxnSpPr>
+          <p:cNvPr id="49" name="Connector: Elbow 48">
+            <a:extLst>
+              <a:ext uri="{FF2B5EF4-FFF2-40B4-BE49-F238E27FC236}">
+                <a16:creationId xmlns:a16="http://schemas.microsoft.com/office/drawing/2014/main" id="{A5FA3F58-8862-561B-1BBF-B48161C85FA3}"/>
+              </a:ext>
+            </a:extLst>
+          </p:cNvPr>
+          <p:cNvCxnSpPr>
+            <a:cxnSpLocks/>
+            <a:stCxn id="44" idx="3"/>
+            <a:endCxn id="43" idx="3"/>
+          </p:cNvCxnSpPr>
+          <p:nvPr/>
+        </p:nvCxnSpPr>
+        <p:spPr>
+          <a:xfrm>
+            <a:off x="5761483" y="4894674"/>
+            <a:ext cx="787983" cy="670561"/>
+          </a:xfrm>
+          <a:prstGeom prst="bentConnector3">
+            <a:avLst>
+              <a:gd name="adj1" fmla="val 129011"/>
+            </a:avLst>
+          </a:prstGeom>
+          <a:ln>
+            <a:tailEnd type="triangle"/>
+          </a:ln>
+        </p:spPr>
+        <p:style>
+          <a:lnRef idx="2">
+            <a:schemeClr val="accent1"/>
+          </a:lnRef>
+          <a:fillRef idx="0">
+            <a:schemeClr val="accent1"/>
+          </a:fillRef>
+          <a:effectRef idx="1">
+            <a:schemeClr val="accent1"/>
+          </a:effectRef>
+          <a:fontRef idx="minor">
+            <a:schemeClr val="tx1"/>
+          </a:fontRef>
+        </p:style>
+      </p:cxnSp>
+      <p:sp>
+        <p:nvSpPr>
+          <p:cNvPr id="54" name="TextBox 53">
+            <a:extLst>
+              <a:ext uri="{FF2B5EF4-FFF2-40B4-BE49-F238E27FC236}">
+                <a16:creationId xmlns:a16="http://schemas.microsoft.com/office/drawing/2014/main" id="{19AB6878-CA4D-AF2F-C3DD-FE6BFB067412}"/>
+              </a:ext>
+            </a:extLst>
+          </p:cNvPr>
+          <p:cNvSpPr txBox="1"/>
+          <p:nvPr/>
+        </p:nvSpPr>
+        <p:spPr>
+          <a:xfrm>
+            <a:off x="5741782" y="4871962"/>
+            <a:ext cx="1377473" cy="430887"/>
+          </a:xfrm>
+          <a:prstGeom prst="rect">
+            <a:avLst/>
+          </a:prstGeom>
+          <a:noFill/>
+        </p:spPr>
+        <p:txBody>
+          <a:bodyPr wrap="square">
+            <a:spAutoFit/>
+          </a:bodyPr>
+          <a:lstStyle/>
+          <a:p>
+            <a:r>
+              <a:rPr lang="en-SG" sz="1100" b="1" dirty="0"/>
+              <a:t>Forward port 11434 to localhost </a:t>
+            </a:r>
+          </a:p>
+        </p:txBody>
+      </p:sp>
+      <p:sp>
+        <p:nvSpPr>
+          <p:cNvPr id="55" name="TextBox 54">
+            <a:extLst>
+              <a:ext uri="{FF2B5EF4-FFF2-40B4-BE49-F238E27FC236}">
+                <a16:creationId xmlns:a16="http://schemas.microsoft.com/office/drawing/2014/main" id="{3E8A96E2-D765-2637-98A8-302E080CD617}"/>
+              </a:ext>
+            </a:extLst>
+          </p:cNvPr>
+          <p:cNvSpPr txBox="1"/>
+          <p:nvPr/>
+        </p:nvSpPr>
+        <p:spPr>
+          <a:xfrm>
+            <a:off x="5139891" y="5858240"/>
+            <a:ext cx="1601444" cy="307777"/>
+          </a:xfrm>
+          <a:prstGeom prst="rect">
+            <a:avLst/>
+          </a:prstGeom>
+          <a:noFill/>
+        </p:spPr>
+        <p:txBody>
+          <a:bodyPr wrap="square">
+            <a:spAutoFit/>
+          </a:bodyPr>
+          <a:lstStyle/>
+          <a:p>
+            <a:r>
+              <a:rPr lang="en-SG" sz="1400" b="1" dirty="0" err="1"/>
+              <a:t>OpenClaw</a:t>
+            </a:r>
+            <a:r>
+              <a:rPr lang="en-SG" sz="1400" b="1" dirty="0"/>
+              <a:t> Agent</a:t>
+            </a:r>
+          </a:p>
+        </p:txBody>
+      </p:sp>
+      <p:sp>
+        <p:nvSpPr>
+          <p:cNvPr id="58" name="Rectangle 57">
+            <a:extLst>
+              <a:ext uri="{FF2B5EF4-FFF2-40B4-BE49-F238E27FC236}">
+                <a16:creationId xmlns:a16="http://schemas.microsoft.com/office/drawing/2014/main" id="{8B6AFD3E-6734-A971-DEDB-5E9A8B3533ED}"/>
+              </a:ext>
+            </a:extLst>
+          </p:cNvPr>
+          <p:cNvSpPr/>
+          <p:nvPr/>
+        </p:nvSpPr>
+        <p:spPr>
+          <a:xfrm>
+            <a:off x="7053085" y="3604068"/>
+            <a:ext cx="1193778" cy="746531"/>
+          </a:xfrm>
+          <a:prstGeom prst="rect">
+            <a:avLst/>
+          </a:prstGeom>
+          <a:solidFill>
+            <a:schemeClr val="bg1"/>
+          </a:solidFill>
+        </p:spPr>
+        <p:style>
+          <a:lnRef idx="2">
+            <a:schemeClr val="accent1">
+              <a:shade val="15000"/>
+            </a:schemeClr>
+          </a:lnRef>
+          <a:fillRef idx="1">
+            <a:schemeClr val="accent1"/>
+          </a:fillRef>
+          <a:effectRef idx="0">
+            <a:schemeClr val="accent1"/>
+          </a:effectRef>
+          <a:fontRef idx="minor">
+            <a:schemeClr val="lt1"/>
+          </a:fontRef>
+        </p:style>
+        <p:txBody>
+          <a:bodyPr rtlCol="0" anchor="ctr"/>
+          <a:lstStyle/>
+          <a:p>
+            <a:pPr algn="ctr"/>
+            <a:endParaRPr lang="en-SG"/>
+          </a:p>
+        </p:txBody>
+      </p:sp>
+      <p:pic>
+        <p:nvPicPr>
+          <p:cNvPr id="59" name="Picture 58">
+            <a:extLst>
+              <a:ext uri="{FF2B5EF4-FFF2-40B4-BE49-F238E27FC236}">
+                <a16:creationId xmlns:a16="http://schemas.microsoft.com/office/drawing/2014/main" id="{C9D8A6B3-2666-385A-770A-709C209B04BB}"/>
+              </a:ext>
+            </a:extLst>
+          </p:cNvPr>
+          <p:cNvPicPr>
+            <a:picLocks noChangeAspect="1"/>
+          </p:cNvPicPr>
+          <p:nvPr/>
+        </p:nvPicPr>
+        <p:blipFill>
+          <a:blip r:embed="rId6"/>
+          <a:stretch>
+            <a:fillRect/>
+          </a:stretch>
+        </p:blipFill>
+        <p:spPr>
+          <a:xfrm>
+            <a:off x="6858186" y="3768771"/>
+            <a:ext cx="368410" cy="361325"/>
+          </a:xfrm>
+          <a:prstGeom prst="rect">
+            <a:avLst/>
+          </a:prstGeom>
+        </p:spPr>
+      </p:pic>
+      <p:pic>
+        <p:nvPicPr>
+          <p:cNvPr id="60" name="Picture 59">
+            <a:extLst>
+              <a:ext uri="{FF2B5EF4-FFF2-40B4-BE49-F238E27FC236}">
+                <a16:creationId xmlns:a16="http://schemas.microsoft.com/office/drawing/2014/main" id="{921E2381-7BDD-6C72-5C2A-A79A0C021D9D}"/>
+              </a:ext>
+            </a:extLst>
+          </p:cNvPr>
+          <p:cNvPicPr>
+            <a:picLocks noChangeAspect="1"/>
+          </p:cNvPicPr>
+          <p:nvPr/>
+        </p:nvPicPr>
+        <p:blipFill>
+          <a:blip r:embed="rId6"/>
+          <a:stretch>
+            <a:fillRect/>
+          </a:stretch>
+        </p:blipFill>
+        <p:spPr>
+          <a:xfrm>
+            <a:off x="8090626" y="3757492"/>
+            <a:ext cx="368410" cy="361325"/>
+          </a:xfrm>
+          <a:prstGeom prst="rect">
+            <a:avLst/>
+          </a:prstGeom>
+        </p:spPr>
+      </p:pic>
+      <p:cxnSp>
+        <p:nvCxnSpPr>
+          <p:cNvPr id="61" name="Straight Connector 60">
+            <a:extLst>
+              <a:ext uri="{FF2B5EF4-FFF2-40B4-BE49-F238E27FC236}">
+                <a16:creationId xmlns:a16="http://schemas.microsoft.com/office/drawing/2014/main" id="{72EA6757-8B06-8859-14CC-0D074E503E01}"/>
+              </a:ext>
+            </a:extLst>
+          </p:cNvPr>
+          <p:cNvCxnSpPr>
+            <a:cxnSpLocks/>
+            <a:stCxn id="38" idx="3"/>
+            <a:endCxn id="59" idx="1"/>
+          </p:cNvCxnSpPr>
+          <p:nvPr/>
+        </p:nvCxnSpPr>
+        <p:spPr>
+          <a:xfrm flipV="1">
+            <a:off x="6030424" y="3949434"/>
+            <a:ext cx="827762" cy="0"/>
+          </a:xfrm>
+          <a:prstGeom prst="line">
+            <a:avLst/>
+          </a:prstGeom>
+        </p:spPr>
+        <p:style>
+          <a:lnRef idx="2">
+            <a:schemeClr val="accent1"/>
+          </a:lnRef>
+          <a:fillRef idx="0">
+            <a:schemeClr val="accent1"/>
+          </a:fillRef>
+          <a:effectRef idx="1">
+            <a:schemeClr val="accent1"/>
+          </a:effectRef>
+          <a:fontRef idx="minor">
+            <a:schemeClr val="tx1"/>
+          </a:fontRef>
+        </p:style>
+      </p:cxnSp>
+      <p:sp>
+        <p:nvSpPr>
+          <p:cNvPr id="64" name="TextBox 63">
+            <a:extLst>
+              <a:ext uri="{FF2B5EF4-FFF2-40B4-BE49-F238E27FC236}">
+                <a16:creationId xmlns:a16="http://schemas.microsoft.com/office/drawing/2014/main" id="{3747CADA-3DE1-A178-CBCF-1C854EB266DB}"/>
+              </a:ext>
+            </a:extLst>
+          </p:cNvPr>
+          <p:cNvSpPr txBox="1"/>
+          <p:nvPr/>
+        </p:nvSpPr>
+        <p:spPr>
+          <a:xfrm>
+            <a:off x="7100279" y="2900141"/>
+            <a:ext cx="1145929" cy="738664"/>
+          </a:xfrm>
+          <a:prstGeom prst="rect">
+            <a:avLst/>
+          </a:prstGeom>
+          <a:noFill/>
+        </p:spPr>
+        <p:txBody>
+          <a:bodyPr wrap="square">
+            <a:spAutoFit/>
+          </a:bodyPr>
+          <a:lstStyle/>
+          <a:p>
+            <a:r>
+              <a:rPr lang="en-SG" sz="1400" b="1" dirty="0"/>
+              <a:t>Gateway or Jump host or firewall</a:t>
+            </a:r>
+          </a:p>
+        </p:txBody>
+      </p:sp>
+      <p:pic>
+        <p:nvPicPr>
+          <p:cNvPr id="68" name="Graphic 67" descr="Server with solid fill">
+            <a:extLst>
+              <a:ext uri="{FF2B5EF4-FFF2-40B4-BE49-F238E27FC236}">
+                <a16:creationId xmlns:a16="http://schemas.microsoft.com/office/drawing/2014/main" id="{C95E7E4E-3CBD-739A-DAD4-DD60DB6085A6}"/>
+              </a:ext>
+            </a:extLst>
+          </p:cNvPr>
+          <p:cNvPicPr>
+            <a:picLocks noChangeAspect="1"/>
+          </p:cNvPicPr>
+          <p:nvPr/>
+        </p:nvPicPr>
+        <p:blipFill>
+          <a:blip r:embed="rId10">
+            <a:extLst>
+              <a:ext uri="{96DAC541-7B7A-43D3-8B79-37D633B846F1}">
+                <asvg:svgBlip xmlns:asvg="http://schemas.microsoft.com/office/drawing/2016/SVG/main" r:embed="rId11"/>
+              </a:ext>
+            </a:extLst>
+          </a:blip>
+          <a:stretch>
+            <a:fillRect/>
+          </a:stretch>
+        </p:blipFill>
+        <p:spPr>
+          <a:xfrm>
+            <a:off x="7357629" y="3728185"/>
+            <a:ext cx="538098" cy="538098"/>
+          </a:xfrm>
+          <a:prstGeom prst="rect">
+            <a:avLst/>
+          </a:prstGeom>
+        </p:spPr>
+      </p:pic>
+      <p:pic>
+        <p:nvPicPr>
+          <p:cNvPr id="70" name="Graphic 69" descr="Laptop with solid fill">
+            <a:extLst>
+              <a:ext uri="{FF2B5EF4-FFF2-40B4-BE49-F238E27FC236}">
+                <a16:creationId xmlns:a16="http://schemas.microsoft.com/office/drawing/2014/main" id="{4F984744-80DA-3142-869A-B35F20F7A0AE}"/>
+              </a:ext>
+            </a:extLst>
+          </p:cNvPr>
+          <p:cNvPicPr>
+            <a:picLocks noChangeAspect="1"/>
+          </p:cNvPicPr>
+          <p:nvPr/>
+        </p:nvPicPr>
+        <p:blipFill>
+          <a:blip r:embed="rId12">
+            <a:extLst>
+              <a:ext uri="{96DAC541-7B7A-43D3-8B79-37D633B846F1}">
+                <asvg:svgBlip xmlns:asvg="http://schemas.microsoft.com/office/drawing/2016/SVG/main" r:embed="rId13"/>
+              </a:ext>
+            </a:extLst>
+          </a:blip>
+          <a:stretch>
+            <a:fillRect/>
+          </a:stretch>
+        </p:blipFill>
+        <p:spPr>
+          <a:xfrm>
+            <a:off x="5416289" y="2021561"/>
+            <a:ext cx="1435131" cy="1435131"/>
+          </a:xfrm>
+          <a:prstGeom prst="rect">
+            <a:avLst/>
+          </a:prstGeom>
+        </p:spPr>
+      </p:pic>
+      <p:pic>
+        <p:nvPicPr>
+          <p:cNvPr id="71" name="Picture 70">
+            <a:extLst>
+              <a:ext uri="{FF2B5EF4-FFF2-40B4-BE49-F238E27FC236}">
+                <a16:creationId xmlns:a16="http://schemas.microsoft.com/office/drawing/2014/main" id="{04F0F3FB-33FE-6E39-67CD-542393FA1C10}"/>
+              </a:ext>
+            </a:extLst>
+          </p:cNvPr>
+          <p:cNvPicPr>
+            <a:picLocks noChangeAspect="1"/>
+          </p:cNvPicPr>
+          <p:nvPr/>
+        </p:nvPicPr>
+        <p:blipFill>
+          <a:blip r:embed="rId9"/>
+          <a:stretch>
+            <a:fillRect/>
+          </a:stretch>
+        </p:blipFill>
+        <p:spPr>
+          <a:xfrm>
+            <a:off x="5757755" y="2514824"/>
+            <a:ext cx="734007" cy="339791"/>
+          </a:xfrm>
+          <a:prstGeom prst="rect">
+            <a:avLst/>
+          </a:prstGeom>
+        </p:spPr>
+      </p:pic>
+      <p:sp>
+        <p:nvSpPr>
+          <p:cNvPr id="72" name="TextBox 71">
+            <a:extLst>
+              <a:ext uri="{FF2B5EF4-FFF2-40B4-BE49-F238E27FC236}">
+                <a16:creationId xmlns:a16="http://schemas.microsoft.com/office/drawing/2014/main" id="{56943F51-D99F-92C3-0850-9105054F5C25}"/>
+              </a:ext>
+            </a:extLst>
+          </p:cNvPr>
+          <p:cNvSpPr txBox="1"/>
+          <p:nvPr/>
+        </p:nvSpPr>
+        <p:spPr>
+          <a:xfrm>
+            <a:off x="5139891" y="1899347"/>
+            <a:ext cx="2378797" cy="461665"/>
+          </a:xfrm>
+          <a:prstGeom prst="rect">
+            <a:avLst/>
+          </a:prstGeom>
+          <a:noFill/>
+        </p:spPr>
+        <p:txBody>
+          <a:bodyPr wrap="square">
+            <a:spAutoFit/>
+          </a:bodyPr>
+          <a:lstStyle/>
+          <a:p>
+            <a:r>
+              <a:rPr lang="en-SG" sz="1200" b="1" dirty="0"/>
+              <a:t>Internal Network User’s working Laptop with </a:t>
+            </a:r>
+            <a:r>
+              <a:rPr lang="en-SG" sz="1200" b="1" dirty="0" err="1"/>
+              <a:t>OpenClaw</a:t>
+            </a:r>
+            <a:r>
+              <a:rPr lang="en-SG" sz="1200" b="1" dirty="0"/>
+              <a:t> </a:t>
+            </a:r>
+          </a:p>
+        </p:txBody>
+      </p:sp>
+      <p:pic>
+        <p:nvPicPr>
+          <p:cNvPr id="74" name="Graphic 73" descr="Wi-Fi with solid fill">
+            <a:extLst>
+              <a:ext uri="{FF2B5EF4-FFF2-40B4-BE49-F238E27FC236}">
+                <a16:creationId xmlns:a16="http://schemas.microsoft.com/office/drawing/2014/main" id="{617181AC-7D86-B815-4414-61D9155A96FE}"/>
+              </a:ext>
+            </a:extLst>
+          </p:cNvPr>
+          <p:cNvPicPr>
+            <a:picLocks noChangeAspect="1"/>
+          </p:cNvPicPr>
+          <p:nvPr/>
+        </p:nvPicPr>
+        <p:blipFill>
+          <a:blip r:embed="rId14">
+            <a:extLst>
+              <a:ext uri="{96DAC541-7B7A-43D3-8B79-37D633B846F1}">
+                <asvg:svgBlip xmlns:asvg="http://schemas.microsoft.com/office/drawing/2016/SVG/main" r:embed="rId15"/>
+              </a:ext>
+            </a:extLst>
+          </a:blip>
+          <a:stretch>
+            <a:fillRect/>
+          </a:stretch>
+        </p:blipFill>
+        <p:spPr>
+          <a:xfrm>
+            <a:off x="6263627" y="3085644"/>
+            <a:ext cx="457200" cy="457200"/>
+          </a:xfrm>
+          <a:prstGeom prst="rect">
+            <a:avLst/>
+          </a:prstGeom>
+        </p:spPr>
+      </p:pic>
+      <p:cxnSp>
+        <p:nvCxnSpPr>
+          <p:cNvPr id="76" name="Connector: Elbow 75">
+            <a:extLst>
+              <a:ext uri="{FF2B5EF4-FFF2-40B4-BE49-F238E27FC236}">
+                <a16:creationId xmlns:a16="http://schemas.microsoft.com/office/drawing/2014/main" id="{E37F0537-1F58-0CED-94A2-C45631F443E2}"/>
+              </a:ext>
+            </a:extLst>
+          </p:cNvPr>
+          <p:cNvCxnSpPr>
+            <a:cxnSpLocks/>
+            <a:endCxn id="74" idx="2"/>
+          </p:cNvCxnSpPr>
+          <p:nvPr/>
+        </p:nvCxnSpPr>
+        <p:spPr>
+          <a:xfrm flipV="1">
+            <a:off x="6051454" y="3542844"/>
+            <a:ext cx="440773" cy="203357"/>
+          </a:xfrm>
+          <a:prstGeom prst="bentConnector2">
+            <a:avLst/>
+          </a:prstGeom>
+        </p:spPr>
+        <p:style>
+          <a:lnRef idx="2">
+            <a:schemeClr val="accent1"/>
+          </a:lnRef>
+          <a:fillRef idx="0">
+            <a:schemeClr val="accent1"/>
+          </a:fillRef>
+          <a:effectRef idx="1">
+            <a:schemeClr val="accent1"/>
+          </a:effectRef>
+          <a:fontRef idx="minor">
+            <a:schemeClr val="tx1"/>
+          </a:fontRef>
+        </p:style>
+      </p:cxnSp>
+      <p:pic>
+        <p:nvPicPr>
+          <p:cNvPr id="84" name="Graphic 83" descr="Server with solid fill">
+            <a:extLst>
+              <a:ext uri="{FF2B5EF4-FFF2-40B4-BE49-F238E27FC236}">
+                <a16:creationId xmlns:a16="http://schemas.microsoft.com/office/drawing/2014/main" id="{ECE733A4-21EA-1D58-D862-B3853419E283}"/>
+              </a:ext>
+            </a:extLst>
+          </p:cNvPr>
+          <p:cNvPicPr>
+            <a:picLocks noChangeAspect="1"/>
+          </p:cNvPicPr>
+          <p:nvPr/>
+        </p:nvPicPr>
+        <p:blipFill>
+          <a:blip r:embed="rId16">
+            <a:extLst>
+              <a:ext uri="{96DAC541-7B7A-43D3-8B79-37D633B846F1}">
+                <asvg:svgBlip xmlns:asvg="http://schemas.microsoft.com/office/drawing/2016/SVG/main" r:embed="rId17"/>
+              </a:ext>
+            </a:extLst>
+          </a:blip>
+          <a:stretch>
+            <a:fillRect/>
+          </a:stretch>
+        </p:blipFill>
+        <p:spPr>
+          <a:xfrm>
+            <a:off x="6529174" y="5574601"/>
+            <a:ext cx="538098" cy="538098"/>
+          </a:xfrm>
+          <a:prstGeom prst="rect">
+            <a:avLst/>
+          </a:prstGeom>
+        </p:spPr>
+      </p:pic>
+      <p:sp>
+        <p:nvSpPr>
+          <p:cNvPr id="87" name="Cloud 86">
+            <a:extLst>
+              <a:ext uri="{FF2B5EF4-FFF2-40B4-BE49-F238E27FC236}">
+                <a16:creationId xmlns:a16="http://schemas.microsoft.com/office/drawing/2014/main" id="{2EDA8AAC-285D-EE91-ADE4-90E88BEF607B}"/>
+              </a:ext>
+            </a:extLst>
+          </p:cNvPr>
+          <p:cNvSpPr/>
+          <p:nvPr/>
+        </p:nvSpPr>
+        <p:spPr>
+          <a:xfrm>
+            <a:off x="8744554" y="3481940"/>
+            <a:ext cx="1414914" cy="912428"/>
+          </a:xfrm>
+          <a:prstGeom prst="cloud">
+            <a:avLst/>
+          </a:prstGeom>
+        </p:spPr>
+        <p:style>
+          <a:lnRef idx="2">
+            <a:schemeClr val="accent1">
+              <a:shade val="15000"/>
+            </a:schemeClr>
+          </a:lnRef>
+          <a:fillRef idx="1">
+            <a:schemeClr val="accent1"/>
+          </a:fillRef>
+          <a:effectRef idx="0">
+            <a:schemeClr val="accent1"/>
+          </a:effectRef>
+          <a:fontRef idx="minor">
+            <a:schemeClr val="lt1"/>
+          </a:fontRef>
+        </p:style>
+        <p:txBody>
+          <a:bodyPr rtlCol="0" anchor="ctr"/>
+          <a:lstStyle/>
+          <a:p>
+            <a:pPr algn="ctr"/>
+            <a:r>
+              <a:rPr lang="en-SG" sz="1600" b="1" dirty="0"/>
+              <a:t>Internet</a:t>
+            </a:r>
+          </a:p>
+        </p:txBody>
+      </p:sp>
+      <p:cxnSp>
+        <p:nvCxnSpPr>
+          <p:cNvPr id="88" name="Straight Connector 87">
+            <a:extLst>
+              <a:ext uri="{FF2B5EF4-FFF2-40B4-BE49-F238E27FC236}">
+                <a16:creationId xmlns:a16="http://schemas.microsoft.com/office/drawing/2014/main" id="{D5A80E07-5071-1335-77BC-617A538306DA}"/>
+              </a:ext>
+            </a:extLst>
+          </p:cNvPr>
+          <p:cNvCxnSpPr>
+            <a:cxnSpLocks/>
+            <a:stCxn id="60" idx="3"/>
+            <a:endCxn id="87" idx="2"/>
+          </p:cNvCxnSpPr>
+          <p:nvPr/>
+        </p:nvCxnSpPr>
+        <p:spPr>
+          <a:xfrm flipV="1">
+            <a:off x="8459036" y="3938154"/>
+            <a:ext cx="289907" cy="1"/>
+          </a:xfrm>
+          <a:prstGeom prst="line">
+            <a:avLst/>
+          </a:prstGeom>
+        </p:spPr>
+        <p:style>
+          <a:lnRef idx="2">
+            <a:schemeClr val="accent1"/>
+          </a:lnRef>
+          <a:fillRef idx="0">
+            <a:schemeClr val="accent1"/>
+          </a:fillRef>
+          <a:effectRef idx="1">
+            <a:schemeClr val="accent1"/>
+          </a:effectRef>
+          <a:fontRef idx="minor">
+            <a:schemeClr val="tx1"/>
+          </a:fontRef>
+        </p:style>
+      </p:cxnSp>
+      <p:pic>
+        <p:nvPicPr>
+          <p:cNvPr id="94" name="Graphic 93" descr="Laptop with solid fill">
+            <a:extLst>
+              <a:ext uri="{FF2B5EF4-FFF2-40B4-BE49-F238E27FC236}">
+                <a16:creationId xmlns:a16="http://schemas.microsoft.com/office/drawing/2014/main" id="{C96F39BD-C3C9-A290-64D3-D2950CBC03A0}"/>
+              </a:ext>
+            </a:extLst>
+          </p:cNvPr>
+          <p:cNvPicPr>
+            <a:picLocks noChangeAspect="1"/>
+          </p:cNvPicPr>
+          <p:nvPr/>
+        </p:nvPicPr>
+        <p:blipFill>
+          <a:blip r:embed="rId12">
+            <a:extLst>
+              <a:ext uri="{96DAC541-7B7A-43D3-8B79-37D633B846F1}">
+                <asvg:svgBlip xmlns:asvg="http://schemas.microsoft.com/office/drawing/2016/SVG/main" r:embed="rId13"/>
+              </a:ext>
+            </a:extLst>
+          </a:blip>
+          <a:stretch>
+            <a:fillRect/>
+          </a:stretch>
+        </p:blipFill>
+        <p:spPr>
+          <a:xfrm>
+            <a:off x="8151606" y="1751425"/>
+            <a:ext cx="1435131" cy="1435131"/>
+          </a:xfrm>
+          <a:prstGeom prst="rect">
+            <a:avLst/>
+          </a:prstGeom>
+        </p:spPr>
+      </p:pic>
+      <p:pic>
+        <p:nvPicPr>
+          <p:cNvPr id="95" name="Picture 94">
+            <a:extLst>
+              <a:ext uri="{FF2B5EF4-FFF2-40B4-BE49-F238E27FC236}">
+                <a16:creationId xmlns:a16="http://schemas.microsoft.com/office/drawing/2014/main" id="{314597AD-588F-8692-23B8-59FA9E6C5019}"/>
+              </a:ext>
+            </a:extLst>
+          </p:cNvPr>
+          <p:cNvPicPr>
+            <a:picLocks noChangeAspect="1"/>
+          </p:cNvPicPr>
+          <p:nvPr/>
+        </p:nvPicPr>
+        <p:blipFill>
+          <a:blip r:embed="rId9"/>
+          <a:stretch>
+            <a:fillRect/>
+          </a:stretch>
+        </p:blipFill>
+        <p:spPr>
+          <a:xfrm>
+            <a:off x="8493072" y="2244688"/>
+            <a:ext cx="734007" cy="339791"/>
+          </a:xfrm>
+          <a:prstGeom prst="rect">
+            <a:avLst/>
+          </a:prstGeom>
+        </p:spPr>
+      </p:pic>
+      <p:sp>
+        <p:nvSpPr>
+          <p:cNvPr id="96" name="TextBox 95">
+            <a:extLst>
+              <a:ext uri="{FF2B5EF4-FFF2-40B4-BE49-F238E27FC236}">
+                <a16:creationId xmlns:a16="http://schemas.microsoft.com/office/drawing/2014/main" id="{CE502BE6-A545-D516-A6C6-1CF01F5F4100}"/>
+              </a:ext>
+            </a:extLst>
+          </p:cNvPr>
+          <p:cNvSpPr txBox="1"/>
+          <p:nvPr/>
+        </p:nvSpPr>
+        <p:spPr>
+          <a:xfrm>
+            <a:off x="7795086" y="1560619"/>
+            <a:ext cx="2378797" cy="461665"/>
+          </a:xfrm>
+          <a:prstGeom prst="rect">
+            <a:avLst/>
+          </a:prstGeom>
+          <a:noFill/>
+        </p:spPr>
+        <p:txBody>
+          <a:bodyPr wrap="square">
+            <a:spAutoFit/>
+          </a:bodyPr>
+          <a:lstStyle/>
+          <a:p>
+            <a:r>
+              <a:rPr lang="en-SG" sz="1200" b="1" dirty="0"/>
+              <a:t>External Network User’s working Laptop with </a:t>
+            </a:r>
+            <a:r>
+              <a:rPr lang="en-SG" sz="1200" b="1" dirty="0" err="1"/>
+              <a:t>OpenClaw</a:t>
+            </a:r>
+            <a:r>
+              <a:rPr lang="en-SG" sz="1200" b="1" dirty="0"/>
+              <a:t> </a:t>
+            </a:r>
+          </a:p>
+        </p:txBody>
+      </p:sp>
+      <p:pic>
+        <p:nvPicPr>
+          <p:cNvPr id="100" name="Picture 99">
+            <a:extLst>
+              <a:ext uri="{FF2B5EF4-FFF2-40B4-BE49-F238E27FC236}">
+                <a16:creationId xmlns:a16="http://schemas.microsoft.com/office/drawing/2014/main" id="{DED6E3C1-0336-EE8D-C309-70B30D3A9C56}"/>
+              </a:ext>
+            </a:extLst>
+          </p:cNvPr>
+          <p:cNvPicPr>
+            <a:picLocks noChangeAspect="1"/>
+          </p:cNvPicPr>
+          <p:nvPr/>
+        </p:nvPicPr>
+        <p:blipFill>
+          <a:blip r:embed="rId18"/>
+          <a:stretch>
+            <a:fillRect/>
+          </a:stretch>
+        </p:blipFill>
+        <p:spPr>
+          <a:xfrm>
+            <a:off x="8823706" y="5002370"/>
+            <a:ext cx="538869" cy="737558"/>
+          </a:xfrm>
+          <a:prstGeom prst="rect">
+            <a:avLst/>
+          </a:prstGeom>
+        </p:spPr>
+      </p:pic>
+      <p:sp>
+        <p:nvSpPr>
+          <p:cNvPr id="102" name="TextBox 101">
+            <a:extLst>
+              <a:ext uri="{FF2B5EF4-FFF2-40B4-BE49-F238E27FC236}">
+                <a16:creationId xmlns:a16="http://schemas.microsoft.com/office/drawing/2014/main" id="{45D61394-6394-A6FE-7D4A-1E6BFA3622FF}"/>
+              </a:ext>
+            </a:extLst>
+          </p:cNvPr>
+          <p:cNvSpPr txBox="1"/>
+          <p:nvPr/>
+        </p:nvSpPr>
+        <p:spPr>
+          <a:xfrm>
+            <a:off x="7848066" y="4340501"/>
+            <a:ext cx="821646" cy="307777"/>
+          </a:xfrm>
+          <a:prstGeom prst="rect">
+            <a:avLst/>
+          </a:prstGeom>
+          <a:noFill/>
+        </p:spPr>
+        <p:txBody>
+          <a:bodyPr wrap="square">
+            <a:spAutoFit/>
+          </a:bodyPr>
+          <a:lstStyle/>
+          <a:p>
+            <a:r>
+              <a:rPr lang="en-US" sz="1400" b="1" dirty="0">
+                <a:solidFill>
+                  <a:schemeClr val="accent1"/>
+                </a:solidFill>
+              </a:rPr>
+              <a:t>Port:22</a:t>
+            </a:r>
+            <a:endParaRPr lang="en-SG" sz="1400" b="1" dirty="0">
+              <a:solidFill>
+                <a:schemeClr val="accent1"/>
+              </a:solidFill>
+            </a:endParaRPr>
+          </a:p>
+        </p:txBody>
+      </p:sp>
+      <p:cxnSp>
+        <p:nvCxnSpPr>
+          <p:cNvPr id="103" name="Straight Connector 102">
+            <a:extLst>
+              <a:ext uri="{FF2B5EF4-FFF2-40B4-BE49-F238E27FC236}">
+                <a16:creationId xmlns:a16="http://schemas.microsoft.com/office/drawing/2014/main" id="{E6BEC16E-4CD4-A239-E071-527C9C7D35F3}"/>
+              </a:ext>
+            </a:extLst>
+          </p:cNvPr>
+          <p:cNvCxnSpPr>
+            <a:cxnSpLocks/>
+            <a:endCxn id="100" idx="0"/>
+          </p:cNvCxnSpPr>
+          <p:nvPr/>
+        </p:nvCxnSpPr>
+        <p:spPr>
+          <a:xfrm>
+            <a:off x="9093140" y="4376998"/>
+            <a:ext cx="1" cy="625372"/>
+          </a:xfrm>
+          <a:prstGeom prst="line">
+            <a:avLst/>
+          </a:prstGeom>
+        </p:spPr>
+        <p:style>
+          <a:lnRef idx="2">
+            <a:schemeClr val="accent1"/>
+          </a:lnRef>
+          <a:fillRef idx="0">
+            <a:schemeClr val="accent1"/>
+          </a:fillRef>
+          <a:effectRef idx="1">
+            <a:schemeClr val="accent1"/>
+          </a:effectRef>
+          <a:fontRef idx="minor">
+            <a:schemeClr val="tx1"/>
+          </a:fontRef>
+        </p:style>
+      </p:cxnSp>
+      <p:sp>
+        <p:nvSpPr>
+          <p:cNvPr id="106" name="TextBox 105">
+            <a:extLst>
+              <a:ext uri="{FF2B5EF4-FFF2-40B4-BE49-F238E27FC236}">
+                <a16:creationId xmlns:a16="http://schemas.microsoft.com/office/drawing/2014/main" id="{F0214270-3016-7121-EFEC-A0CA42D30C00}"/>
+              </a:ext>
+            </a:extLst>
+          </p:cNvPr>
+          <p:cNvSpPr txBox="1"/>
+          <p:nvPr/>
+        </p:nvSpPr>
+        <p:spPr>
+          <a:xfrm>
+            <a:off x="7949341" y="5747124"/>
+            <a:ext cx="2477422" cy="461665"/>
+          </a:xfrm>
+          <a:prstGeom prst="rect">
+            <a:avLst/>
+          </a:prstGeom>
+          <a:noFill/>
+        </p:spPr>
+        <p:txBody>
+          <a:bodyPr wrap="square">
+            <a:spAutoFit/>
+          </a:bodyPr>
+          <a:lstStyle/>
+          <a:p>
+            <a:r>
+              <a:rPr lang="en-SG" sz="1200" b="1" dirty="0"/>
+              <a:t>User’s Mobile App such as WhatsApp, Telegram, WeChat</a:t>
+            </a:r>
+          </a:p>
+        </p:txBody>
+      </p:sp>
+      <p:sp>
+        <p:nvSpPr>
+          <p:cNvPr id="107" name="TextBox 106">
+            <a:extLst>
+              <a:ext uri="{FF2B5EF4-FFF2-40B4-BE49-F238E27FC236}">
+                <a16:creationId xmlns:a16="http://schemas.microsoft.com/office/drawing/2014/main" id="{4B8963BE-B0E3-602B-FB27-642D50549A0B}"/>
+              </a:ext>
+            </a:extLst>
+          </p:cNvPr>
+          <p:cNvSpPr txBox="1"/>
+          <p:nvPr/>
+        </p:nvSpPr>
+        <p:spPr>
+          <a:xfrm>
+            <a:off x="803828" y="1966256"/>
+            <a:ext cx="2038819" cy="338554"/>
+          </a:xfrm>
+          <a:prstGeom prst="rect">
+            <a:avLst/>
+          </a:prstGeom>
+          <a:noFill/>
+        </p:spPr>
+        <p:txBody>
+          <a:bodyPr wrap="square">
+            <a:spAutoFit/>
+          </a:bodyPr>
+          <a:lstStyle/>
+          <a:p>
+            <a:r>
+              <a:rPr lang="en-SG" sz="1600" b="1" dirty="0">
+                <a:solidFill>
+                  <a:schemeClr val="tx2">
+                    <a:lumMod val="75000"/>
+                    <a:lumOff val="25000"/>
+                  </a:schemeClr>
+                </a:solidFill>
+              </a:rPr>
+              <a:t>Internal Network</a:t>
+            </a:r>
+          </a:p>
+        </p:txBody>
+      </p:sp>
+      <p:cxnSp>
+        <p:nvCxnSpPr>
+          <p:cNvPr id="115" name="Straight Arrow Connector 114">
+            <a:extLst>
+              <a:ext uri="{FF2B5EF4-FFF2-40B4-BE49-F238E27FC236}">
+                <a16:creationId xmlns:a16="http://schemas.microsoft.com/office/drawing/2014/main" id="{BD5479A9-934A-2D78-CB37-E79E203F0BA7}"/>
+              </a:ext>
+            </a:extLst>
+          </p:cNvPr>
+          <p:cNvCxnSpPr>
+            <a:cxnSpLocks/>
+          </p:cNvCxnSpPr>
+          <p:nvPr/>
+        </p:nvCxnSpPr>
+        <p:spPr>
+          <a:xfrm>
+            <a:off x="8869172" y="2953714"/>
+            <a:ext cx="0" cy="641473"/>
+          </a:xfrm>
+          <a:prstGeom prst="straightConnector1">
+            <a:avLst/>
+          </a:prstGeom>
+          <a:ln>
+            <a:solidFill>
+              <a:schemeClr val="accent2">
+                <a:lumMod val="75000"/>
+              </a:schemeClr>
+            </a:solidFill>
+            <a:prstDash val="sysDash"/>
+            <a:tailEnd type="triangle"/>
+          </a:ln>
+        </p:spPr>
+        <p:style>
+          <a:lnRef idx="2">
+            <a:schemeClr val="accent1"/>
+          </a:lnRef>
+          <a:fillRef idx="0">
+            <a:schemeClr val="accent1"/>
+          </a:fillRef>
+          <a:effectRef idx="1">
+            <a:schemeClr val="accent1"/>
+          </a:effectRef>
+          <a:fontRef idx="minor">
+            <a:schemeClr val="tx1"/>
+          </a:fontRef>
+        </p:style>
+      </p:cxnSp>
+      <p:cxnSp>
+        <p:nvCxnSpPr>
+          <p:cNvPr id="118" name="Straight Arrow Connector 117">
+            <a:extLst>
+              <a:ext uri="{FF2B5EF4-FFF2-40B4-BE49-F238E27FC236}">
+                <a16:creationId xmlns:a16="http://schemas.microsoft.com/office/drawing/2014/main" id="{A609CE49-EDA0-C9A8-EAB8-80B4B64D4117}"/>
+              </a:ext>
+            </a:extLst>
+          </p:cNvPr>
+          <p:cNvCxnSpPr>
+            <a:cxnSpLocks/>
+          </p:cNvCxnSpPr>
+          <p:nvPr/>
+        </p:nvCxnSpPr>
+        <p:spPr>
+          <a:xfrm flipH="1">
+            <a:off x="8433138" y="3819665"/>
+            <a:ext cx="257478" cy="0"/>
+          </a:xfrm>
+          <a:prstGeom prst="straightConnector1">
+            <a:avLst/>
+          </a:prstGeom>
+          <a:ln>
+            <a:solidFill>
+              <a:schemeClr val="accent2">
+                <a:lumMod val="75000"/>
+              </a:schemeClr>
+            </a:solidFill>
+            <a:prstDash val="sysDash"/>
+            <a:tailEnd type="triangle"/>
+          </a:ln>
+        </p:spPr>
+        <p:style>
+          <a:lnRef idx="2">
+            <a:schemeClr val="accent1"/>
+          </a:lnRef>
+          <a:fillRef idx="0">
+            <a:schemeClr val="accent1"/>
+          </a:fillRef>
+          <a:effectRef idx="1">
+            <a:schemeClr val="accent1"/>
+          </a:effectRef>
+          <a:fontRef idx="minor">
+            <a:schemeClr val="tx1"/>
+          </a:fontRef>
+        </p:style>
+      </p:cxnSp>
+      <p:cxnSp>
+        <p:nvCxnSpPr>
+          <p:cNvPr id="121" name="Straight Arrow Connector 120">
+            <a:extLst>
+              <a:ext uri="{FF2B5EF4-FFF2-40B4-BE49-F238E27FC236}">
+                <a16:creationId xmlns:a16="http://schemas.microsoft.com/office/drawing/2014/main" id="{435B0A72-0514-04E5-5E38-6E1612A92544}"/>
+              </a:ext>
+            </a:extLst>
+          </p:cNvPr>
+          <p:cNvCxnSpPr>
+            <a:cxnSpLocks/>
+          </p:cNvCxnSpPr>
+          <p:nvPr/>
+        </p:nvCxnSpPr>
+        <p:spPr>
+          <a:xfrm flipH="1">
+            <a:off x="6133854" y="4060870"/>
+            <a:ext cx="652798" cy="0"/>
+          </a:xfrm>
+          <a:prstGeom prst="straightConnector1">
+            <a:avLst/>
+          </a:prstGeom>
+          <a:ln>
+            <a:solidFill>
+              <a:schemeClr val="accent2">
+                <a:lumMod val="75000"/>
+              </a:schemeClr>
+            </a:solidFill>
+            <a:prstDash val="sysDash"/>
+            <a:tailEnd type="triangle"/>
+          </a:ln>
+        </p:spPr>
+        <p:style>
+          <a:lnRef idx="2">
+            <a:schemeClr val="accent1"/>
+          </a:lnRef>
+          <a:fillRef idx="0">
+            <a:schemeClr val="accent1"/>
+          </a:fillRef>
+          <a:effectRef idx="1">
+            <a:schemeClr val="accent1"/>
+          </a:effectRef>
+          <a:fontRef idx="minor">
+            <a:schemeClr val="tx1"/>
+          </a:fontRef>
+        </p:style>
+      </p:cxnSp>
+      <p:cxnSp>
+        <p:nvCxnSpPr>
+          <p:cNvPr id="123" name="Straight Arrow Connector 122">
+            <a:extLst>
+              <a:ext uri="{FF2B5EF4-FFF2-40B4-BE49-F238E27FC236}">
+                <a16:creationId xmlns:a16="http://schemas.microsoft.com/office/drawing/2014/main" id="{DEC2FB36-3E5A-58AC-28EE-0C46505EEDBB}"/>
+              </a:ext>
+            </a:extLst>
+          </p:cNvPr>
+          <p:cNvCxnSpPr>
+            <a:cxnSpLocks/>
+          </p:cNvCxnSpPr>
+          <p:nvPr/>
+        </p:nvCxnSpPr>
+        <p:spPr>
+          <a:xfrm flipV="1">
+            <a:off x="5464416" y="4420172"/>
+            <a:ext cx="0" cy="258976"/>
+          </a:xfrm>
+          <a:prstGeom prst="straightConnector1">
+            <a:avLst/>
+          </a:prstGeom>
+          <a:ln>
+            <a:solidFill>
+              <a:schemeClr val="accent2">
+                <a:lumMod val="75000"/>
+              </a:schemeClr>
+            </a:solidFill>
+            <a:prstDash val="sysDash"/>
+            <a:tailEnd type="triangle"/>
+          </a:ln>
+        </p:spPr>
+        <p:style>
+          <a:lnRef idx="2">
+            <a:schemeClr val="accent1"/>
+          </a:lnRef>
+          <a:fillRef idx="0">
+            <a:schemeClr val="accent1"/>
+          </a:fillRef>
+          <a:effectRef idx="1">
+            <a:schemeClr val="accent1"/>
+          </a:effectRef>
+          <a:fontRef idx="minor">
+            <a:schemeClr val="tx1"/>
+          </a:fontRef>
+        </p:style>
+      </p:cxnSp>
+      <p:cxnSp>
+        <p:nvCxnSpPr>
+          <p:cNvPr id="125" name="Straight Arrow Connector 124">
+            <a:extLst>
+              <a:ext uri="{FF2B5EF4-FFF2-40B4-BE49-F238E27FC236}">
+                <a16:creationId xmlns:a16="http://schemas.microsoft.com/office/drawing/2014/main" id="{33FA6A3A-58FE-2C27-A2DD-5F1592D10719}"/>
+              </a:ext>
+            </a:extLst>
+          </p:cNvPr>
+          <p:cNvCxnSpPr>
+            <a:cxnSpLocks/>
+          </p:cNvCxnSpPr>
+          <p:nvPr/>
+        </p:nvCxnSpPr>
+        <p:spPr>
+          <a:xfrm flipH="1">
+            <a:off x="4219117" y="4035164"/>
+            <a:ext cx="728268" cy="0"/>
+          </a:xfrm>
+          <a:prstGeom prst="straightConnector1">
+            <a:avLst/>
+          </a:prstGeom>
+          <a:ln>
+            <a:solidFill>
+              <a:schemeClr val="accent2">
+                <a:lumMod val="75000"/>
+              </a:schemeClr>
+            </a:solidFill>
+            <a:prstDash val="sysDash"/>
+            <a:tailEnd type="triangle"/>
+          </a:ln>
+        </p:spPr>
+        <p:style>
+          <a:lnRef idx="2">
+            <a:schemeClr val="accent1"/>
+          </a:lnRef>
+          <a:fillRef idx="0">
+            <a:schemeClr val="accent1"/>
+          </a:fillRef>
+          <a:effectRef idx="1">
+            <a:schemeClr val="accent1"/>
+          </a:effectRef>
+          <a:fontRef idx="minor">
+            <a:schemeClr val="tx1"/>
+          </a:fontRef>
+        </p:style>
+      </p:cxnSp>
+      <p:cxnSp>
+        <p:nvCxnSpPr>
+          <p:cNvPr id="127" name="Straight Arrow Connector 126">
+            <a:extLst>
+              <a:ext uri="{FF2B5EF4-FFF2-40B4-BE49-F238E27FC236}">
+                <a16:creationId xmlns:a16="http://schemas.microsoft.com/office/drawing/2014/main" id="{96C69708-3EDC-2858-5AFB-CC0276AA863B}"/>
+              </a:ext>
+            </a:extLst>
+          </p:cNvPr>
+          <p:cNvCxnSpPr>
+            <a:cxnSpLocks/>
+          </p:cNvCxnSpPr>
+          <p:nvPr/>
+        </p:nvCxnSpPr>
+        <p:spPr>
+          <a:xfrm flipH="1">
+            <a:off x="6314659" y="3219211"/>
+            <a:ext cx="0" cy="375976"/>
+          </a:xfrm>
+          <a:prstGeom prst="straightConnector1">
+            <a:avLst/>
+          </a:prstGeom>
+          <a:ln>
+            <a:solidFill>
+              <a:schemeClr val="accent2">
+                <a:lumMod val="75000"/>
+              </a:schemeClr>
+            </a:solidFill>
+            <a:prstDash val="sysDash"/>
+            <a:tailEnd type="triangle"/>
+          </a:ln>
+        </p:spPr>
+        <p:style>
+          <a:lnRef idx="2">
+            <a:schemeClr val="accent1"/>
+          </a:lnRef>
+          <a:fillRef idx="0">
+            <a:schemeClr val="accent1"/>
+          </a:fillRef>
+          <a:effectRef idx="1">
+            <a:schemeClr val="accent1"/>
+          </a:effectRef>
+          <a:fontRef idx="minor">
+            <a:schemeClr val="tx1"/>
+          </a:fontRef>
+        </p:style>
+      </p:cxnSp>
+      <p:cxnSp>
+        <p:nvCxnSpPr>
+          <p:cNvPr id="130" name="Straight Arrow Connector 129">
+            <a:extLst>
+              <a:ext uri="{FF2B5EF4-FFF2-40B4-BE49-F238E27FC236}">
+                <a16:creationId xmlns:a16="http://schemas.microsoft.com/office/drawing/2014/main" id="{506D418B-BFA6-73A7-6FC0-42A16B532A53}"/>
+              </a:ext>
+            </a:extLst>
+          </p:cNvPr>
+          <p:cNvCxnSpPr>
+            <a:cxnSpLocks/>
+          </p:cNvCxnSpPr>
+          <p:nvPr/>
+        </p:nvCxnSpPr>
+        <p:spPr>
+          <a:xfrm flipH="1" flipV="1">
+            <a:off x="6096000" y="3635237"/>
+            <a:ext cx="219942" cy="0"/>
+          </a:xfrm>
+          <a:prstGeom prst="straightConnector1">
+            <a:avLst/>
+          </a:prstGeom>
+          <a:ln>
+            <a:solidFill>
+              <a:schemeClr val="accent2">
+                <a:lumMod val="75000"/>
+              </a:schemeClr>
+            </a:solidFill>
+            <a:prstDash val="sysDash"/>
+            <a:tailEnd type="triangle"/>
+          </a:ln>
+        </p:spPr>
+        <p:style>
+          <a:lnRef idx="2">
+            <a:schemeClr val="accent1"/>
+          </a:lnRef>
+          <a:fillRef idx="0">
+            <a:schemeClr val="accent1"/>
+          </a:fillRef>
+          <a:effectRef idx="1">
+            <a:schemeClr val="accent1"/>
+          </a:effectRef>
+          <a:fontRef idx="minor">
+            <a:schemeClr val="tx1"/>
+          </a:fontRef>
+        </p:style>
+      </p:cxnSp>
+      <p:cxnSp>
+        <p:nvCxnSpPr>
+          <p:cNvPr id="134" name="Straight Arrow Connector 133">
+            <a:extLst>
+              <a:ext uri="{FF2B5EF4-FFF2-40B4-BE49-F238E27FC236}">
+                <a16:creationId xmlns:a16="http://schemas.microsoft.com/office/drawing/2014/main" id="{36881F5D-9F48-CA18-EF37-26022C76E32C}"/>
+              </a:ext>
+            </a:extLst>
+          </p:cNvPr>
+          <p:cNvCxnSpPr>
+            <a:cxnSpLocks/>
+          </p:cNvCxnSpPr>
+          <p:nvPr/>
+        </p:nvCxnSpPr>
+        <p:spPr>
+          <a:xfrm flipH="1">
+            <a:off x="1143258" y="5897744"/>
+            <a:ext cx="385466" cy="0"/>
+          </a:xfrm>
+          <a:prstGeom prst="straightConnector1">
+            <a:avLst/>
+          </a:prstGeom>
+          <a:ln>
+            <a:solidFill>
+              <a:schemeClr val="accent2">
+                <a:lumMod val="75000"/>
+              </a:schemeClr>
+            </a:solidFill>
+            <a:prstDash val="sysDash"/>
+            <a:tailEnd type="triangle"/>
+          </a:ln>
+        </p:spPr>
+        <p:style>
+          <a:lnRef idx="2">
+            <a:schemeClr val="accent1"/>
+          </a:lnRef>
+          <a:fillRef idx="0">
+            <a:schemeClr val="accent1"/>
+          </a:fillRef>
+          <a:effectRef idx="1">
+            <a:schemeClr val="accent1"/>
+          </a:effectRef>
+          <a:fontRef idx="minor">
+            <a:schemeClr val="tx1"/>
+          </a:fontRef>
+        </p:style>
+      </p:cxnSp>
+      <p:sp>
+        <p:nvSpPr>
+          <p:cNvPr id="136" name="TextBox 135">
+            <a:extLst>
+              <a:ext uri="{FF2B5EF4-FFF2-40B4-BE49-F238E27FC236}">
+                <a16:creationId xmlns:a16="http://schemas.microsoft.com/office/drawing/2014/main" id="{BC8F2FAA-16CD-8B28-C126-80E01FE0E88F}"/>
+              </a:ext>
+            </a:extLst>
+          </p:cNvPr>
+          <p:cNvSpPr txBox="1"/>
+          <p:nvPr/>
+        </p:nvSpPr>
+        <p:spPr>
+          <a:xfrm>
+            <a:off x="1544230" y="5739928"/>
+            <a:ext cx="3042866" cy="276999"/>
+          </a:xfrm>
+          <a:prstGeom prst="rect">
+            <a:avLst/>
+          </a:prstGeom>
+          <a:noFill/>
+        </p:spPr>
+        <p:txBody>
+          <a:bodyPr wrap="square">
+            <a:spAutoFit/>
+          </a:bodyPr>
+          <a:lstStyle/>
+          <a:p>
+            <a:r>
+              <a:rPr lang="en-SG" sz="1200" b="1" dirty="0">
+                <a:solidFill>
+                  <a:schemeClr val="accent2">
+                    <a:lumMod val="75000"/>
+                  </a:schemeClr>
+                </a:solidFill>
+              </a:rPr>
+              <a:t>Port Forwarded </a:t>
+            </a:r>
+            <a:r>
+              <a:rPr lang="en-SG" sz="1200" b="1" dirty="0" err="1">
+                <a:solidFill>
+                  <a:schemeClr val="accent2">
+                    <a:lumMod val="75000"/>
+                  </a:schemeClr>
+                </a:solidFill>
+              </a:rPr>
+              <a:t>OpenClaw</a:t>
+            </a:r>
+            <a:r>
+              <a:rPr lang="en-SG" sz="1200" b="1" dirty="0">
+                <a:solidFill>
+                  <a:schemeClr val="accent2">
+                    <a:lumMod val="75000"/>
+                  </a:schemeClr>
+                </a:solidFill>
+              </a:rPr>
+              <a:t> API call to LLM </a:t>
+            </a:r>
+          </a:p>
+        </p:txBody>
+      </p:sp>
+      <p:sp>
+        <p:nvSpPr>
+          <p:cNvPr id="2" name="TextBox 1">
+            <a:extLst>
+              <a:ext uri="{FF2B5EF4-FFF2-40B4-BE49-F238E27FC236}">
+                <a16:creationId xmlns:a16="http://schemas.microsoft.com/office/drawing/2014/main" id="{8CB96D30-06B5-E99B-A8C0-A8EC424613D7}"/>
+              </a:ext>
+            </a:extLst>
+          </p:cNvPr>
+          <p:cNvSpPr txBox="1"/>
+          <p:nvPr/>
+        </p:nvSpPr>
+        <p:spPr>
+          <a:xfrm>
+            <a:off x="729339" y="654238"/>
+            <a:ext cx="10713772" cy="830997"/>
+          </a:xfrm>
+          <a:prstGeom prst="rect">
+            <a:avLst/>
+          </a:prstGeom>
+          <a:solidFill>
+            <a:schemeClr val="accent6">
+              <a:lumMod val="50000"/>
+            </a:schemeClr>
+          </a:solidFill>
+          <a:ln w="19050">
+            <a:solidFill>
+              <a:schemeClr val="tx1"/>
+            </a:solidFill>
+            <a:prstDash val="sysDash"/>
+          </a:ln>
+        </p:spPr>
+        <p:txBody>
+          <a:bodyPr wrap="square">
+            <a:spAutoFit/>
+          </a:bodyPr>
+          <a:lstStyle/>
+          <a:p>
+            <a:r>
+              <a:rPr lang="en-US" sz="2400" b="1" dirty="0">
+                <a:solidFill>
+                  <a:schemeClr val="bg1"/>
+                </a:solidFill>
+              </a:rPr>
+              <a:t>Deploy Multiple </a:t>
+            </a:r>
+            <a:r>
+              <a:rPr lang="en-US" sz="2400" b="1" dirty="0" err="1">
+                <a:solidFill>
+                  <a:schemeClr val="bg1"/>
+                </a:solidFill>
+              </a:rPr>
+              <a:t>OpenClaw</a:t>
+            </a:r>
+            <a:r>
+              <a:rPr lang="en-US" sz="2400" b="1" dirty="0">
+                <a:solidFill>
+                  <a:schemeClr val="bg1"/>
+                </a:solidFill>
+              </a:rPr>
+              <a:t> AI Assistants Cluster With the Local GPU Server/Laptop Running LLM Model Such As Qwen3.5 or DeepSeek-r1</a:t>
+            </a:r>
+            <a:endParaRPr lang="en-SG" sz="2400" b="1" dirty="0">
+              <a:solidFill>
+                <a:schemeClr val="bg1"/>
+              </a:solidFill>
+            </a:endParaRPr>
+          </a:p>
+        </p:txBody>
+      </p:sp>
+      <p:cxnSp>
+        <p:nvCxnSpPr>
+          <p:cNvPr id="3" name="Straight Connector 2">
+            <a:extLst>
+              <a:ext uri="{FF2B5EF4-FFF2-40B4-BE49-F238E27FC236}">
+                <a16:creationId xmlns:a16="http://schemas.microsoft.com/office/drawing/2014/main" id="{38BBDE53-88D0-3E6F-F9A7-94448318BCA2}"/>
+              </a:ext>
+            </a:extLst>
+          </p:cNvPr>
+          <p:cNvCxnSpPr>
+            <a:cxnSpLocks/>
+          </p:cNvCxnSpPr>
+          <p:nvPr/>
+        </p:nvCxnSpPr>
+        <p:spPr>
+          <a:xfrm>
+            <a:off x="9089723" y="2930656"/>
+            <a:ext cx="1" cy="625372"/>
+          </a:xfrm>
+          <a:prstGeom prst="line">
+            <a:avLst/>
+          </a:prstGeom>
+        </p:spPr>
+        <p:style>
+          <a:lnRef idx="2">
+            <a:schemeClr val="accent1"/>
+          </a:lnRef>
+          <a:fillRef idx="0">
+            <a:schemeClr val="accent1"/>
+          </a:fillRef>
+          <a:effectRef idx="1">
+            <a:schemeClr val="accent1"/>
+          </a:effectRef>
+          <a:fontRef idx="minor">
+            <a:schemeClr val="tx1"/>
+          </a:fontRef>
+        </p:style>
+      </p:cxnSp>
+      <p:pic>
+        <p:nvPicPr>
+          <p:cNvPr id="14" name="Picture 13">
+            <a:extLst>
+              <a:ext uri="{FF2B5EF4-FFF2-40B4-BE49-F238E27FC236}">
+                <a16:creationId xmlns:a16="http://schemas.microsoft.com/office/drawing/2014/main" id="{9B4CD888-CACF-2F77-C016-77AA40107995}"/>
+              </a:ext>
+            </a:extLst>
+          </p:cNvPr>
+          <p:cNvPicPr>
+            <a:picLocks noChangeAspect="1"/>
+          </p:cNvPicPr>
+          <p:nvPr/>
+        </p:nvPicPr>
+        <p:blipFill>
+          <a:blip r:embed="rId19">
+            <a:extLst>
+              <a:ext uri="{28A0092B-C50C-407E-A947-70E740481C1C}">
+                <a14:useLocalDpi xmlns:a14="http://schemas.microsoft.com/office/drawing/2010/main" val="0"/>
+              </a:ext>
+            </a:extLst>
+          </a:blip>
+          <a:stretch>
+            <a:fillRect/>
+          </a:stretch>
+        </p:blipFill>
+        <p:spPr>
+          <a:xfrm>
+            <a:off x="9492885" y="4591118"/>
+            <a:ext cx="2049779" cy="1037188"/>
+          </a:xfrm>
+          <a:prstGeom prst="rect">
+            <a:avLst/>
+          </a:prstGeom>
+          <a:ln w="12700">
+            <a:solidFill>
+              <a:schemeClr val="tx1"/>
+            </a:solidFill>
+          </a:ln>
+        </p:spPr>
+      </p:pic>
+      <p:pic>
+        <p:nvPicPr>
+          <p:cNvPr id="22" name="Picture 21">
+            <a:extLst>
+              <a:ext uri="{FF2B5EF4-FFF2-40B4-BE49-F238E27FC236}">
+                <a16:creationId xmlns:a16="http://schemas.microsoft.com/office/drawing/2014/main" id="{EA8DD870-F2C8-6F87-0A31-7B7DD475402B}"/>
+              </a:ext>
+            </a:extLst>
+          </p:cNvPr>
+          <p:cNvPicPr>
+            <a:picLocks noChangeAspect="1"/>
+          </p:cNvPicPr>
+          <p:nvPr/>
+        </p:nvPicPr>
+        <p:blipFill>
+          <a:blip r:embed="rId20">
+            <a:extLst>
+              <a:ext uri="{28A0092B-C50C-407E-A947-70E740481C1C}">
+                <a14:useLocalDpi xmlns:a14="http://schemas.microsoft.com/office/drawing/2010/main" val="0"/>
+              </a:ext>
+            </a:extLst>
+          </a:blip>
+          <a:stretch>
+            <a:fillRect/>
+          </a:stretch>
+        </p:blipFill>
+        <p:spPr>
+          <a:xfrm>
+            <a:off x="9616864" y="2103593"/>
+            <a:ext cx="1871199" cy="1194585"/>
+          </a:xfrm>
+          <a:prstGeom prst="rect">
+            <a:avLst/>
+          </a:prstGeom>
+          <a:ln w="12700">
+            <a:solidFill>
+              <a:schemeClr val="tx1"/>
+            </a:solidFill>
+          </a:ln>
+        </p:spPr>
+      </p:pic>
+      <p:cxnSp>
+        <p:nvCxnSpPr>
+          <p:cNvPr id="24" name="Straight Arrow Connector 23">
+            <a:extLst>
+              <a:ext uri="{FF2B5EF4-FFF2-40B4-BE49-F238E27FC236}">
+                <a16:creationId xmlns:a16="http://schemas.microsoft.com/office/drawing/2014/main" id="{B812D083-C284-0005-CB14-E1C11E1504AB}"/>
+              </a:ext>
+            </a:extLst>
+          </p:cNvPr>
+          <p:cNvCxnSpPr/>
+          <p:nvPr/>
+        </p:nvCxnSpPr>
+        <p:spPr>
+          <a:xfrm flipH="1">
+            <a:off x="9279064" y="2514824"/>
+            <a:ext cx="307673" cy="0"/>
+          </a:xfrm>
+          <a:prstGeom prst="straightConnector1">
+            <a:avLst/>
+          </a:prstGeom>
+          <a:ln>
+            <a:solidFill>
+              <a:srgbClr val="FF0000"/>
+            </a:solidFill>
+            <a:tailEnd type="triangle"/>
+          </a:ln>
+        </p:spPr>
+        <p:style>
+          <a:lnRef idx="2">
+            <a:schemeClr val="accent1"/>
+          </a:lnRef>
+          <a:fillRef idx="0">
+            <a:schemeClr val="accent1"/>
+          </a:fillRef>
+          <a:effectRef idx="1">
+            <a:schemeClr val="accent1"/>
+          </a:effectRef>
+          <a:fontRef idx="minor">
+            <a:schemeClr val="tx1"/>
+          </a:fontRef>
+        </p:style>
+      </p:cxnSp>
+      <p:pic>
+        <p:nvPicPr>
+          <p:cNvPr id="25" name="Graphic 24" descr="User with solid fill">
+            <a:extLst>
+              <a:ext uri="{FF2B5EF4-FFF2-40B4-BE49-F238E27FC236}">
+                <a16:creationId xmlns:a16="http://schemas.microsoft.com/office/drawing/2014/main" id="{FA20A761-4628-6B62-A5C9-04B9FF445729}"/>
+              </a:ext>
+            </a:extLst>
+          </p:cNvPr>
+          <p:cNvPicPr>
+            <a:picLocks noChangeAspect="1"/>
+          </p:cNvPicPr>
+          <p:nvPr/>
+        </p:nvPicPr>
+        <p:blipFill>
+          <a:blip r:embed="rId21">
+            <a:extLst>
+              <a:ext uri="{96DAC541-7B7A-43D3-8B79-37D633B846F1}">
+                <asvg:svgBlip xmlns:asvg="http://schemas.microsoft.com/office/drawing/2016/SVG/main" r:embed="rId22"/>
+              </a:ext>
+            </a:extLst>
+          </a:blip>
+          <a:stretch>
+            <a:fillRect/>
+          </a:stretch>
+        </p:blipFill>
+        <p:spPr>
+          <a:xfrm>
+            <a:off x="10916259" y="3168651"/>
+            <a:ext cx="683583" cy="683583"/>
+          </a:xfrm>
+          <a:prstGeom prst="rect">
+            <a:avLst/>
+          </a:prstGeom>
+        </p:spPr>
+      </p:pic>
+      <p:cxnSp>
+        <p:nvCxnSpPr>
+          <p:cNvPr id="28" name="Straight Arrow Connector 27">
+            <a:extLst>
+              <a:ext uri="{FF2B5EF4-FFF2-40B4-BE49-F238E27FC236}">
+                <a16:creationId xmlns:a16="http://schemas.microsoft.com/office/drawing/2014/main" id="{194306B0-B4FD-CC35-ECA9-4B95BEDE327D}"/>
+              </a:ext>
+            </a:extLst>
+          </p:cNvPr>
+          <p:cNvCxnSpPr/>
+          <p:nvPr/>
+        </p:nvCxnSpPr>
+        <p:spPr>
+          <a:xfrm flipH="1">
+            <a:off x="9144338" y="5329430"/>
+            <a:ext cx="307673" cy="0"/>
+          </a:xfrm>
+          <a:prstGeom prst="straightConnector1">
+            <a:avLst/>
+          </a:prstGeom>
+          <a:ln>
+            <a:solidFill>
+              <a:srgbClr val="FF0000"/>
+            </a:solidFill>
+            <a:tailEnd type="triangle"/>
+          </a:ln>
+        </p:spPr>
+        <p:style>
+          <a:lnRef idx="2">
+            <a:schemeClr val="accent1"/>
+          </a:lnRef>
+          <a:fillRef idx="0">
+            <a:schemeClr val="accent1"/>
+          </a:fillRef>
+          <a:effectRef idx="1">
+            <a:schemeClr val="accent1"/>
+          </a:effectRef>
+          <a:fontRef idx="minor">
+            <a:schemeClr val="tx1"/>
+          </a:fontRef>
+        </p:style>
+      </p:cxnSp>
+      <p:sp>
+        <p:nvSpPr>
+          <p:cNvPr id="30" name="TextBox 29">
+            <a:extLst>
+              <a:ext uri="{FF2B5EF4-FFF2-40B4-BE49-F238E27FC236}">
+                <a16:creationId xmlns:a16="http://schemas.microsoft.com/office/drawing/2014/main" id="{0D85B8DA-4F78-8F23-3677-35A7982E8C5D}"/>
+              </a:ext>
+            </a:extLst>
+          </p:cNvPr>
+          <p:cNvSpPr txBox="1"/>
+          <p:nvPr/>
+        </p:nvSpPr>
+        <p:spPr>
+          <a:xfrm>
+            <a:off x="10426763" y="1853180"/>
+            <a:ext cx="1041812" cy="276999"/>
+          </a:xfrm>
+          <a:prstGeom prst="rect">
+            <a:avLst/>
+          </a:prstGeom>
+          <a:noFill/>
+        </p:spPr>
+        <p:txBody>
+          <a:bodyPr wrap="square">
+            <a:spAutoFit/>
+          </a:bodyPr>
+          <a:lstStyle/>
+          <a:p>
+            <a:r>
+              <a:rPr lang="en-US" sz="1200" b="1" dirty="0"/>
+              <a:t>We</a:t>
+            </a:r>
+            <a:r>
+              <a:rPr lang="en-US" sz="1200" b="1" dirty="0">
+                <a:solidFill>
+                  <a:schemeClr val="accent6">
+                    <a:lumMod val="75000"/>
+                  </a:schemeClr>
+                </a:solidFill>
+              </a:rPr>
+              <a:t>b UI User</a:t>
+            </a:r>
+            <a:endParaRPr lang="en-SG" sz="1200" b="1" dirty="0">
+              <a:solidFill>
+                <a:schemeClr val="accent6">
+                  <a:lumMod val="75000"/>
+                </a:schemeClr>
+              </a:solidFill>
+            </a:endParaRPr>
+          </a:p>
+        </p:txBody>
+      </p:sp>
+      <p:sp>
+        <p:nvSpPr>
+          <p:cNvPr id="33" name="TextBox 32">
+            <a:extLst>
+              <a:ext uri="{FF2B5EF4-FFF2-40B4-BE49-F238E27FC236}">
+                <a16:creationId xmlns:a16="http://schemas.microsoft.com/office/drawing/2014/main" id="{13C080F2-2D30-D843-E6A0-893C96B88B17}"/>
+              </a:ext>
+            </a:extLst>
+          </p:cNvPr>
+          <p:cNvSpPr txBox="1"/>
+          <p:nvPr/>
+        </p:nvSpPr>
+        <p:spPr>
+          <a:xfrm>
+            <a:off x="10309769" y="4294165"/>
+            <a:ext cx="1392665" cy="276999"/>
+          </a:xfrm>
+          <a:prstGeom prst="rect">
+            <a:avLst/>
+          </a:prstGeom>
+          <a:noFill/>
+        </p:spPr>
+        <p:txBody>
+          <a:bodyPr wrap="square">
+            <a:spAutoFit/>
+          </a:bodyPr>
+          <a:lstStyle/>
+          <a:p>
+            <a:r>
+              <a:rPr lang="en-US" sz="1200" b="1" dirty="0">
+                <a:solidFill>
+                  <a:schemeClr val="accent6">
+                    <a:lumMod val="75000"/>
+                  </a:schemeClr>
+                </a:solidFill>
+              </a:rPr>
+              <a:t>Telegram User</a:t>
+            </a:r>
+            <a:endParaRPr lang="en-SG" sz="1200" b="1" dirty="0">
+              <a:solidFill>
+                <a:schemeClr val="accent6">
+                  <a:lumMod val="75000"/>
+                </a:schemeClr>
+              </a:solidFill>
+            </a:endParaRPr>
+          </a:p>
+        </p:txBody>
+      </p:sp>
+      <p:pic>
+        <p:nvPicPr>
+          <p:cNvPr id="101" name="Graphic 100" descr="User with solid fill">
+            <a:extLst>
+              <a:ext uri="{FF2B5EF4-FFF2-40B4-BE49-F238E27FC236}">
+                <a16:creationId xmlns:a16="http://schemas.microsoft.com/office/drawing/2014/main" id="{8F58717C-4321-BE93-9F22-A62030B89F00}"/>
+              </a:ext>
+            </a:extLst>
+          </p:cNvPr>
+          <p:cNvPicPr>
+            <a:picLocks noChangeAspect="1"/>
+          </p:cNvPicPr>
+          <p:nvPr/>
+        </p:nvPicPr>
+        <p:blipFill>
+          <a:blip r:embed="rId21">
+            <a:extLst>
+              <a:ext uri="{96DAC541-7B7A-43D3-8B79-37D633B846F1}">
+                <asvg:svgBlip xmlns:asvg="http://schemas.microsoft.com/office/drawing/2016/SVG/main" r:embed="rId22"/>
+              </a:ext>
+            </a:extLst>
+          </a:blip>
+          <a:stretch>
+            <a:fillRect/>
+          </a:stretch>
+        </p:blipFill>
+        <p:spPr>
+          <a:xfrm>
+            <a:off x="10972553" y="5511172"/>
+            <a:ext cx="683583" cy="683583"/>
+          </a:xfrm>
+          <a:prstGeom prst="rect">
+            <a:avLst/>
+          </a:prstGeom>
+        </p:spPr>
+      </p:pic>
+      <p:pic>
+        <p:nvPicPr>
+          <p:cNvPr id="37" name="Picture 36">
+            <a:extLst>
+              <a:ext uri="{FF2B5EF4-FFF2-40B4-BE49-F238E27FC236}">
+                <a16:creationId xmlns:a16="http://schemas.microsoft.com/office/drawing/2014/main" id="{426C64FB-D472-B95C-3DE6-87FF02504B84}"/>
+              </a:ext>
+            </a:extLst>
+          </p:cNvPr>
+          <p:cNvPicPr>
+            <a:picLocks noChangeAspect="1"/>
+          </p:cNvPicPr>
+          <p:nvPr/>
+        </p:nvPicPr>
+        <p:blipFill>
+          <a:blip r:embed="rId9"/>
+          <a:stretch>
+            <a:fillRect/>
+          </a:stretch>
+        </p:blipFill>
+        <p:spPr>
+          <a:xfrm>
+            <a:off x="10339051" y="766548"/>
+            <a:ext cx="1392665" cy="644701"/>
+          </a:xfrm>
+          <a:prstGeom prst="rect">
+            <a:avLst/>
+          </a:prstGeom>
+        </p:spPr>
+      </p:pic>
+    </p:spTree>
+    <p:extLst>
+      <p:ext uri="{BB962C8B-B14F-4D97-AF65-F5344CB8AC3E}">
+        <p14:creationId xmlns:p14="http://schemas.microsoft.com/office/powerpoint/2010/main" val="1150805690"/>
+      </p:ext>
+    </p:extLst>
+  </p:cSld>
+  <p:clrMapOvr>
+    <a:masterClrMapping/>
+  </p:clrMapOvr>
+</p:sld>
+</file>
+
+<file path=ppt/slides/slide5.xml><?xml version="1.0" encoding="utf-8"?>
 <p:sld xmlns:a="http://schemas.openxmlformats.org/drawingml/2006/main" xmlns:r="http://schemas.openxmlformats.org/officeDocument/2006/relationships" xmlns:p="http://schemas.openxmlformats.org/presentationml/2006/main">
   <p:cSld>
     <p:spTree>

</xml_diff>